<commit_message>
Update slide 23 photo to match slide 3 size, opacity, and position
Changed photo from dim 50% full-background to 97% opacity positioned
on the right side, matching the intro slide styling exactly.

Co-Authored-By: Claude Opus 4.6 <noreply@anthropic.com>
</commit_message>
<xml_diff>
--- a/Tracey-Scott-Portfolio-New.pptx
+++ b/Tracey-Scott-Portfolio-New.pptx
@@ -37178,16 +37178,17 @@
         </p:nvPicPr>
         <p:blipFill>
           <a:blip r:embed="rId4">
-            <a:alphaModFix amt="50000"/>
+            <a:alphaModFix amt="97000"/>
           </a:blip>
+          <a:srcRect l="5670" r="6097"/>
           <a:stretch>
             <a:fillRect/>
           </a:stretch>
         </p:blipFill>
         <p:spPr>
           <a:xfrm>
-            <a:off x="0" y="0"/>
-            <a:ext cx="9144000" cy="5143500"/>
+            <a:off x="2651760" y="0"/>
+            <a:ext cx="6583680" cy="5096950"/>
           </a:xfrm>
           <a:prstGeom prst="rect">
             <a:avLst/>

</xml_diff>

<commit_message>
Simplify animations: keep transitions only, remove element animations
Removed all element entrance animations that were causing the stock
image to show on slide 3 and making the deck slow to click through.
Kept smooth slide transitions (fade, push, wipe) for a clean flow.

Co-Authored-By: Claude Opus 4.6 <noreply@anthropic.com>
</commit_message>
<xml_diff>
--- a/Tracey-Scott-Portfolio-New.pptx
+++ b/Tracey-Scott-Portfolio-New.pptx
@@ -11290,246 +11290,6 @@
   <p:transition spd="med" advClick="1">
     <p:fade/>
   </p:transition>
-  <p:timing>
-    <p:tnLst>
-      <p:par>
-        <p:cTn id="1" dur="indefinite" restart="never" nodeType="tmRoot">
-          <p:childTnLst>
-            <p:seq concurrent="1" nextAc="seek">
-              <p:cTn id="2" dur="indefinite" nodeType="mainSeq">
-                <p:childTnLst>
-                  <p:par>
-                    <p:cTn id="3" presetID="10" presetClass="entr" presetSubtype="0" fill="hold" nodeType="afterPrev">
-                      <p:stCondLst>
-                        <p:cond delay="0"/>
-                      </p:stCondLst>
-                      <p:childTnLst>
-                        <p:set>
-                          <p:cBhvr>
-                            <p:cTn id="4" dur="1" fill="hold">
-                              <p:stCondLst>
-                                <p:cond delay="0"/>
-                              </p:stCondLst>
-                            </p:cTn>
-                            <p:tgtEl>
-                              <p:spTgt spid="72"/>
-                            </p:tgtEl>
-                            <p:attrNameLst>
-                              <p:attrName>style.visibility</p:attrName>
-                            </p:attrNameLst>
-                          </p:cBhvr>
-                          <p:to>
-                            <p:strVal val="visible"/>
-                          </p:to>
-                        </p:set>
-                        <p:animEffect transition="in" filter="fade">
-                          <p:cBhvr>
-                            <p:cTn id="100" dur="500"/>
-                            <p:tgtEl>
-                              <p:spTgt spid="72"/>
-                            </p:tgtEl>
-                          </p:cBhvr>
-                        </p:animEffect>
-                      </p:childTnLst>
-                    </p:cTn>
-                  </p:par>
-                  <p:par>
-                    <p:cTn id="5" presetID="10" presetClass="entr" presetSubtype="0" fill="hold" nodeType="afterPrev">
-                      <p:stCondLst>
-                        <p:cond delay="300"/>
-                      </p:stCondLst>
-                      <p:childTnLst>
-                        <p:set>
-                          <p:cBhvr>
-                            <p:cTn id="6" dur="1" fill="hold">
-                              <p:stCondLst>
-                                <p:cond delay="0"/>
-                              </p:stCondLst>
-                            </p:cTn>
-                            <p:tgtEl>
-                              <p:spTgt spid="61"/>
-                            </p:tgtEl>
-                            <p:attrNameLst>
-                              <p:attrName>style.visibility</p:attrName>
-                            </p:attrNameLst>
-                          </p:cBhvr>
-                          <p:to>
-                            <p:strVal val="visible"/>
-                          </p:to>
-                        </p:set>
-                        <p:animEffect transition="in" filter="fade">
-                          <p:cBhvr>
-                            <p:cTn id="101" dur="500"/>
-                            <p:tgtEl>
-                              <p:spTgt spid="61"/>
-                            </p:tgtEl>
-                          </p:cBhvr>
-                        </p:animEffect>
-                      </p:childTnLst>
-                    </p:cTn>
-                  </p:par>
-                  <p:par>
-                    <p:cTn id="7" presetID="10" presetClass="entr" presetSubtype="0" fill="hold" nodeType="afterPrev">
-                      <p:stCondLst>
-                        <p:cond delay="600"/>
-                      </p:stCondLst>
-                      <p:childTnLst>
-                        <p:set>
-                          <p:cBhvr>
-                            <p:cTn id="8" dur="1" fill="hold">
-                              <p:stCondLst>
-                                <p:cond delay="0"/>
-                              </p:stCondLst>
-                            </p:cTn>
-                            <p:tgtEl>
-                              <p:spTgt spid="62"/>
-                            </p:tgtEl>
-                            <p:attrNameLst>
-                              <p:attrName>style.visibility</p:attrName>
-                            </p:attrNameLst>
-                          </p:cBhvr>
-                          <p:to>
-                            <p:strVal val="visible"/>
-                          </p:to>
-                        </p:set>
-                        <p:animEffect transition="in" filter="fade">
-                          <p:cBhvr>
-                            <p:cTn id="102" dur="500"/>
-                            <p:tgtEl>
-                              <p:spTgt spid="62"/>
-                            </p:tgtEl>
-                          </p:cBhvr>
-                        </p:animEffect>
-                      </p:childTnLst>
-                    </p:cTn>
-                  </p:par>
-                  <p:par>
-                    <p:cTn id="9" presetID="10" presetClass="entr" presetSubtype="0" fill="hold" nodeType="afterPrev">
-                      <p:stCondLst>
-                        <p:cond delay="900"/>
-                      </p:stCondLst>
-                      <p:childTnLst>
-                        <p:set>
-                          <p:cBhvr>
-                            <p:cTn id="10" dur="1" fill="hold">
-                              <p:stCondLst>
-                                <p:cond delay="0"/>
-                              </p:stCondLst>
-                            </p:cTn>
-                            <p:tgtEl>
-                              <p:spTgt spid="63"/>
-                            </p:tgtEl>
-                            <p:attrNameLst>
-                              <p:attrName>style.visibility</p:attrName>
-                            </p:attrNameLst>
-                          </p:cBhvr>
-                          <p:to>
-                            <p:strVal val="visible"/>
-                          </p:to>
-                        </p:set>
-                        <p:animEffect transition="in" filter="fade">
-                          <p:cBhvr>
-                            <p:cTn id="103" dur="500"/>
-                            <p:tgtEl>
-                              <p:spTgt spid="63"/>
-                            </p:tgtEl>
-                          </p:cBhvr>
-                        </p:animEffect>
-                      </p:childTnLst>
-                    </p:cTn>
-                  </p:par>
-                  <p:par>
-                    <p:cTn id="11" presetID="10" presetClass="entr" presetSubtype="0" fill="hold" nodeType="afterPrev">
-                      <p:stCondLst>
-                        <p:cond delay="1200"/>
-                      </p:stCondLst>
-                      <p:childTnLst>
-                        <p:set>
-                          <p:cBhvr>
-                            <p:cTn id="12" dur="1" fill="hold">
-                              <p:stCondLst>
-                                <p:cond delay="0"/>
-                              </p:stCondLst>
-                            </p:cTn>
-                            <p:tgtEl>
-                              <p:spTgt spid="64"/>
-                            </p:tgtEl>
-                            <p:attrNameLst>
-                              <p:attrName>style.visibility</p:attrName>
-                            </p:attrNameLst>
-                          </p:cBhvr>
-                          <p:to>
-                            <p:strVal val="visible"/>
-                          </p:to>
-                        </p:set>
-                        <p:animEffect transition="in" filter="fade">
-                          <p:cBhvr>
-                            <p:cTn id="104" dur="500"/>
-                            <p:tgtEl>
-                              <p:spTgt spid="64"/>
-                            </p:tgtEl>
-                          </p:cBhvr>
-                        </p:animEffect>
-                      </p:childTnLst>
-                    </p:cTn>
-                  </p:par>
-                  <p:par>
-                    <p:cTn id="13" presetID="10" presetClass="entr" presetSubtype="0" fill="hold" nodeType="afterPrev">
-                      <p:stCondLst>
-                        <p:cond delay="1500"/>
-                      </p:stCondLst>
-                      <p:childTnLst>
-                        <p:set>
-                          <p:cBhvr>
-                            <p:cTn id="14" dur="1" fill="hold">
-                              <p:stCondLst>
-                                <p:cond delay="0"/>
-                              </p:stCondLst>
-                            </p:cTn>
-                            <p:tgtEl>
-                              <p:spTgt spid="65"/>
-                            </p:tgtEl>
-                            <p:attrNameLst>
-                              <p:attrName>style.visibility</p:attrName>
-                            </p:attrNameLst>
-                          </p:cBhvr>
-                          <p:to>
-                            <p:strVal val="visible"/>
-                          </p:to>
-                        </p:set>
-                        <p:animEffect transition="in" filter="fade">
-                          <p:cBhvr>
-                            <p:cTn id="105" dur="500"/>
-                            <p:tgtEl>
-                              <p:spTgt spid="65"/>
-                            </p:tgtEl>
-                          </p:cBhvr>
-                        </p:animEffect>
-                      </p:childTnLst>
-                    </p:cTn>
-                  </p:par>
-                </p:childTnLst>
-              </p:cTn>
-              <p:prevCondLst>
-                <p:cond evt="onPrev" delay="0">
-                  <p:tgtEl>
-                    <p:sldTgt/>
-                  </p:tgtEl>
-                </p:cond>
-              </p:prevCondLst>
-              <p:nextCondLst>
-                <p:cond evt="onNext" delay="0">
-                  <p:tgtEl>
-                    <p:sldTgt/>
-                  </p:tgtEl>
-                </p:cond>
-              </p:nextCondLst>
-            </p:seq>
-          </p:childTnLst>
-        </p:cTn>
-      </p:par>
-    </p:tnLst>
-  </p:timing>
 </p:sld>
 </file>
 
@@ -11711,176 +11471,6 @@
   <p:transition spd="med" advClick="1">
     <p:fade/>
   </p:transition>
-  <p:timing>
-    <p:tnLst>
-      <p:par>
-        <p:cTn id="1" dur="indefinite" restart="never" nodeType="tmRoot">
-          <p:childTnLst>
-            <p:seq concurrent="1" nextAc="seek">
-              <p:cTn id="2" dur="indefinite" nodeType="mainSeq">
-                <p:childTnLst>
-                  <p:par>
-                    <p:cTn id="3" presetID="10" presetClass="entr" presetSubtype="0" fill="hold" nodeType="afterPrev">
-                      <p:stCondLst>
-                        <p:cond delay="0"/>
-                      </p:stCondLst>
-                      <p:childTnLst>
-                        <p:set>
-                          <p:cBhvr>
-                            <p:cTn id="4" dur="1" fill="hold">
-                              <p:stCondLst>
-                                <p:cond delay="0"/>
-                              </p:stCondLst>
-                            </p:cTn>
-                            <p:tgtEl>
-                              <p:spTgt spid="273"/>
-                            </p:tgtEl>
-                            <p:attrNameLst>
-                              <p:attrName>style.visibility</p:attrName>
-                            </p:attrNameLst>
-                          </p:cBhvr>
-                          <p:to>
-                            <p:strVal val="visible"/>
-                          </p:to>
-                        </p:set>
-                        <p:animEffect transition="in" filter="fade">
-                          <p:cBhvr>
-                            <p:cTn id="100" dur="500"/>
-                            <p:tgtEl>
-                              <p:spTgt spid="273"/>
-                            </p:tgtEl>
-                          </p:cBhvr>
-                        </p:animEffect>
-                      </p:childTnLst>
-                    </p:cTn>
-                  </p:par>
-                  <p:par>
-                    <p:cTn id="5" presetID="10" presetClass="entr" presetSubtype="0" fill="hold" nodeType="afterPrev">
-                      <p:stCondLst>
-                        <p:cond delay="300"/>
-                      </p:stCondLst>
-                      <p:childTnLst>
-                        <p:set>
-                          <p:cBhvr>
-                            <p:cTn id="6" dur="1" fill="hold">
-                              <p:stCondLst>
-                                <p:cond delay="0"/>
-                              </p:stCondLst>
-                            </p:cTn>
-                            <p:tgtEl>
-                              <p:spTgt spid="274"/>
-                            </p:tgtEl>
-                            <p:attrNameLst>
-                              <p:attrName>style.visibility</p:attrName>
-                            </p:attrNameLst>
-                          </p:cBhvr>
-                          <p:to>
-                            <p:strVal val="visible"/>
-                          </p:to>
-                        </p:set>
-                        <p:animEffect transition="in" filter="fade">
-                          <p:cBhvr>
-                            <p:cTn id="101" dur="500"/>
-                            <p:tgtEl>
-                              <p:spTgt spid="274"/>
-                            </p:tgtEl>
-                          </p:cBhvr>
-                        </p:animEffect>
-                      </p:childTnLst>
-                    </p:cTn>
-                  </p:par>
-                  <p:par>
-                    <p:cTn id="7" presetID="10" presetClass="entr" presetSubtype="0" fill="hold" nodeType="afterPrev">
-                      <p:stCondLst>
-                        <p:cond delay="600"/>
-                      </p:stCondLst>
-                      <p:childTnLst>
-                        <p:set>
-                          <p:cBhvr>
-                            <p:cTn id="8" dur="1" fill="hold">
-                              <p:stCondLst>
-                                <p:cond delay="0"/>
-                              </p:stCondLst>
-                            </p:cTn>
-                            <p:tgtEl>
-                              <p:spTgt spid="275"/>
-                            </p:tgtEl>
-                            <p:attrNameLst>
-                              <p:attrName>style.visibility</p:attrName>
-                            </p:attrNameLst>
-                          </p:cBhvr>
-                          <p:to>
-                            <p:strVal val="visible"/>
-                          </p:to>
-                        </p:set>
-                        <p:animEffect transition="in" filter="fade">
-                          <p:cBhvr>
-                            <p:cTn id="102" dur="500"/>
-                            <p:tgtEl>
-                              <p:spTgt spid="275"/>
-                            </p:tgtEl>
-                          </p:cBhvr>
-                        </p:animEffect>
-                      </p:childTnLst>
-                    </p:cTn>
-                  </p:par>
-                  <p:par>
-                    <p:cTn id="9" presetID="10" presetClass="entr" presetSubtype="0" fill="hold" nodeType="afterPrev">
-                      <p:stCondLst>
-                        <p:cond delay="900"/>
-                      </p:stCondLst>
-                      <p:childTnLst>
-                        <p:set>
-                          <p:cBhvr>
-                            <p:cTn id="10" dur="1" fill="hold">
-                              <p:stCondLst>
-                                <p:cond delay="0"/>
-                              </p:stCondLst>
-                            </p:cTn>
-                            <p:tgtEl>
-                              <p:spTgt spid="276"/>
-                            </p:tgtEl>
-                            <p:attrNameLst>
-                              <p:attrName>style.visibility</p:attrName>
-                            </p:attrNameLst>
-                          </p:cBhvr>
-                          <p:to>
-                            <p:strVal val="visible"/>
-                          </p:to>
-                        </p:set>
-                        <p:animEffect transition="in" filter="fade">
-                          <p:cBhvr>
-                            <p:cTn id="103" dur="500"/>
-                            <p:tgtEl>
-                              <p:spTgt spid="276"/>
-                            </p:tgtEl>
-                          </p:cBhvr>
-                        </p:animEffect>
-                      </p:childTnLst>
-                    </p:cTn>
-                  </p:par>
-                </p:childTnLst>
-              </p:cTn>
-              <p:prevCondLst>
-                <p:cond evt="onPrev" delay="0">
-                  <p:tgtEl>
-                    <p:sldTgt/>
-                  </p:tgtEl>
-                </p:cond>
-              </p:prevCondLst>
-              <p:nextCondLst>
-                <p:cond evt="onNext" delay="0">
-                  <p:tgtEl>
-                    <p:sldTgt/>
-                  </p:tgtEl>
-                </p:cond>
-              </p:nextCondLst>
-            </p:seq>
-          </p:childTnLst>
-        </p:cTn>
-      </p:par>
-    </p:tnLst>
-  </p:timing>
 </p:sld>
 </file>
 
@@ -12030,106 +11620,6 @@
   <p:transition spd="med" advClick="1">
     <p:fade/>
   </p:transition>
-  <p:timing>
-    <p:tnLst>
-      <p:par>
-        <p:cTn id="1" dur="indefinite" restart="never" nodeType="tmRoot">
-          <p:childTnLst>
-            <p:seq concurrent="1" nextAc="seek">
-              <p:cTn id="2" dur="indefinite" nodeType="mainSeq">
-                <p:childTnLst>
-                  <p:par>
-                    <p:cTn id="3" presetID="10" presetClass="entr" presetSubtype="0" fill="hold" nodeType="afterPrev">
-                      <p:stCondLst>
-                        <p:cond delay="0"/>
-                      </p:stCondLst>
-                      <p:childTnLst>
-                        <p:set>
-                          <p:cBhvr>
-                            <p:cTn id="4" dur="1" fill="hold">
-                              <p:stCondLst>
-                                <p:cond delay="0"/>
-                              </p:stCondLst>
-                            </p:cTn>
-                            <p:tgtEl>
-                              <p:spTgt spid="281"/>
-                            </p:tgtEl>
-                            <p:attrNameLst>
-                              <p:attrName>style.visibility</p:attrName>
-                            </p:attrNameLst>
-                          </p:cBhvr>
-                          <p:to>
-                            <p:strVal val="visible"/>
-                          </p:to>
-                        </p:set>
-                        <p:animEffect transition="in" filter="fade">
-                          <p:cBhvr>
-                            <p:cTn id="100" dur="500"/>
-                            <p:tgtEl>
-                              <p:spTgt spid="281"/>
-                            </p:tgtEl>
-                          </p:cBhvr>
-                        </p:animEffect>
-                      </p:childTnLst>
-                    </p:cTn>
-                  </p:par>
-                  <p:par>
-                    <p:cTn id="5" presetID="10" presetClass="entr" presetSubtype="0" fill="hold" nodeType="afterPrev">
-                      <p:stCondLst>
-                        <p:cond delay="300"/>
-                      </p:stCondLst>
-                      <p:childTnLst>
-                        <p:set>
-                          <p:cBhvr>
-                            <p:cTn id="6" dur="1" fill="hold">
-                              <p:stCondLst>
-                                <p:cond delay="0"/>
-                              </p:stCondLst>
-                            </p:cTn>
-                            <p:tgtEl>
-                              <p:spTgt spid="282"/>
-                            </p:tgtEl>
-                            <p:attrNameLst>
-                              <p:attrName>style.visibility</p:attrName>
-                            </p:attrNameLst>
-                          </p:cBhvr>
-                          <p:to>
-                            <p:strVal val="visible"/>
-                          </p:to>
-                        </p:set>
-                        <p:animEffect transition="in" filter="fade">
-                          <p:cBhvr>
-                            <p:cTn id="101" dur="500"/>
-                            <p:tgtEl>
-                              <p:spTgt spid="282"/>
-                            </p:tgtEl>
-                          </p:cBhvr>
-                        </p:animEffect>
-                      </p:childTnLst>
-                    </p:cTn>
-                  </p:par>
-                </p:childTnLst>
-              </p:cTn>
-              <p:prevCondLst>
-                <p:cond evt="onPrev" delay="0">
-                  <p:tgtEl>
-                    <p:sldTgt/>
-                  </p:tgtEl>
-                </p:cond>
-              </p:prevCondLst>
-              <p:nextCondLst>
-                <p:cond evt="onNext" delay="0">
-                  <p:tgtEl>
-                    <p:sldTgt/>
-                  </p:tgtEl>
-                </p:cond>
-              </p:nextCondLst>
-            </p:seq>
-          </p:childTnLst>
-        </p:cTn>
-      </p:par>
-    </p:tnLst>
-  </p:timing>
 </p:sld>
 </file>
 
@@ -13042,246 +12532,6 @@
   <p:transition spd="med" advClick="1">
     <p:fade/>
   </p:transition>
-  <p:timing>
-    <p:tnLst>
-      <p:par>
-        <p:cTn id="1" dur="indefinite" restart="never" nodeType="tmRoot">
-          <p:childTnLst>
-            <p:seq concurrent="1" nextAc="seek">
-              <p:cTn id="2" dur="indefinite" nodeType="mainSeq">
-                <p:childTnLst>
-                  <p:par>
-                    <p:cTn id="3" presetID="10" presetClass="entr" presetSubtype="0" fill="hold" nodeType="afterPrev">
-                      <p:stCondLst>
-                        <p:cond delay="0"/>
-                      </p:stCondLst>
-                      <p:childTnLst>
-                        <p:set>
-                          <p:cBhvr>
-                            <p:cTn id="4" dur="1" fill="hold">
-                              <p:stCondLst>
-                                <p:cond delay="0"/>
-                              </p:stCondLst>
-                            </p:cTn>
-                            <p:tgtEl>
-                              <p:spTgt spid="287"/>
-                            </p:tgtEl>
-                            <p:attrNameLst>
-                              <p:attrName>style.visibility</p:attrName>
-                            </p:attrNameLst>
-                          </p:cBhvr>
-                          <p:to>
-                            <p:strVal val="visible"/>
-                          </p:to>
-                        </p:set>
-                        <p:animEffect transition="in" filter="fade">
-                          <p:cBhvr>
-                            <p:cTn id="100" dur="500"/>
-                            <p:tgtEl>
-                              <p:spTgt spid="287"/>
-                            </p:tgtEl>
-                          </p:cBhvr>
-                        </p:animEffect>
-                      </p:childTnLst>
-                    </p:cTn>
-                  </p:par>
-                  <p:par>
-                    <p:cTn id="5" presetID="10" presetClass="entr" presetSubtype="0" fill="hold" nodeType="afterPrev">
-                      <p:stCondLst>
-                        <p:cond delay="300"/>
-                      </p:stCondLst>
-                      <p:childTnLst>
-                        <p:set>
-                          <p:cBhvr>
-                            <p:cTn id="6" dur="1" fill="hold">
-                              <p:stCondLst>
-                                <p:cond delay="0"/>
-                              </p:stCondLst>
-                            </p:cTn>
-                            <p:tgtEl>
-                              <p:spTgt spid="288"/>
-                            </p:tgtEl>
-                            <p:attrNameLst>
-                              <p:attrName>style.visibility</p:attrName>
-                            </p:attrNameLst>
-                          </p:cBhvr>
-                          <p:to>
-                            <p:strVal val="visible"/>
-                          </p:to>
-                        </p:set>
-                        <p:animEffect transition="in" filter="fade">
-                          <p:cBhvr>
-                            <p:cTn id="101" dur="500"/>
-                            <p:tgtEl>
-                              <p:spTgt spid="288"/>
-                            </p:tgtEl>
-                          </p:cBhvr>
-                        </p:animEffect>
-                      </p:childTnLst>
-                    </p:cTn>
-                  </p:par>
-                  <p:par>
-                    <p:cTn id="7" presetID="10" presetClass="entr" presetSubtype="0" fill="hold" nodeType="afterPrev">
-                      <p:stCondLst>
-                        <p:cond delay="600"/>
-                      </p:stCondLst>
-                      <p:childTnLst>
-                        <p:set>
-                          <p:cBhvr>
-                            <p:cTn id="8" dur="1" fill="hold">
-                              <p:stCondLst>
-                                <p:cond delay="0"/>
-                              </p:stCondLst>
-                            </p:cTn>
-                            <p:tgtEl>
-                              <p:spTgt spid="289"/>
-                            </p:tgtEl>
-                            <p:attrNameLst>
-                              <p:attrName>style.visibility</p:attrName>
-                            </p:attrNameLst>
-                          </p:cBhvr>
-                          <p:to>
-                            <p:strVal val="visible"/>
-                          </p:to>
-                        </p:set>
-                        <p:animEffect transition="in" filter="fade">
-                          <p:cBhvr>
-                            <p:cTn id="102" dur="500"/>
-                            <p:tgtEl>
-                              <p:spTgt spid="289"/>
-                            </p:tgtEl>
-                          </p:cBhvr>
-                        </p:animEffect>
-                      </p:childTnLst>
-                    </p:cTn>
-                  </p:par>
-                  <p:par>
-                    <p:cTn id="9" presetID="10" presetClass="entr" presetSubtype="0" fill="hold" nodeType="afterPrev">
-                      <p:stCondLst>
-                        <p:cond delay="900"/>
-                      </p:stCondLst>
-                      <p:childTnLst>
-                        <p:set>
-                          <p:cBhvr>
-                            <p:cTn id="10" dur="1" fill="hold">
-                              <p:stCondLst>
-                                <p:cond delay="0"/>
-                              </p:stCondLst>
-                            </p:cTn>
-                            <p:tgtEl>
-                              <p:spTgt spid="290"/>
-                            </p:tgtEl>
-                            <p:attrNameLst>
-                              <p:attrName>style.visibility</p:attrName>
-                            </p:attrNameLst>
-                          </p:cBhvr>
-                          <p:to>
-                            <p:strVal val="visible"/>
-                          </p:to>
-                        </p:set>
-                        <p:animEffect transition="in" filter="fade">
-                          <p:cBhvr>
-                            <p:cTn id="103" dur="500"/>
-                            <p:tgtEl>
-                              <p:spTgt spid="290"/>
-                            </p:tgtEl>
-                          </p:cBhvr>
-                        </p:animEffect>
-                      </p:childTnLst>
-                    </p:cTn>
-                  </p:par>
-                  <p:par>
-                    <p:cTn id="11" presetID="10" presetClass="entr" presetSubtype="0" fill="hold" nodeType="afterPrev">
-                      <p:stCondLst>
-                        <p:cond delay="1200"/>
-                      </p:stCondLst>
-                      <p:childTnLst>
-                        <p:set>
-                          <p:cBhvr>
-                            <p:cTn id="12" dur="1" fill="hold">
-                              <p:stCondLst>
-                                <p:cond delay="0"/>
-                              </p:stCondLst>
-                            </p:cTn>
-                            <p:tgtEl>
-                              <p:spTgt spid="291"/>
-                            </p:tgtEl>
-                            <p:attrNameLst>
-                              <p:attrName>style.visibility</p:attrName>
-                            </p:attrNameLst>
-                          </p:cBhvr>
-                          <p:to>
-                            <p:strVal val="visible"/>
-                          </p:to>
-                        </p:set>
-                        <p:animEffect transition="in" filter="fade">
-                          <p:cBhvr>
-                            <p:cTn id="104" dur="500"/>
-                            <p:tgtEl>
-                              <p:spTgt spid="291"/>
-                            </p:tgtEl>
-                          </p:cBhvr>
-                        </p:animEffect>
-                      </p:childTnLst>
-                    </p:cTn>
-                  </p:par>
-                  <p:par>
-                    <p:cTn id="13" presetID="10" presetClass="entr" presetSubtype="0" fill="hold" nodeType="afterPrev">
-                      <p:stCondLst>
-                        <p:cond delay="1500"/>
-                      </p:stCondLst>
-                      <p:childTnLst>
-                        <p:set>
-                          <p:cBhvr>
-                            <p:cTn id="14" dur="1" fill="hold">
-                              <p:stCondLst>
-                                <p:cond delay="0"/>
-                              </p:stCondLst>
-                            </p:cTn>
-                            <p:tgtEl>
-                              <p:spTgt spid="292"/>
-                            </p:tgtEl>
-                            <p:attrNameLst>
-                              <p:attrName>style.visibility</p:attrName>
-                            </p:attrNameLst>
-                          </p:cBhvr>
-                          <p:to>
-                            <p:strVal val="visible"/>
-                          </p:to>
-                        </p:set>
-                        <p:animEffect transition="in" filter="fade">
-                          <p:cBhvr>
-                            <p:cTn id="105" dur="500"/>
-                            <p:tgtEl>
-                              <p:spTgt spid="292"/>
-                            </p:tgtEl>
-                          </p:cBhvr>
-                        </p:animEffect>
-                      </p:childTnLst>
-                    </p:cTn>
-                  </p:par>
-                </p:childTnLst>
-              </p:cTn>
-              <p:prevCondLst>
-                <p:cond evt="onPrev" delay="0">
-                  <p:tgtEl>
-                    <p:sldTgt/>
-                  </p:tgtEl>
-                </p:cond>
-              </p:prevCondLst>
-              <p:nextCondLst>
-                <p:cond evt="onNext" delay="0">
-                  <p:tgtEl>
-                    <p:sldTgt/>
-                  </p:tgtEl>
-                </p:cond>
-              </p:nextCondLst>
-            </p:seq>
-          </p:childTnLst>
-        </p:cTn>
-      </p:par>
-    </p:tnLst>
-  </p:timing>
 </p:sld>
 </file>
 
@@ -14717,141 +13967,6 @@
   <p:transition spd="med" advClick="1">
     <p:fade/>
   </p:transition>
-  <p:timing>
-    <p:tnLst>
-      <p:par>
-        <p:cTn id="1" dur="indefinite" restart="never" nodeType="tmRoot">
-          <p:childTnLst>
-            <p:seq concurrent="1" nextAc="seek">
-              <p:cTn id="2" dur="indefinite" nodeType="mainSeq">
-                <p:childTnLst>
-                  <p:par>
-                    <p:cTn id="3" presetID="10" presetClass="entr" presetSubtype="0" fill="hold" nodeType="afterPrev">
-                      <p:stCondLst>
-                        <p:cond delay="0"/>
-                      </p:stCondLst>
-                      <p:childTnLst>
-                        <p:set>
-                          <p:cBhvr>
-                            <p:cTn id="4" dur="1" fill="hold">
-                              <p:stCondLst>
-                                <p:cond delay="0"/>
-                              </p:stCondLst>
-                            </p:cTn>
-                            <p:tgtEl>
-                              <p:spTgt spid="308"/>
-                            </p:tgtEl>
-                            <p:attrNameLst>
-                              <p:attrName>style.visibility</p:attrName>
-                            </p:attrNameLst>
-                          </p:cBhvr>
-                          <p:to>
-                            <p:strVal val="visible"/>
-                          </p:to>
-                        </p:set>
-                        <p:animEffect transition="in" filter="fade">
-                          <p:cBhvr>
-                            <p:cTn id="100" dur="500"/>
-                            <p:tgtEl>
-                              <p:spTgt spid="308"/>
-                            </p:tgtEl>
-                          </p:cBhvr>
-                        </p:animEffect>
-                      </p:childTnLst>
-                    </p:cTn>
-                  </p:par>
-                  <p:par>
-                    <p:cTn id="5" presetID="10" presetClass="entr" presetSubtype="0" fill="hold" nodeType="afterPrev">
-                      <p:stCondLst>
-                        <p:cond delay="300"/>
-                      </p:stCondLst>
-                      <p:childTnLst>
-                        <p:set>
-                          <p:cBhvr>
-                            <p:cTn id="6" dur="1" fill="hold">
-                              <p:stCondLst>
-                                <p:cond delay="0"/>
-                              </p:stCondLst>
-                            </p:cTn>
-                            <p:tgtEl>
-                              <p:spTgt spid="309"/>
-                            </p:tgtEl>
-                            <p:attrNameLst>
-                              <p:attrName>style.visibility</p:attrName>
-                            </p:attrNameLst>
-                          </p:cBhvr>
-                          <p:to>
-                            <p:strVal val="visible"/>
-                          </p:to>
-                        </p:set>
-                        <p:animEffect transition="in" filter="fade">
-                          <p:cBhvr>
-                            <p:cTn id="101" dur="500"/>
-                            <p:tgtEl>
-                              <p:spTgt spid="309"/>
-                            </p:tgtEl>
-                          </p:cBhvr>
-                        </p:animEffect>
-                      </p:childTnLst>
-                    </p:cTn>
-                  </p:par>
-                  <p:par>
-                    <p:cTn id="7" presetID="10" presetClass="entr" presetSubtype="0" fill="hold" nodeType="afterPrev">
-                      <p:stCondLst>
-                        <p:cond delay="600"/>
-                      </p:stCondLst>
-                      <p:childTnLst>
-                        <p:set>
-                          <p:cBhvr>
-                            <p:cTn id="8" dur="1" fill="hold">
-                              <p:stCondLst>
-                                <p:cond delay="0"/>
-                              </p:stCondLst>
-                            </p:cTn>
-                            <p:tgtEl>
-                              <p:spTgt spid="310"/>
-                            </p:tgtEl>
-                            <p:attrNameLst>
-                              <p:attrName>style.visibility</p:attrName>
-                            </p:attrNameLst>
-                          </p:cBhvr>
-                          <p:to>
-                            <p:strVal val="visible"/>
-                          </p:to>
-                        </p:set>
-                        <p:animEffect transition="in" filter="fade">
-                          <p:cBhvr>
-                            <p:cTn id="102" dur="500"/>
-                            <p:tgtEl>
-                              <p:spTgt spid="310"/>
-                            </p:tgtEl>
-                          </p:cBhvr>
-                        </p:animEffect>
-                      </p:childTnLst>
-                    </p:cTn>
-                  </p:par>
-                </p:childTnLst>
-              </p:cTn>
-              <p:prevCondLst>
-                <p:cond evt="onPrev" delay="0">
-                  <p:tgtEl>
-                    <p:sldTgt/>
-                  </p:tgtEl>
-                </p:cond>
-              </p:prevCondLst>
-              <p:nextCondLst>
-                <p:cond evt="onNext" delay="0">
-                  <p:tgtEl>
-                    <p:sldTgt/>
-                  </p:tgtEl>
-                </p:cond>
-              </p:nextCondLst>
-            </p:seq>
-          </p:childTnLst>
-        </p:cTn>
-      </p:par>
-    </p:tnLst>
-  </p:timing>
 </p:sld>
 </file>
 
@@ -30893,246 +30008,6 @@
   <p:transition spd="med" advClick="1">
     <p:fade/>
   </p:transition>
-  <p:timing>
-    <p:tnLst>
-      <p:par>
-        <p:cTn id="1" dur="indefinite" restart="never" nodeType="tmRoot">
-          <p:childTnLst>
-            <p:seq concurrent="1" nextAc="seek">
-              <p:cTn id="2" dur="indefinite" nodeType="mainSeq">
-                <p:childTnLst>
-                  <p:par>
-                    <p:cTn id="3" presetID="10" presetClass="entr" presetSubtype="0" fill="hold" nodeType="afterPrev">
-                      <p:stCondLst>
-                        <p:cond delay="0"/>
-                      </p:stCondLst>
-                      <p:childTnLst>
-                        <p:set>
-                          <p:cBhvr>
-                            <p:cTn id="4" dur="1" fill="hold">
-                              <p:stCondLst>
-                                <p:cond delay="0"/>
-                              </p:stCondLst>
-                            </p:cTn>
-                            <p:tgtEl>
-                              <p:spTgt spid="315"/>
-                            </p:tgtEl>
-                            <p:attrNameLst>
-                              <p:attrName>style.visibility</p:attrName>
-                            </p:attrNameLst>
-                          </p:cBhvr>
-                          <p:to>
-                            <p:strVal val="visible"/>
-                          </p:to>
-                        </p:set>
-                        <p:animEffect transition="in" filter="fade">
-                          <p:cBhvr>
-                            <p:cTn id="100" dur="500"/>
-                            <p:tgtEl>
-                              <p:spTgt spid="315"/>
-                            </p:tgtEl>
-                          </p:cBhvr>
-                        </p:animEffect>
-                      </p:childTnLst>
-                    </p:cTn>
-                  </p:par>
-                  <p:par>
-                    <p:cTn id="5" presetID="10" presetClass="entr" presetSubtype="0" fill="hold" nodeType="afterPrev">
-                      <p:stCondLst>
-                        <p:cond delay="300"/>
-                      </p:stCondLst>
-                      <p:childTnLst>
-                        <p:set>
-                          <p:cBhvr>
-                            <p:cTn id="6" dur="1" fill="hold">
-                              <p:stCondLst>
-                                <p:cond delay="0"/>
-                              </p:stCondLst>
-                            </p:cTn>
-                            <p:tgtEl>
-                              <p:spTgt spid="316"/>
-                            </p:tgtEl>
-                            <p:attrNameLst>
-                              <p:attrName>style.visibility</p:attrName>
-                            </p:attrNameLst>
-                          </p:cBhvr>
-                          <p:to>
-                            <p:strVal val="visible"/>
-                          </p:to>
-                        </p:set>
-                        <p:animEffect transition="in" filter="fade">
-                          <p:cBhvr>
-                            <p:cTn id="101" dur="500"/>
-                            <p:tgtEl>
-                              <p:spTgt spid="316"/>
-                            </p:tgtEl>
-                          </p:cBhvr>
-                        </p:animEffect>
-                      </p:childTnLst>
-                    </p:cTn>
-                  </p:par>
-                  <p:par>
-                    <p:cTn id="7" presetID="10" presetClass="entr" presetSubtype="0" fill="hold" nodeType="afterPrev">
-                      <p:stCondLst>
-                        <p:cond delay="600"/>
-                      </p:stCondLst>
-                      <p:childTnLst>
-                        <p:set>
-                          <p:cBhvr>
-                            <p:cTn id="8" dur="1" fill="hold">
-                              <p:stCondLst>
-                                <p:cond delay="0"/>
-                              </p:stCondLst>
-                            </p:cTn>
-                            <p:tgtEl>
-                              <p:spTgt spid="317"/>
-                            </p:tgtEl>
-                            <p:attrNameLst>
-                              <p:attrName>style.visibility</p:attrName>
-                            </p:attrNameLst>
-                          </p:cBhvr>
-                          <p:to>
-                            <p:strVal val="visible"/>
-                          </p:to>
-                        </p:set>
-                        <p:animEffect transition="in" filter="fade">
-                          <p:cBhvr>
-                            <p:cTn id="102" dur="500"/>
-                            <p:tgtEl>
-                              <p:spTgt spid="317"/>
-                            </p:tgtEl>
-                          </p:cBhvr>
-                        </p:animEffect>
-                      </p:childTnLst>
-                    </p:cTn>
-                  </p:par>
-                  <p:par>
-                    <p:cTn id="9" presetID="10" presetClass="entr" presetSubtype="0" fill="hold" nodeType="afterPrev">
-                      <p:stCondLst>
-                        <p:cond delay="900"/>
-                      </p:stCondLst>
-                      <p:childTnLst>
-                        <p:set>
-                          <p:cBhvr>
-                            <p:cTn id="10" dur="1" fill="hold">
-                              <p:stCondLst>
-                                <p:cond delay="0"/>
-                              </p:stCondLst>
-                            </p:cTn>
-                            <p:tgtEl>
-                              <p:spTgt spid="318"/>
-                            </p:tgtEl>
-                            <p:attrNameLst>
-                              <p:attrName>style.visibility</p:attrName>
-                            </p:attrNameLst>
-                          </p:cBhvr>
-                          <p:to>
-                            <p:strVal val="visible"/>
-                          </p:to>
-                        </p:set>
-                        <p:animEffect transition="in" filter="fade">
-                          <p:cBhvr>
-                            <p:cTn id="103" dur="500"/>
-                            <p:tgtEl>
-                              <p:spTgt spid="318"/>
-                            </p:tgtEl>
-                          </p:cBhvr>
-                        </p:animEffect>
-                      </p:childTnLst>
-                    </p:cTn>
-                  </p:par>
-                  <p:par>
-                    <p:cTn id="11" presetID="10" presetClass="entr" presetSubtype="0" fill="hold" nodeType="afterPrev">
-                      <p:stCondLst>
-                        <p:cond delay="1200"/>
-                      </p:stCondLst>
-                      <p:childTnLst>
-                        <p:set>
-                          <p:cBhvr>
-                            <p:cTn id="12" dur="1" fill="hold">
-                              <p:stCondLst>
-                                <p:cond delay="0"/>
-                              </p:stCondLst>
-                            </p:cTn>
-                            <p:tgtEl>
-                              <p:spTgt spid="319"/>
-                            </p:tgtEl>
-                            <p:attrNameLst>
-                              <p:attrName>style.visibility</p:attrName>
-                            </p:attrNameLst>
-                          </p:cBhvr>
-                          <p:to>
-                            <p:strVal val="visible"/>
-                          </p:to>
-                        </p:set>
-                        <p:animEffect transition="in" filter="fade">
-                          <p:cBhvr>
-                            <p:cTn id="104" dur="500"/>
-                            <p:tgtEl>
-                              <p:spTgt spid="319"/>
-                            </p:tgtEl>
-                          </p:cBhvr>
-                        </p:animEffect>
-                      </p:childTnLst>
-                    </p:cTn>
-                  </p:par>
-                  <p:par>
-                    <p:cTn id="13" presetID="10" presetClass="entr" presetSubtype="0" fill="hold" nodeType="afterPrev">
-                      <p:stCondLst>
-                        <p:cond delay="1500"/>
-                      </p:stCondLst>
-                      <p:childTnLst>
-                        <p:set>
-                          <p:cBhvr>
-                            <p:cTn id="14" dur="1" fill="hold">
-                              <p:stCondLst>
-                                <p:cond delay="0"/>
-                              </p:stCondLst>
-                            </p:cTn>
-                            <p:tgtEl>
-                              <p:spTgt spid="320"/>
-                            </p:tgtEl>
-                            <p:attrNameLst>
-                              <p:attrName>style.visibility</p:attrName>
-                            </p:attrNameLst>
-                          </p:cBhvr>
-                          <p:to>
-                            <p:strVal val="visible"/>
-                          </p:to>
-                        </p:set>
-                        <p:animEffect transition="in" filter="fade">
-                          <p:cBhvr>
-                            <p:cTn id="105" dur="500"/>
-                            <p:tgtEl>
-                              <p:spTgt spid="320"/>
-                            </p:tgtEl>
-                          </p:cBhvr>
-                        </p:animEffect>
-                      </p:childTnLst>
-                    </p:cTn>
-                  </p:par>
-                </p:childTnLst>
-              </p:cTn>
-              <p:prevCondLst>
-                <p:cond evt="onPrev" delay="0">
-                  <p:tgtEl>
-                    <p:sldTgt/>
-                  </p:tgtEl>
-                </p:cond>
-              </p:prevCondLst>
-              <p:nextCondLst>
-                <p:cond evt="onNext" delay="0">
-                  <p:tgtEl>
-                    <p:sldTgt/>
-                  </p:tgtEl>
-                </p:cond>
-              </p:nextCondLst>
-            </p:seq>
-          </p:childTnLst>
-        </p:cTn>
-      </p:par>
-    </p:tnLst>
-  </p:timing>
 </p:sld>
 </file>
 
@@ -31314,141 +30189,6 @@
   <p:transition spd="med" advClick="1">
     <p:fade/>
   </p:transition>
-  <p:timing>
-    <p:tnLst>
-      <p:par>
-        <p:cTn id="1" dur="indefinite" restart="never" nodeType="tmRoot">
-          <p:childTnLst>
-            <p:seq concurrent="1" nextAc="seek">
-              <p:cTn id="2" dur="indefinite" nodeType="mainSeq">
-                <p:childTnLst>
-                  <p:par>
-                    <p:cTn id="3" presetID="10" presetClass="entr" presetSubtype="0" fill="hold" nodeType="afterPrev">
-                      <p:stCondLst>
-                        <p:cond delay="0"/>
-                      </p:stCondLst>
-                      <p:childTnLst>
-                        <p:set>
-                          <p:cBhvr>
-                            <p:cTn id="4" dur="1" fill="hold">
-                              <p:stCondLst>
-                                <p:cond delay="0"/>
-                              </p:stCondLst>
-                            </p:cTn>
-                            <p:tgtEl>
-                              <p:spTgt spid="342"/>
-                            </p:tgtEl>
-                            <p:attrNameLst>
-                              <p:attrName>style.visibility</p:attrName>
-                            </p:attrNameLst>
-                          </p:cBhvr>
-                          <p:to>
-                            <p:strVal val="visible"/>
-                          </p:to>
-                        </p:set>
-                        <p:animEffect transition="in" filter="fade">
-                          <p:cBhvr>
-                            <p:cTn id="100" dur="500"/>
-                            <p:tgtEl>
-                              <p:spTgt spid="342"/>
-                            </p:tgtEl>
-                          </p:cBhvr>
-                        </p:animEffect>
-                      </p:childTnLst>
-                    </p:cTn>
-                  </p:par>
-                  <p:par>
-                    <p:cTn id="5" presetID="10" presetClass="entr" presetSubtype="0" fill="hold" nodeType="afterPrev">
-                      <p:stCondLst>
-                        <p:cond delay="300"/>
-                      </p:stCondLst>
-                      <p:childTnLst>
-                        <p:set>
-                          <p:cBhvr>
-                            <p:cTn id="6" dur="1" fill="hold">
-                              <p:stCondLst>
-                                <p:cond delay="0"/>
-                              </p:stCondLst>
-                            </p:cTn>
-                            <p:tgtEl>
-                              <p:spTgt spid="343"/>
-                            </p:tgtEl>
-                            <p:attrNameLst>
-                              <p:attrName>style.visibility</p:attrName>
-                            </p:attrNameLst>
-                          </p:cBhvr>
-                          <p:to>
-                            <p:strVal val="visible"/>
-                          </p:to>
-                        </p:set>
-                        <p:animEffect transition="in" filter="fade">
-                          <p:cBhvr>
-                            <p:cTn id="101" dur="500"/>
-                            <p:tgtEl>
-                              <p:spTgt spid="343"/>
-                            </p:tgtEl>
-                          </p:cBhvr>
-                        </p:animEffect>
-                      </p:childTnLst>
-                    </p:cTn>
-                  </p:par>
-                  <p:par>
-                    <p:cTn id="7" presetID="10" presetClass="entr" presetSubtype="0" fill="hold" nodeType="afterPrev">
-                      <p:stCondLst>
-                        <p:cond delay="600"/>
-                      </p:stCondLst>
-                      <p:childTnLst>
-                        <p:set>
-                          <p:cBhvr>
-                            <p:cTn id="8" dur="1" fill="hold">
-                              <p:stCondLst>
-                                <p:cond delay="0"/>
-                              </p:stCondLst>
-                            </p:cTn>
-                            <p:tgtEl>
-                              <p:spTgt spid="344"/>
-                            </p:tgtEl>
-                            <p:attrNameLst>
-                              <p:attrName>style.visibility</p:attrName>
-                            </p:attrNameLst>
-                          </p:cBhvr>
-                          <p:to>
-                            <p:strVal val="visible"/>
-                          </p:to>
-                        </p:set>
-                        <p:animEffect transition="in" filter="fade">
-                          <p:cBhvr>
-                            <p:cTn id="102" dur="500"/>
-                            <p:tgtEl>
-                              <p:spTgt spid="344"/>
-                            </p:tgtEl>
-                          </p:cBhvr>
-                        </p:animEffect>
-                      </p:childTnLst>
-                    </p:cTn>
-                  </p:par>
-                </p:childTnLst>
-              </p:cTn>
-              <p:prevCondLst>
-                <p:cond evt="onPrev" delay="0">
-                  <p:tgtEl>
-                    <p:sldTgt/>
-                  </p:tgtEl>
-                </p:cond>
-              </p:prevCondLst>
-              <p:nextCondLst>
-                <p:cond evt="onNext" delay="0">
-                  <p:tgtEl>
-                    <p:sldTgt/>
-                  </p:tgtEl>
-                </p:cond>
-              </p:nextCondLst>
-            </p:seq>
-          </p:childTnLst>
-        </p:cTn>
-      </p:par>
-    </p:tnLst>
-  </p:timing>
 </p:sld>
 </file>
 
@@ -33588,246 +32328,6 @@
   <p:transition spd="med" advClick="1">
     <p:fade/>
   </p:transition>
-  <p:timing>
-    <p:tnLst>
-      <p:par>
-        <p:cTn id="1" dur="indefinite" restart="never" nodeType="tmRoot">
-          <p:childTnLst>
-            <p:seq concurrent="1" nextAc="seek">
-              <p:cTn id="2" dur="indefinite" nodeType="mainSeq">
-                <p:childTnLst>
-                  <p:par>
-                    <p:cTn id="3" presetID="10" presetClass="entr" presetSubtype="0" fill="hold" nodeType="afterPrev">
-                      <p:stCondLst>
-                        <p:cond delay="0"/>
-                      </p:stCondLst>
-                      <p:childTnLst>
-                        <p:set>
-                          <p:cBhvr>
-                            <p:cTn id="4" dur="1" fill="hold">
-                              <p:stCondLst>
-                                <p:cond delay="0"/>
-                              </p:stCondLst>
-                            </p:cTn>
-                            <p:tgtEl>
-                              <p:spTgt spid="349"/>
-                            </p:tgtEl>
-                            <p:attrNameLst>
-                              <p:attrName>style.visibility</p:attrName>
-                            </p:attrNameLst>
-                          </p:cBhvr>
-                          <p:to>
-                            <p:strVal val="visible"/>
-                          </p:to>
-                        </p:set>
-                        <p:animEffect transition="in" filter="fade">
-                          <p:cBhvr>
-                            <p:cTn id="100" dur="500"/>
-                            <p:tgtEl>
-                              <p:spTgt spid="349"/>
-                            </p:tgtEl>
-                          </p:cBhvr>
-                        </p:animEffect>
-                      </p:childTnLst>
-                    </p:cTn>
-                  </p:par>
-                  <p:par>
-                    <p:cTn id="5" presetID="10" presetClass="entr" presetSubtype="0" fill="hold" nodeType="afterPrev">
-                      <p:stCondLst>
-                        <p:cond delay="300"/>
-                      </p:stCondLst>
-                      <p:childTnLst>
-                        <p:set>
-                          <p:cBhvr>
-                            <p:cTn id="6" dur="1" fill="hold">
-                              <p:stCondLst>
-                                <p:cond delay="0"/>
-                              </p:stCondLst>
-                            </p:cTn>
-                            <p:tgtEl>
-                              <p:spTgt spid="350"/>
-                            </p:tgtEl>
-                            <p:attrNameLst>
-                              <p:attrName>style.visibility</p:attrName>
-                            </p:attrNameLst>
-                          </p:cBhvr>
-                          <p:to>
-                            <p:strVal val="visible"/>
-                          </p:to>
-                        </p:set>
-                        <p:animEffect transition="in" filter="fade">
-                          <p:cBhvr>
-                            <p:cTn id="101" dur="500"/>
-                            <p:tgtEl>
-                              <p:spTgt spid="350"/>
-                            </p:tgtEl>
-                          </p:cBhvr>
-                        </p:animEffect>
-                      </p:childTnLst>
-                    </p:cTn>
-                  </p:par>
-                  <p:par>
-                    <p:cTn id="7" presetID="10" presetClass="entr" presetSubtype="0" fill="hold" nodeType="afterPrev">
-                      <p:stCondLst>
-                        <p:cond delay="600"/>
-                      </p:stCondLst>
-                      <p:childTnLst>
-                        <p:set>
-                          <p:cBhvr>
-                            <p:cTn id="8" dur="1" fill="hold">
-                              <p:stCondLst>
-                                <p:cond delay="0"/>
-                              </p:stCondLst>
-                            </p:cTn>
-                            <p:tgtEl>
-                              <p:spTgt spid="351"/>
-                            </p:tgtEl>
-                            <p:attrNameLst>
-                              <p:attrName>style.visibility</p:attrName>
-                            </p:attrNameLst>
-                          </p:cBhvr>
-                          <p:to>
-                            <p:strVal val="visible"/>
-                          </p:to>
-                        </p:set>
-                        <p:animEffect transition="in" filter="fade">
-                          <p:cBhvr>
-                            <p:cTn id="102" dur="500"/>
-                            <p:tgtEl>
-                              <p:spTgt spid="351"/>
-                            </p:tgtEl>
-                          </p:cBhvr>
-                        </p:animEffect>
-                      </p:childTnLst>
-                    </p:cTn>
-                  </p:par>
-                  <p:par>
-                    <p:cTn id="9" presetID="10" presetClass="entr" presetSubtype="0" fill="hold" nodeType="afterPrev">
-                      <p:stCondLst>
-                        <p:cond delay="900"/>
-                      </p:stCondLst>
-                      <p:childTnLst>
-                        <p:set>
-                          <p:cBhvr>
-                            <p:cTn id="10" dur="1" fill="hold">
-                              <p:stCondLst>
-                                <p:cond delay="0"/>
-                              </p:stCondLst>
-                            </p:cTn>
-                            <p:tgtEl>
-                              <p:spTgt spid="352"/>
-                            </p:tgtEl>
-                            <p:attrNameLst>
-                              <p:attrName>style.visibility</p:attrName>
-                            </p:attrNameLst>
-                          </p:cBhvr>
-                          <p:to>
-                            <p:strVal val="visible"/>
-                          </p:to>
-                        </p:set>
-                        <p:animEffect transition="in" filter="fade">
-                          <p:cBhvr>
-                            <p:cTn id="103" dur="500"/>
-                            <p:tgtEl>
-                              <p:spTgt spid="352"/>
-                            </p:tgtEl>
-                          </p:cBhvr>
-                        </p:animEffect>
-                      </p:childTnLst>
-                    </p:cTn>
-                  </p:par>
-                  <p:par>
-                    <p:cTn id="11" presetID="10" presetClass="entr" presetSubtype="0" fill="hold" nodeType="afterPrev">
-                      <p:stCondLst>
-                        <p:cond delay="1200"/>
-                      </p:stCondLst>
-                      <p:childTnLst>
-                        <p:set>
-                          <p:cBhvr>
-                            <p:cTn id="12" dur="1" fill="hold">
-                              <p:stCondLst>
-                                <p:cond delay="0"/>
-                              </p:stCondLst>
-                            </p:cTn>
-                            <p:tgtEl>
-                              <p:spTgt spid="353"/>
-                            </p:tgtEl>
-                            <p:attrNameLst>
-                              <p:attrName>style.visibility</p:attrName>
-                            </p:attrNameLst>
-                          </p:cBhvr>
-                          <p:to>
-                            <p:strVal val="visible"/>
-                          </p:to>
-                        </p:set>
-                        <p:animEffect transition="in" filter="fade">
-                          <p:cBhvr>
-                            <p:cTn id="104" dur="500"/>
-                            <p:tgtEl>
-                              <p:spTgt spid="353"/>
-                            </p:tgtEl>
-                          </p:cBhvr>
-                        </p:animEffect>
-                      </p:childTnLst>
-                    </p:cTn>
-                  </p:par>
-                  <p:par>
-                    <p:cTn id="13" presetID="10" presetClass="entr" presetSubtype="0" fill="hold" nodeType="afterPrev">
-                      <p:stCondLst>
-                        <p:cond delay="1500"/>
-                      </p:stCondLst>
-                      <p:childTnLst>
-                        <p:set>
-                          <p:cBhvr>
-                            <p:cTn id="14" dur="1" fill="hold">
-                              <p:stCondLst>
-                                <p:cond delay="0"/>
-                              </p:stCondLst>
-                            </p:cTn>
-                            <p:tgtEl>
-                              <p:spTgt spid="354"/>
-                            </p:tgtEl>
-                            <p:attrNameLst>
-                              <p:attrName>style.visibility</p:attrName>
-                            </p:attrNameLst>
-                          </p:cBhvr>
-                          <p:to>
-                            <p:strVal val="visible"/>
-                          </p:to>
-                        </p:set>
-                        <p:animEffect transition="in" filter="fade">
-                          <p:cBhvr>
-                            <p:cTn id="105" dur="500"/>
-                            <p:tgtEl>
-                              <p:spTgt spid="354"/>
-                            </p:tgtEl>
-                          </p:cBhvr>
-                        </p:animEffect>
-                      </p:childTnLst>
-                    </p:cTn>
-                  </p:par>
-                </p:childTnLst>
-              </p:cTn>
-              <p:prevCondLst>
-                <p:cond evt="onPrev" delay="0">
-                  <p:tgtEl>
-                    <p:sldTgt/>
-                  </p:tgtEl>
-                </p:cond>
-              </p:prevCondLst>
-              <p:nextCondLst>
-                <p:cond evt="onNext" delay="0">
-                  <p:tgtEl>
-                    <p:sldTgt/>
-                  </p:tgtEl>
-                </p:cond>
-              </p:nextCondLst>
-            </p:seq>
-          </p:childTnLst>
-        </p:cTn>
-      </p:par>
-    </p:tnLst>
-  </p:timing>
 </p:sld>
 </file>
 
@@ -34345,246 +32845,6 @@
   <p:transition spd="med" advClick="1">
     <p:wipe dir="l"/>
   </p:transition>
-  <p:timing>
-    <p:tnLst>
-      <p:par>
-        <p:cTn id="1" dur="indefinite" restart="never" nodeType="tmRoot">
-          <p:childTnLst>
-            <p:seq concurrent="1" nextAc="seek">
-              <p:cTn id="2" dur="indefinite" nodeType="mainSeq">
-                <p:childTnLst>
-                  <p:par>
-                    <p:cTn id="3" presetID="10" presetClass="entr" presetSubtype="0" fill="hold" nodeType="afterPrev">
-                      <p:stCondLst>
-                        <p:cond delay="0"/>
-                      </p:stCondLst>
-                      <p:childTnLst>
-                        <p:set>
-                          <p:cBhvr>
-                            <p:cTn id="4" dur="1" fill="hold">
-                              <p:stCondLst>
-                                <p:cond delay="0"/>
-                              </p:stCondLst>
-                            </p:cTn>
-                            <p:tgtEl>
-                              <p:spTgt spid="381"/>
-                            </p:tgtEl>
-                            <p:attrNameLst>
-                              <p:attrName>style.visibility</p:attrName>
-                            </p:attrNameLst>
-                          </p:cBhvr>
-                          <p:to>
-                            <p:strVal val="visible"/>
-                          </p:to>
-                        </p:set>
-                        <p:animEffect transition="in" filter="fade">
-                          <p:cBhvr>
-                            <p:cTn id="100" dur="500"/>
-                            <p:tgtEl>
-                              <p:spTgt spid="381"/>
-                            </p:tgtEl>
-                          </p:cBhvr>
-                        </p:animEffect>
-                      </p:childTnLst>
-                    </p:cTn>
-                  </p:par>
-                  <p:par>
-                    <p:cTn id="5" presetID="10" presetClass="entr" presetSubtype="0" fill="hold" nodeType="afterPrev">
-                      <p:stCondLst>
-                        <p:cond delay="300"/>
-                      </p:stCondLst>
-                      <p:childTnLst>
-                        <p:set>
-                          <p:cBhvr>
-                            <p:cTn id="6" dur="1" fill="hold">
-                              <p:stCondLst>
-                                <p:cond delay="0"/>
-                              </p:stCondLst>
-                            </p:cTn>
-                            <p:tgtEl>
-                              <p:spTgt spid="382"/>
-                            </p:tgtEl>
-                            <p:attrNameLst>
-                              <p:attrName>style.visibility</p:attrName>
-                            </p:attrNameLst>
-                          </p:cBhvr>
-                          <p:to>
-                            <p:strVal val="visible"/>
-                          </p:to>
-                        </p:set>
-                        <p:animEffect transition="in" filter="fade">
-                          <p:cBhvr>
-                            <p:cTn id="101" dur="500"/>
-                            <p:tgtEl>
-                              <p:spTgt spid="382"/>
-                            </p:tgtEl>
-                          </p:cBhvr>
-                        </p:animEffect>
-                      </p:childTnLst>
-                    </p:cTn>
-                  </p:par>
-                  <p:par>
-                    <p:cTn id="7" presetID="10" presetClass="entr" presetSubtype="0" fill="hold" nodeType="afterPrev">
-                      <p:stCondLst>
-                        <p:cond delay="600"/>
-                      </p:stCondLst>
-                      <p:childTnLst>
-                        <p:set>
-                          <p:cBhvr>
-                            <p:cTn id="8" dur="1" fill="hold">
-                              <p:stCondLst>
-                                <p:cond delay="0"/>
-                              </p:stCondLst>
-                            </p:cTn>
-                            <p:tgtEl>
-                              <p:spTgt spid="383"/>
-                            </p:tgtEl>
-                            <p:attrNameLst>
-                              <p:attrName>style.visibility</p:attrName>
-                            </p:attrNameLst>
-                          </p:cBhvr>
-                          <p:to>
-                            <p:strVal val="visible"/>
-                          </p:to>
-                        </p:set>
-                        <p:animEffect transition="in" filter="fade">
-                          <p:cBhvr>
-                            <p:cTn id="102" dur="500"/>
-                            <p:tgtEl>
-                              <p:spTgt spid="383"/>
-                            </p:tgtEl>
-                          </p:cBhvr>
-                        </p:animEffect>
-                      </p:childTnLst>
-                    </p:cTn>
-                  </p:par>
-                  <p:par>
-                    <p:cTn id="9" presetID="10" presetClass="entr" presetSubtype="0" fill="hold" nodeType="afterPrev">
-                      <p:stCondLst>
-                        <p:cond delay="900"/>
-                      </p:stCondLst>
-                      <p:childTnLst>
-                        <p:set>
-                          <p:cBhvr>
-                            <p:cTn id="10" dur="1" fill="hold">
-                              <p:stCondLst>
-                                <p:cond delay="0"/>
-                              </p:stCondLst>
-                            </p:cTn>
-                            <p:tgtEl>
-                              <p:spTgt spid="384"/>
-                            </p:tgtEl>
-                            <p:attrNameLst>
-                              <p:attrName>style.visibility</p:attrName>
-                            </p:attrNameLst>
-                          </p:cBhvr>
-                          <p:to>
-                            <p:strVal val="visible"/>
-                          </p:to>
-                        </p:set>
-                        <p:animEffect transition="in" filter="fade">
-                          <p:cBhvr>
-                            <p:cTn id="103" dur="500"/>
-                            <p:tgtEl>
-                              <p:spTgt spid="384"/>
-                            </p:tgtEl>
-                          </p:cBhvr>
-                        </p:animEffect>
-                      </p:childTnLst>
-                    </p:cTn>
-                  </p:par>
-                  <p:par>
-                    <p:cTn id="11" presetID="10" presetClass="entr" presetSubtype="0" fill="hold" nodeType="afterPrev">
-                      <p:stCondLst>
-                        <p:cond delay="1200"/>
-                      </p:stCondLst>
-                      <p:childTnLst>
-                        <p:set>
-                          <p:cBhvr>
-                            <p:cTn id="12" dur="1" fill="hold">
-                              <p:stCondLst>
-                                <p:cond delay="0"/>
-                              </p:stCondLst>
-                            </p:cTn>
-                            <p:tgtEl>
-                              <p:spTgt spid="385"/>
-                            </p:tgtEl>
-                            <p:attrNameLst>
-                              <p:attrName>style.visibility</p:attrName>
-                            </p:attrNameLst>
-                          </p:cBhvr>
-                          <p:to>
-                            <p:strVal val="visible"/>
-                          </p:to>
-                        </p:set>
-                        <p:animEffect transition="in" filter="fade">
-                          <p:cBhvr>
-                            <p:cTn id="104" dur="500"/>
-                            <p:tgtEl>
-                              <p:spTgt spid="385"/>
-                            </p:tgtEl>
-                          </p:cBhvr>
-                        </p:animEffect>
-                      </p:childTnLst>
-                    </p:cTn>
-                  </p:par>
-                  <p:par>
-                    <p:cTn id="13" presetID="10" presetClass="entr" presetSubtype="0" fill="hold" nodeType="afterPrev">
-                      <p:stCondLst>
-                        <p:cond delay="1500"/>
-                      </p:stCondLst>
-                      <p:childTnLst>
-                        <p:set>
-                          <p:cBhvr>
-                            <p:cTn id="14" dur="1" fill="hold">
-                              <p:stCondLst>
-                                <p:cond delay="0"/>
-                              </p:stCondLst>
-                            </p:cTn>
-                            <p:tgtEl>
-                              <p:spTgt spid="386"/>
-                            </p:tgtEl>
-                            <p:attrNameLst>
-                              <p:attrName>style.visibility</p:attrName>
-                            </p:attrNameLst>
-                          </p:cBhvr>
-                          <p:to>
-                            <p:strVal val="visible"/>
-                          </p:to>
-                        </p:set>
-                        <p:animEffect transition="in" filter="fade">
-                          <p:cBhvr>
-                            <p:cTn id="105" dur="500"/>
-                            <p:tgtEl>
-                              <p:spTgt spid="386"/>
-                            </p:tgtEl>
-                          </p:cBhvr>
-                        </p:animEffect>
-                      </p:childTnLst>
-                    </p:cTn>
-                  </p:par>
-                </p:childTnLst>
-              </p:cTn>
-              <p:prevCondLst>
-                <p:cond evt="onPrev" delay="0">
-                  <p:tgtEl>
-                    <p:sldTgt/>
-                  </p:tgtEl>
-                </p:cond>
-              </p:prevCondLst>
-              <p:nextCondLst>
-                <p:cond evt="onNext" delay="0">
-                  <p:tgtEl>
-                    <p:sldTgt/>
-                  </p:tgtEl>
-                </p:cond>
-              </p:nextCondLst>
-            </p:seq>
-          </p:childTnLst>
-        </p:cTn>
-      </p:par>
-    </p:tnLst>
-  </p:timing>
 </p:sld>
 </file>
 
@@ -35069,246 +33329,6 @@
   <p:transition spd="med" advClick="1">
     <p:wipe dir="l"/>
   </p:transition>
-  <p:timing>
-    <p:tnLst>
-      <p:par>
-        <p:cTn id="1" dur="indefinite" restart="never" nodeType="tmRoot">
-          <p:childTnLst>
-            <p:seq concurrent="1" nextAc="seek">
-              <p:cTn id="2" dur="indefinite" nodeType="mainSeq">
-                <p:childTnLst>
-                  <p:par>
-                    <p:cTn id="3" presetID="10" presetClass="entr" presetSubtype="0" fill="hold" nodeType="afterPrev">
-                      <p:stCondLst>
-                        <p:cond delay="0"/>
-                      </p:stCondLst>
-                      <p:childTnLst>
-                        <p:set>
-                          <p:cBhvr>
-                            <p:cTn id="4" dur="1" fill="hold">
-                              <p:stCondLst>
-                                <p:cond delay="0"/>
-                              </p:stCondLst>
-                            </p:cTn>
-                            <p:tgtEl>
-                              <p:spTgt spid="393"/>
-                            </p:tgtEl>
-                            <p:attrNameLst>
-                              <p:attrName>style.visibility</p:attrName>
-                            </p:attrNameLst>
-                          </p:cBhvr>
-                          <p:to>
-                            <p:strVal val="visible"/>
-                          </p:to>
-                        </p:set>
-                        <p:animEffect transition="in" filter="fade">
-                          <p:cBhvr>
-                            <p:cTn id="100" dur="500"/>
-                            <p:tgtEl>
-                              <p:spTgt spid="393"/>
-                            </p:tgtEl>
-                          </p:cBhvr>
-                        </p:animEffect>
-                      </p:childTnLst>
-                    </p:cTn>
-                  </p:par>
-                  <p:par>
-                    <p:cTn id="5" presetID="10" presetClass="entr" presetSubtype="0" fill="hold" nodeType="afterPrev">
-                      <p:stCondLst>
-                        <p:cond delay="300"/>
-                      </p:stCondLst>
-                      <p:childTnLst>
-                        <p:set>
-                          <p:cBhvr>
-                            <p:cTn id="6" dur="1" fill="hold">
-                              <p:stCondLst>
-                                <p:cond delay="0"/>
-                              </p:stCondLst>
-                            </p:cTn>
-                            <p:tgtEl>
-                              <p:spTgt spid="394"/>
-                            </p:tgtEl>
-                            <p:attrNameLst>
-                              <p:attrName>style.visibility</p:attrName>
-                            </p:attrNameLst>
-                          </p:cBhvr>
-                          <p:to>
-                            <p:strVal val="visible"/>
-                          </p:to>
-                        </p:set>
-                        <p:animEffect transition="in" filter="fade">
-                          <p:cBhvr>
-                            <p:cTn id="101" dur="500"/>
-                            <p:tgtEl>
-                              <p:spTgt spid="394"/>
-                            </p:tgtEl>
-                          </p:cBhvr>
-                        </p:animEffect>
-                      </p:childTnLst>
-                    </p:cTn>
-                  </p:par>
-                  <p:par>
-                    <p:cTn id="7" presetID="10" presetClass="entr" presetSubtype="0" fill="hold" nodeType="afterPrev">
-                      <p:stCondLst>
-                        <p:cond delay="600"/>
-                      </p:stCondLst>
-                      <p:childTnLst>
-                        <p:set>
-                          <p:cBhvr>
-                            <p:cTn id="8" dur="1" fill="hold">
-                              <p:stCondLst>
-                                <p:cond delay="0"/>
-                              </p:stCondLst>
-                            </p:cTn>
-                            <p:tgtEl>
-                              <p:spTgt spid="395"/>
-                            </p:tgtEl>
-                            <p:attrNameLst>
-                              <p:attrName>style.visibility</p:attrName>
-                            </p:attrNameLst>
-                          </p:cBhvr>
-                          <p:to>
-                            <p:strVal val="visible"/>
-                          </p:to>
-                        </p:set>
-                        <p:animEffect transition="in" filter="fade">
-                          <p:cBhvr>
-                            <p:cTn id="102" dur="500"/>
-                            <p:tgtEl>
-                              <p:spTgt spid="395"/>
-                            </p:tgtEl>
-                          </p:cBhvr>
-                        </p:animEffect>
-                      </p:childTnLst>
-                    </p:cTn>
-                  </p:par>
-                  <p:par>
-                    <p:cTn id="9" presetID="10" presetClass="entr" presetSubtype="0" fill="hold" nodeType="afterPrev">
-                      <p:stCondLst>
-                        <p:cond delay="900"/>
-                      </p:stCondLst>
-                      <p:childTnLst>
-                        <p:set>
-                          <p:cBhvr>
-                            <p:cTn id="10" dur="1" fill="hold">
-                              <p:stCondLst>
-                                <p:cond delay="0"/>
-                              </p:stCondLst>
-                            </p:cTn>
-                            <p:tgtEl>
-                              <p:spTgt spid="396"/>
-                            </p:tgtEl>
-                            <p:attrNameLst>
-                              <p:attrName>style.visibility</p:attrName>
-                            </p:attrNameLst>
-                          </p:cBhvr>
-                          <p:to>
-                            <p:strVal val="visible"/>
-                          </p:to>
-                        </p:set>
-                        <p:animEffect transition="in" filter="fade">
-                          <p:cBhvr>
-                            <p:cTn id="103" dur="500"/>
-                            <p:tgtEl>
-                              <p:spTgt spid="396"/>
-                            </p:tgtEl>
-                          </p:cBhvr>
-                        </p:animEffect>
-                      </p:childTnLst>
-                    </p:cTn>
-                  </p:par>
-                  <p:par>
-                    <p:cTn id="11" presetID="10" presetClass="entr" presetSubtype="0" fill="hold" nodeType="afterPrev">
-                      <p:stCondLst>
-                        <p:cond delay="1200"/>
-                      </p:stCondLst>
-                      <p:childTnLst>
-                        <p:set>
-                          <p:cBhvr>
-                            <p:cTn id="12" dur="1" fill="hold">
-                              <p:stCondLst>
-                                <p:cond delay="0"/>
-                              </p:stCondLst>
-                            </p:cTn>
-                            <p:tgtEl>
-                              <p:spTgt spid="397"/>
-                            </p:tgtEl>
-                            <p:attrNameLst>
-                              <p:attrName>style.visibility</p:attrName>
-                            </p:attrNameLst>
-                          </p:cBhvr>
-                          <p:to>
-                            <p:strVal val="visible"/>
-                          </p:to>
-                        </p:set>
-                        <p:animEffect transition="in" filter="fade">
-                          <p:cBhvr>
-                            <p:cTn id="104" dur="500"/>
-                            <p:tgtEl>
-                              <p:spTgt spid="397"/>
-                            </p:tgtEl>
-                          </p:cBhvr>
-                        </p:animEffect>
-                      </p:childTnLst>
-                    </p:cTn>
-                  </p:par>
-                  <p:par>
-                    <p:cTn id="13" presetID="10" presetClass="entr" presetSubtype="0" fill="hold" nodeType="afterPrev">
-                      <p:stCondLst>
-                        <p:cond delay="1500"/>
-                      </p:stCondLst>
-                      <p:childTnLst>
-                        <p:set>
-                          <p:cBhvr>
-                            <p:cTn id="14" dur="1" fill="hold">
-                              <p:stCondLst>
-                                <p:cond delay="0"/>
-                              </p:stCondLst>
-                            </p:cTn>
-                            <p:tgtEl>
-                              <p:spTgt spid="398"/>
-                            </p:tgtEl>
-                            <p:attrNameLst>
-                              <p:attrName>style.visibility</p:attrName>
-                            </p:attrNameLst>
-                          </p:cBhvr>
-                          <p:to>
-                            <p:strVal val="visible"/>
-                          </p:to>
-                        </p:set>
-                        <p:animEffect transition="in" filter="fade">
-                          <p:cBhvr>
-                            <p:cTn id="105" dur="500"/>
-                            <p:tgtEl>
-                              <p:spTgt spid="398"/>
-                            </p:tgtEl>
-                          </p:cBhvr>
-                        </p:animEffect>
-                      </p:childTnLst>
-                    </p:cTn>
-                  </p:par>
-                </p:childTnLst>
-              </p:cTn>
-              <p:prevCondLst>
-                <p:cond evt="onPrev" delay="0">
-                  <p:tgtEl>
-                    <p:sldTgt/>
-                  </p:tgtEl>
-                </p:cond>
-              </p:prevCondLst>
-              <p:nextCondLst>
-                <p:cond evt="onNext" delay="0">
-                  <p:tgtEl>
-                    <p:sldTgt/>
-                  </p:tgtEl>
-                </p:cond>
-              </p:nextCondLst>
-            </p:seq>
-          </p:childTnLst>
-        </p:cTn>
-      </p:par>
-    </p:tnLst>
-  </p:timing>
 </p:sld>
 </file>
 
@@ -36232,246 +34252,6 @@
   <p:transition spd="med" advClick="1">
     <p:fade/>
   </p:transition>
-  <p:timing>
-    <p:tnLst>
-      <p:par>
-        <p:cTn id="1" dur="indefinite" restart="never" nodeType="tmRoot">
-          <p:childTnLst>
-            <p:seq concurrent="1" nextAc="seek">
-              <p:cTn id="2" dur="indefinite" nodeType="mainSeq">
-                <p:childTnLst>
-                  <p:par>
-                    <p:cTn id="3" presetID="10" presetClass="entr" presetSubtype="0" fill="hold" nodeType="afterPrev">
-                      <p:stCondLst>
-                        <p:cond delay="0"/>
-                      </p:stCondLst>
-                      <p:childTnLst>
-                        <p:set>
-                          <p:cBhvr>
-                            <p:cTn id="4" dur="1" fill="hold">
-                              <p:stCondLst>
-                                <p:cond delay="0"/>
-                              </p:stCondLst>
-                            </p:cTn>
-                            <p:tgtEl>
-                              <p:spTgt spid="405"/>
-                            </p:tgtEl>
-                            <p:attrNameLst>
-                              <p:attrName>style.visibility</p:attrName>
-                            </p:attrNameLst>
-                          </p:cBhvr>
-                          <p:to>
-                            <p:strVal val="visible"/>
-                          </p:to>
-                        </p:set>
-                        <p:animEffect transition="in" filter="fade">
-                          <p:cBhvr>
-                            <p:cTn id="100" dur="500"/>
-                            <p:tgtEl>
-                              <p:spTgt spid="405"/>
-                            </p:tgtEl>
-                          </p:cBhvr>
-                        </p:animEffect>
-                      </p:childTnLst>
-                    </p:cTn>
-                  </p:par>
-                  <p:par>
-                    <p:cTn id="5" presetID="10" presetClass="entr" presetSubtype="0" fill="hold" nodeType="afterPrev">
-                      <p:stCondLst>
-                        <p:cond delay="300"/>
-                      </p:stCondLst>
-                      <p:childTnLst>
-                        <p:set>
-                          <p:cBhvr>
-                            <p:cTn id="6" dur="1" fill="hold">
-                              <p:stCondLst>
-                                <p:cond delay="0"/>
-                              </p:stCondLst>
-                            </p:cTn>
-                            <p:tgtEl>
-                              <p:spTgt spid="406"/>
-                            </p:tgtEl>
-                            <p:attrNameLst>
-                              <p:attrName>style.visibility</p:attrName>
-                            </p:attrNameLst>
-                          </p:cBhvr>
-                          <p:to>
-                            <p:strVal val="visible"/>
-                          </p:to>
-                        </p:set>
-                        <p:animEffect transition="in" filter="fade">
-                          <p:cBhvr>
-                            <p:cTn id="101" dur="500"/>
-                            <p:tgtEl>
-                              <p:spTgt spid="406"/>
-                            </p:tgtEl>
-                          </p:cBhvr>
-                        </p:animEffect>
-                      </p:childTnLst>
-                    </p:cTn>
-                  </p:par>
-                  <p:par>
-                    <p:cTn id="7" presetID="10" presetClass="entr" presetSubtype="0" fill="hold" nodeType="afterPrev">
-                      <p:stCondLst>
-                        <p:cond delay="600"/>
-                      </p:stCondLst>
-                      <p:childTnLst>
-                        <p:set>
-                          <p:cBhvr>
-                            <p:cTn id="8" dur="1" fill="hold">
-                              <p:stCondLst>
-                                <p:cond delay="0"/>
-                              </p:stCondLst>
-                            </p:cTn>
-                            <p:tgtEl>
-                              <p:spTgt spid="407"/>
-                            </p:tgtEl>
-                            <p:attrNameLst>
-                              <p:attrName>style.visibility</p:attrName>
-                            </p:attrNameLst>
-                          </p:cBhvr>
-                          <p:to>
-                            <p:strVal val="visible"/>
-                          </p:to>
-                        </p:set>
-                        <p:animEffect transition="in" filter="fade">
-                          <p:cBhvr>
-                            <p:cTn id="102" dur="500"/>
-                            <p:tgtEl>
-                              <p:spTgt spid="407"/>
-                            </p:tgtEl>
-                          </p:cBhvr>
-                        </p:animEffect>
-                      </p:childTnLst>
-                    </p:cTn>
-                  </p:par>
-                  <p:par>
-                    <p:cTn id="9" presetID="10" presetClass="entr" presetSubtype="0" fill="hold" nodeType="afterPrev">
-                      <p:stCondLst>
-                        <p:cond delay="900"/>
-                      </p:stCondLst>
-                      <p:childTnLst>
-                        <p:set>
-                          <p:cBhvr>
-                            <p:cTn id="10" dur="1" fill="hold">
-                              <p:stCondLst>
-                                <p:cond delay="0"/>
-                              </p:stCondLst>
-                            </p:cTn>
-                            <p:tgtEl>
-                              <p:spTgt spid="408"/>
-                            </p:tgtEl>
-                            <p:attrNameLst>
-                              <p:attrName>style.visibility</p:attrName>
-                            </p:attrNameLst>
-                          </p:cBhvr>
-                          <p:to>
-                            <p:strVal val="visible"/>
-                          </p:to>
-                        </p:set>
-                        <p:animEffect transition="in" filter="fade">
-                          <p:cBhvr>
-                            <p:cTn id="103" dur="500"/>
-                            <p:tgtEl>
-                              <p:spTgt spid="408"/>
-                            </p:tgtEl>
-                          </p:cBhvr>
-                        </p:animEffect>
-                      </p:childTnLst>
-                    </p:cTn>
-                  </p:par>
-                  <p:par>
-                    <p:cTn id="11" presetID="10" presetClass="entr" presetSubtype="0" fill="hold" nodeType="afterPrev">
-                      <p:stCondLst>
-                        <p:cond delay="1200"/>
-                      </p:stCondLst>
-                      <p:childTnLst>
-                        <p:set>
-                          <p:cBhvr>
-                            <p:cTn id="12" dur="1" fill="hold">
-                              <p:stCondLst>
-                                <p:cond delay="0"/>
-                              </p:stCondLst>
-                            </p:cTn>
-                            <p:tgtEl>
-                              <p:spTgt spid="409"/>
-                            </p:tgtEl>
-                            <p:attrNameLst>
-                              <p:attrName>style.visibility</p:attrName>
-                            </p:attrNameLst>
-                          </p:cBhvr>
-                          <p:to>
-                            <p:strVal val="visible"/>
-                          </p:to>
-                        </p:set>
-                        <p:animEffect transition="in" filter="fade">
-                          <p:cBhvr>
-                            <p:cTn id="104" dur="500"/>
-                            <p:tgtEl>
-                              <p:spTgt spid="409"/>
-                            </p:tgtEl>
-                          </p:cBhvr>
-                        </p:animEffect>
-                      </p:childTnLst>
-                    </p:cTn>
-                  </p:par>
-                  <p:par>
-                    <p:cTn id="13" presetID="10" presetClass="entr" presetSubtype="0" fill="hold" nodeType="afterPrev">
-                      <p:stCondLst>
-                        <p:cond delay="1500"/>
-                      </p:stCondLst>
-                      <p:childTnLst>
-                        <p:set>
-                          <p:cBhvr>
-                            <p:cTn id="14" dur="1" fill="hold">
-                              <p:stCondLst>
-                                <p:cond delay="0"/>
-                              </p:stCondLst>
-                            </p:cTn>
-                            <p:tgtEl>
-                              <p:spTgt spid="410"/>
-                            </p:tgtEl>
-                            <p:attrNameLst>
-                              <p:attrName>style.visibility</p:attrName>
-                            </p:attrNameLst>
-                          </p:cBhvr>
-                          <p:to>
-                            <p:strVal val="visible"/>
-                          </p:to>
-                        </p:set>
-                        <p:animEffect transition="in" filter="fade">
-                          <p:cBhvr>
-                            <p:cTn id="105" dur="500"/>
-                            <p:tgtEl>
-                              <p:spTgt spid="410"/>
-                            </p:tgtEl>
-                          </p:cBhvr>
-                        </p:animEffect>
-                      </p:childTnLst>
-                    </p:cTn>
-                  </p:par>
-                </p:childTnLst>
-              </p:cTn>
-              <p:prevCondLst>
-                <p:cond evt="onPrev" delay="0">
-                  <p:tgtEl>
-                    <p:sldTgt/>
-                  </p:tgtEl>
-                </p:cond>
-              </p:prevCondLst>
-              <p:nextCondLst>
-                <p:cond evt="onNext" delay="0">
-                  <p:tgtEl>
-                    <p:sldTgt/>
-                  </p:tgtEl>
-                </p:cond>
-              </p:nextCondLst>
-            </p:seq>
-          </p:childTnLst>
-        </p:cTn>
-      </p:par>
-    </p:tnLst>
-  </p:timing>
 </p:sld>
 </file>
 
@@ -36930,211 +34710,6 @@
   <p:transition spd="med" advClick="1">
     <p:fade/>
   </p:transition>
-  <p:timing>
-    <p:tnLst>
-      <p:par>
-        <p:cTn id="1" dur="indefinite" restart="never" nodeType="tmRoot">
-          <p:childTnLst>
-            <p:seq concurrent="1" nextAc="seek">
-              <p:cTn id="2" dur="indefinite" nodeType="mainSeq">
-                <p:childTnLst>
-                  <p:par>
-                    <p:cTn id="3" presetID="10" presetClass="entr" presetSubtype="0" fill="hold" nodeType="afterPrev">
-                      <p:stCondLst>
-                        <p:cond delay="0"/>
-                      </p:stCondLst>
-                      <p:childTnLst>
-                        <p:set>
-                          <p:cBhvr>
-                            <p:cTn id="4" dur="1" fill="hold">
-                              <p:stCondLst>
-                                <p:cond delay="0"/>
-                              </p:stCondLst>
-                            </p:cTn>
-                            <p:tgtEl>
-                              <p:spTgt spid="106"/>
-                            </p:tgtEl>
-                            <p:attrNameLst>
-                              <p:attrName>style.visibility</p:attrName>
-                            </p:attrNameLst>
-                          </p:cBhvr>
-                          <p:to>
-                            <p:strVal val="visible"/>
-                          </p:to>
-                        </p:set>
-                        <p:animEffect transition="in" filter="fade">
-                          <p:cBhvr>
-                            <p:cTn id="100" dur="500"/>
-                            <p:tgtEl>
-                              <p:spTgt spid="106"/>
-                            </p:tgtEl>
-                          </p:cBhvr>
-                        </p:animEffect>
-                      </p:childTnLst>
-                    </p:cTn>
-                  </p:par>
-                  <p:par>
-                    <p:cTn id="5" presetID="10" presetClass="entr" presetSubtype="0" fill="hold" nodeType="afterPrev">
-                      <p:stCondLst>
-                        <p:cond delay="300"/>
-                      </p:stCondLst>
-                      <p:childTnLst>
-                        <p:set>
-                          <p:cBhvr>
-                            <p:cTn id="6" dur="1" fill="hold">
-                              <p:stCondLst>
-                                <p:cond delay="0"/>
-                              </p:stCondLst>
-                            </p:cTn>
-                            <p:tgtEl>
-                              <p:spTgt spid="107"/>
-                            </p:tgtEl>
-                            <p:attrNameLst>
-                              <p:attrName>style.visibility</p:attrName>
-                            </p:attrNameLst>
-                          </p:cBhvr>
-                          <p:to>
-                            <p:strVal val="visible"/>
-                          </p:to>
-                        </p:set>
-                        <p:animEffect transition="in" filter="fade">
-                          <p:cBhvr>
-                            <p:cTn id="101" dur="500"/>
-                            <p:tgtEl>
-                              <p:spTgt spid="107"/>
-                            </p:tgtEl>
-                          </p:cBhvr>
-                        </p:animEffect>
-                      </p:childTnLst>
-                    </p:cTn>
-                  </p:par>
-                  <p:par>
-                    <p:cTn id="7" presetID="10" presetClass="entr" presetSubtype="0" fill="hold" nodeType="afterPrev">
-                      <p:stCondLst>
-                        <p:cond delay="600"/>
-                      </p:stCondLst>
-                      <p:childTnLst>
-                        <p:set>
-                          <p:cBhvr>
-                            <p:cTn id="8" dur="1" fill="hold">
-                              <p:stCondLst>
-                                <p:cond delay="0"/>
-                              </p:stCondLst>
-                            </p:cTn>
-                            <p:tgtEl>
-                              <p:spTgt spid="108"/>
-                            </p:tgtEl>
-                            <p:attrNameLst>
-                              <p:attrName>style.visibility</p:attrName>
-                            </p:attrNameLst>
-                          </p:cBhvr>
-                          <p:to>
-                            <p:strVal val="visible"/>
-                          </p:to>
-                        </p:set>
-                        <p:animEffect transition="in" filter="fade">
-                          <p:cBhvr>
-                            <p:cTn id="102" dur="500"/>
-                            <p:tgtEl>
-                              <p:spTgt spid="108"/>
-                            </p:tgtEl>
-                          </p:cBhvr>
-                        </p:animEffect>
-                      </p:childTnLst>
-                    </p:cTn>
-                  </p:par>
-                  <p:par>
-                    <p:cTn id="9" presetID="10" presetClass="entr" presetSubtype="0" fill="hold" nodeType="afterPrev">
-                      <p:stCondLst>
-                        <p:cond delay="900"/>
-                      </p:stCondLst>
-                      <p:childTnLst>
-                        <p:set>
-                          <p:cBhvr>
-                            <p:cTn id="10" dur="1" fill="hold">
-                              <p:stCondLst>
-                                <p:cond delay="0"/>
-                              </p:stCondLst>
-                            </p:cTn>
-                            <p:tgtEl>
-                              <p:spTgt spid="109"/>
-                            </p:tgtEl>
-                            <p:attrNameLst>
-                              <p:attrName>style.visibility</p:attrName>
-                            </p:attrNameLst>
-                          </p:cBhvr>
-                          <p:to>
-                            <p:strVal val="visible"/>
-                          </p:to>
-                        </p:set>
-                        <p:animEffect transition="in" filter="fade">
-                          <p:cBhvr>
-                            <p:cTn id="103" dur="500"/>
-                            <p:tgtEl>
-                              <p:spTgt spid="109"/>
-                            </p:tgtEl>
-                          </p:cBhvr>
-                        </p:animEffect>
-                      </p:childTnLst>
-                    </p:cTn>
-                  </p:par>
-                  <p:par>
-                    <p:cTn id="11" presetID="10" presetClass="entr" presetSubtype="0" fill="hold" nodeType="afterPrev">
-                      <p:stCondLst>
-                        <p:cond delay="1200"/>
-                      </p:stCondLst>
-                      <p:childTnLst>
-                        <p:set>
-                          <p:cBhvr>
-                            <p:cTn id="12" dur="1" fill="hold">
-                              <p:stCondLst>
-                                <p:cond delay="0"/>
-                              </p:stCondLst>
-                            </p:cTn>
-                            <p:tgtEl>
-                              <p:spTgt spid="110"/>
-                            </p:tgtEl>
-                            <p:attrNameLst>
-                              <p:attrName>style.visibility</p:attrName>
-                            </p:attrNameLst>
-                          </p:cBhvr>
-                          <p:to>
-                            <p:strVal val="visible"/>
-                          </p:to>
-                        </p:set>
-                        <p:animEffect transition="in" filter="fade">
-                          <p:cBhvr>
-                            <p:cTn id="104" dur="500"/>
-                            <p:tgtEl>
-                              <p:spTgt spid="110"/>
-                            </p:tgtEl>
-                          </p:cBhvr>
-                        </p:animEffect>
-                      </p:childTnLst>
-                    </p:cTn>
-                  </p:par>
-                </p:childTnLst>
-              </p:cTn>
-              <p:prevCondLst>
-                <p:cond evt="onPrev" delay="0">
-                  <p:tgtEl>
-                    <p:sldTgt/>
-                  </p:tgtEl>
-                </p:cond>
-              </p:prevCondLst>
-              <p:nextCondLst>
-                <p:cond evt="onNext" delay="0">
-                  <p:tgtEl>
-                    <p:sldTgt/>
-                  </p:tgtEl>
-                </p:cond>
-              </p:nextCondLst>
-            </p:seq>
-          </p:childTnLst>
-        </p:cTn>
-      </p:par>
-    </p:tnLst>
-  </p:timing>
 </p:sld>
 </file>
 
@@ -38103,246 +35678,6 @@
   <p:transition spd="med" advClick="1">
     <p:wipe dir="l"/>
   </p:transition>
-  <p:timing>
-    <p:tnLst>
-      <p:par>
-        <p:cTn id="1" dur="indefinite" restart="never" nodeType="tmRoot">
-          <p:childTnLst>
-            <p:seq concurrent="1" nextAc="seek">
-              <p:cTn id="2" dur="indefinite" nodeType="mainSeq">
-                <p:childTnLst>
-                  <p:par>
-                    <p:cTn id="3" presetID="10" presetClass="entr" presetSubtype="0" fill="hold" nodeType="afterPrev">
-                      <p:stCondLst>
-                        <p:cond delay="0"/>
-                      </p:stCondLst>
-                      <p:childTnLst>
-                        <p:set>
-                          <p:cBhvr>
-                            <p:cTn id="4" dur="1" fill="hold">
-                              <p:stCondLst>
-                                <p:cond delay="0"/>
-                              </p:stCondLst>
-                            </p:cTn>
-                            <p:tgtEl>
-                              <p:spTgt spid="429"/>
-                            </p:tgtEl>
-                            <p:attrNameLst>
-                              <p:attrName>style.visibility</p:attrName>
-                            </p:attrNameLst>
-                          </p:cBhvr>
-                          <p:to>
-                            <p:strVal val="visible"/>
-                          </p:to>
-                        </p:set>
-                        <p:animEffect transition="in" filter="fade">
-                          <p:cBhvr>
-                            <p:cTn id="100" dur="500"/>
-                            <p:tgtEl>
-                              <p:spTgt spid="429"/>
-                            </p:tgtEl>
-                          </p:cBhvr>
-                        </p:animEffect>
-                      </p:childTnLst>
-                    </p:cTn>
-                  </p:par>
-                  <p:par>
-                    <p:cTn id="5" presetID="10" presetClass="entr" presetSubtype="0" fill="hold" nodeType="afterPrev">
-                      <p:stCondLst>
-                        <p:cond delay="300"/>
-                      </p:stCondLst>
-                      <p:childTnLst>
-                        <p:set>
-                          <p:cBhvr>
-                            <p:cTn id="6" dur="1" fill="hold">
-                              <p:stCondLst>
-                                <p:cond delay="0"/>
-                              </p:stCondLst>
-                            </p:cTn>
-                            <p:tgtEl>
-                              <p:spTgt spid="430"/>
-                            </p:tgtEl>
-                            <p:attrNameLst>
-                              <p:attrName>style.visibility</p:attrName>
-                            </p:attrNameLst>
-                          </p:cBhvr>
-                          <p:to>
-                            <p:strVal val="visible"/>
-                          </p:to>
-                        </p:set>
-                        <p:animEffect transition="in" filter="fade">
-                          <p:cBhvr>
-                            <p:cTn id="101" dur="500"/>
-                            <p:tgtEl>
-                              <p:spTgt spid="430"/>
-                            </p:tgtEl>
-                          </p:cBhvr>
-                        </p:animEffect>
-                      </p:childTnLst>
-                    </p:cTn>
-                  </p:par>
-                  <p:par>
-                    <p:cTn id="7" presetID="10" presetClass="entr" presetSubtype="0" fill="hold" nodeType="afterPrev">
-                      <p:stCondLst>
-                        <p:cond delay="600"/>
-                      </p:stCondLst>
-                      <p:childTnLst>
-                        <p:set>
-                          <p:cBhvr>
-                            <p:cTn id="8" dur="1" fill="hold">
-                              <p:stCondLst>
-                                <p:cond delay="0"/>
-                              </p:stCondLst>
-                            </p:cTn>
-                            <p:tgtEl>
-                              <p:spTgt spid="431"/>
-                            </p:tgtEl>
-                            <p:attrNameLst>
-                              <p:attrName>style.visibility</p:attrName>
-                            </p:attrNameLst>
-                          </p:cBhvr>
-                          <p:to>
-                            <p:strVal val="visible"/>
-                          </p:to>
-                        </p:set>
-                        <p:animEffect transition="in" filter="fade">
-                          <p:cBhvr>
-                            <p:cTn id="102" dur="500"/>
-                            <p:tgtEl>
-                              <p:spTgt spid="431"/>
-                            </p:tgtEl>
-                          </p:cBhvr>
-                        </p:animEffect>
-                      </p:childTnLst>
-                    </p:cTn>
-                  </p:par>
-                  <p:par>
-                    <p:cTn id="9" presetID="10" presetClass="entr" presetSubtype="0" fill="hold" nodeType="afterPrev">
-                      <p:stCondLst>
-                        <p:cond delay="900"/>
-                      </p:stCondLst>
-                      <p:childTnLst>
-                        <p:set>
-                          <p:cBhvr>
-                            <p:cTn id="10" dur="1" fill="hold">
-                              <p:stCondLst>
-                                <p:cond delay="0"/>
-                              </p:stCondLst>
-                            </p:cTn>
-                            <p:tgtEl>
-                              <p:spTgt spid="432"/>
-                            </p:tgtEl>
-                            <p:attrNameLst>
-                              <p:attrName>style.visibility</p:attrName>
-                            </p:attrNameLst>
-                          </p:cBhvr>
-                          <p:to>
-                            <p:strVal val="visible"/>
-                          </p:to>
-                        </p:set>
-                        <p:animEffect transition="in" filter="fade">
-                          <p:cBhvr>
-                            <p:cTn id="103" dur="500"/>
-                            <p:tgtEl>
-                              <p:spTgt spid="432"/>
-                            </p:tgtEl>
-                          </p:cBhvr>
-                        </p:animEffect>
-                      </p:childTnLst>
-                    </p:cTn>
-                  </p:par>
-                  <p:par>
-                    <p:cTn id="11" presetID="10" presetClass="entr" presetSubtype="0" fill="hold" nodeType="afterPrev">
-                      <p:stCondLst>
-                        <p:cond delay="1200"/>
-                      </p:stCondLst>
-                      <p:childTnLst>
-                        <p:set>
-                          <p:cBhvr>
-                            <p:cTn id="12" dur="1" fill="hold">
-                              <p:stCondLst>
-                                <p:cond delay="0"/>
-                              </p:stCondLst>
-                            </p:cTn>
-                            <p:tgtEl>
-                              <p:spTgt spid="433"/>
-                            </p:tgtEl>
-                            <p:attrNameLst>
-                              <p:attrName>style.visibility</p:attrName>
-                            </p:attrNameLst>
-                          </p:cBhvr>
-                          <p:to>
-                            <p:strVal val="visible"/>
-                          </p:to>
-                        </p:set>
-                        <p:animEffect transition="in" filter="fade">
-                          <p:cBhvr>
-                            <p:cTn id="104" dur="500"/>
-                            <p:tgtEl>
-                              <p:spTgt spid="433"/>
-                            </p:tgtEl>
-                          </p:cBhvr>
-                        </p:animEffect>
-                      </p:childTnLst>
-                    </p:cTn>
-                  </p:par>
-                  <p:par>
-                    <p:cTn id="13" presetID="10" presetClass="entr" presetSubtype="0" fill="hold" nodeType="afterPrev">
-                      <p:stCondLst>
-                        <p:cond delay="1500"/>
-                      </p:stCondLst>
-                      <p:childTnLst>
-                        <p:set>
-                          <p:cBhvr>
-                            <p:cTn id="14" dur="1" fill="hold">
-                              <p:stCondLst>
-                                <p:cond delay="0"/>
-                              </p:stCondLst>
-                            </p:cTn>
-                            <p:tgtEl>
-                              <p:spTgt spid="434"/>
-                            </p:tgtEl>
-                            <p:attrNameLst>
-                              <p:attrName>style.visibility</p:attrName>
-                            </p:attrNameLst>
-                          </p:cBhvr>
-                          <p:to>
-                            <p:strVal val="visible"/>
-                          </p:to>
-                        </p:set>
-                        <p:animEffect transition="in" filter="fade">
-                          <p:cBhvr>
-                            <p:cTn id="105" dur="500"/>
-                            <p:tgtEl>
-                              <p:spTgt spid="434"/>
-                            </p:tgtEl>
-                          </p:cBhvr>
-                        </p:animEffect>
-                      </p:childTnLst>
-                    </p:cTn>
-                  </p:par>
-                </p:childTnLst>
-              </p:cTn>
-              <p:prevCondLst>
-                <p:cond evt="onPrev" delay="0">
-                  <p:tgtEl>
-                    <p:sldTgt/>
-                  </p:tgtEl>
-                </p:cond>
-              </p:prevCondLst>
-              <p:nextCondLst>
-                <p:cond evt="onNext" delay="0">
-                  <p:tgtEl>
-                    <p:sldTgt/>
-                  </p:tgtEl>
-                </p:cond>
-              </p:nextCondLst>
-            </p:seq>
-          </p:childTnLst>
-        </p:cTn>
-      </p:par>
-    </p:tnLst>
-  </p:timing>
 </p:sld>
 </file>
 
@@ -39306,246 +36641,6 @@
   <p:transition spd="med" advClick="1">
     <p:wipe dir="l"/>
   </p:transition>
-  <p:timing>
-    <p:tnLst>
-      <p:par>
-        <p:cTn id="1" dur="indefinite" restart="never" nodeType="tmRoot">
-          <p:childTnLst>
-            <p:seq concurrent="1" nextAc="seek">
-              <p:cTn id="2" dur="indefinite" nodeType="mainSeq">
-                <p:childTnLst>
-                  <p:par>
-                    <p:cTn id="3" presetID="10" presetClass="entr" presetSubtype="0" fill="hold" nodeType="afterPrev">
-                      <p:stCondLst>
-                        <p:cond delay="0"/>
-                      </p:stCondLst>
-                      <p:childTnLst>
-                        <p:set>
-                          <p:cBhvr>
-                            <p:cTn id="4" dur="1" fill="hold">
-                              <p:stCondLst>
-                                <p:cond delay="0"/>
-                              </p:stCondLst>
-                            </p:cTn>
-                            <p:tgtEl>
-                              <p:spTgt spid="442"/>
-                            </p:tgtEl>
-                            <p:attrNameLst>
-                              <p:attrName>style.visibility</p:attrName>
-                            </p:attrNameLst>
-                          </p:cBhvr>
-                          <p:to>
-                            <p:strVal val="visible"/>
-                          </p:to>
-                        </p:set>
-                        <p:animEffect transition="in" filter="fade">
-                          <p:cBhvr>
-                            <p:cTn id="100" dur="500"/>
-                            <p:tgtEl>
-                              <p:spTgt spid="442"/>
-                            </p:tgtEl>
-                          </p:cBhvr>
-                        </p:animEffect>
-                      </p:childTnLst>
-                    </p:cTn>
-                  </p:par>
-                  <p:par>
-                    <p:cTn id="5" presetID="10" presetClass="entr" presetSubtype="0" fill="hold" nodeType="afterPrev">
-                      <p:stCondLst>
-                        <p:cond delay="300"/>
-                      </p:stCondLst>
-                      <p:childTnLst>
-                        <p:set>
-                          <p:cBhvr>
-                            <p:cTn id="6" dur="1" fill="hold">
-                              <p:stCondLst>
-                                <p:cond delay="0"/>
-                              </p:stCondLst>
-                            </p:cTn>
-                            <p:tgtEl>
-                              <p:spTgt spid="443"/>
-                            </p:tgtEl>
-                            <p:attrNameLst>
-                              <p:attrName>style.visibility</p:attrName>
-                            </p:attrNameLst>
-                          </p:cBhvr>
-                          <p:to>
-                            <p:strVal val="visible"/>
-                          </p:to>
-                        </p:set>
-                        <p:animEffect transition="in" filter="fade">
-                          <p:cBhvr>
-                            <p:cTn id="101" dur="500"/>
-                            <p:tgtEl>
-                              <p:spTgt spid="443"/>
-                            </p:tgtEl>
-                          </p:cBhvr>
-                        </p:animEffect>
-                      </p:childTnLst>
-                    </p:cTn>
-                  </p:par>
-                  <p:par>
-                    <p:cTn id="7" presetID="10" presetClass="entr" presetSubtype="0" fill="hold" nodeType="afterPrev">
-                      <p:stCondLst>
-                        <p:cond delay="600"/>
-                      </p:stCondLst>
-                      <p:childTnLst>
-                        <p:set>
-                          <p:cBhvr>
-                            <p:cTn id="8" dur="1" fill="hold">
-                              <p:stCondLst>
-                                <p:cond delay="0"/>
-                              </p:stCondLst>
-                            </p:cTn>
-                            <p:tgtEl>
-                              <p:spTgt spid="444"/>
-                            </p:tgtEl>
-                            <p:attrNameLst>
-                              <p:attrName>style.visibility</p:attrName>
-                            </p:attrNameLst>
-                          </p:cBhvr>
-                          <p:to>
-                            <p:strVal val="visible"/>
-                          </p:to>
-                        </p:set>
-                        <p:animEffect transition="in" filter="fade">
-                          <p:cBhvr>
-                            <p:cTn id="102" dur="500"/>
-                            <p:tgtEl>
-                              <p:spTgt spid="444"/>
-                            </p:tgtEl>
-                          </p:cBhvr>
-                        </p:animEffect>
-                      </p:childTnLst>
-                    </p:cTn>
-                  </p:par>
-                  <p:par>
-                    <p:cTn id="9" presetID="10" presetClass="entr" presetSubtype="0" fill="hold" nodeType="afterPrev">
-                      <p:stCondLst>
-                        <p:cond delay="900"/>
-                      </p:stCondLst>
-                      <p:childTnLst>
-                        <p:set>
-                          <p:cBhvr>
-                            <p:cTn id="10" dur="1" fill="hold">
-                              <p:stCondLst>
-                                <p:cond delay="0"/>
-                              </p:stCondLst>
-                            </p:cTn>
-                            <p:tgtEl>
-                              <p:spTgt spid="445"/>
-                            </p:tgtEl>
-                            <p:attrNameLst>
-                              <p:attrName>style.visibility</p:attrName>
-                            </p:attrNameLst>
-                          </p:cBhvr>
-                          <p:to>
-                            <p:strVal val="visible"/>
-                          </p:to>
-                        </p:set>
-                        <p:animEffect transition="in" filter="fade">
-                          <p:cBhvr>
-                            <p:cTn id="103" dur="500"/>
-                            <p:tgtEl>
-                              <p:spTgt spid="445"/>
-                            </p:tgtEl>
-                          </p:cBhvr>
-                        </p:animEffect>
-                      </p:childTnLst>
-                    </p:cTn>
-                  </p:par>
-                  <p:par>
-                    <p:cTn id="11" presetID="10" presetClass="entr" presetSubtype="0" fill="hold" nodeType="afterPrev">
-                      <p:stCondLst>
-                        <p:cond delay="1200"/>
-                      </p:stCondLst>
-                      <p:childTnLst>
-                        <p:set>
-                          <p:cBhvr>
-                            <p:cTn id="12" dur="1" fill="hold">
-                              <p:stCondLst>
-                                <p:cond delay="0"/>
-                              </p:stCondLst>
-                            </p:cTn>
-                            <p:tgtEl>
-                              <p:spTgt spid="446"/>
-                            </p:tgtEl>
-                            <p:attrNameLst>
-                              <p:attrName>style.visibility</p:attrName>
-                            </p:attrNameLst>
-                          </p:cBhvr>
-                          <p:to>
-                            <p:strVal val="visible"/>
-                          </p:to>
-                        </p:set>
-                        <p:animEffect transition="in" filter="fade">
-                          <p:cBhvr>
-                            <p:cTn id="104" dur="500"/>
-                            <p:tgtEl>
-                              <p:spTgt spid="446"/>
-                            </p:tgtEl>
-                          </p:cBhvr>
-                        </p:animEffect>
-                      </p:childTnLst>
-                    </p:cTn>
-                  </p:par>
-                  <p:par>
-                    <p:cTn id="13" presetID="10" presetClass="entr" presetSubtype="0" fill="hold" nodeType="afterPrev">
-                      <p:stCondLst>
-                        <p:cond delay="1500"/>
-                      </p:stCondLst>
-                      <p:childTnLst>
-                        <p:set>
-                          <p:cBhvr>
-                            <p:cTn id="14" dur="1" fill="hold">
-                              <p:stCondLst>
-                                <p:cond delay="0"/>
-                              </p:stCondLst>
-                            </p:cTn>
-                            <p:tgtEl>
-                              <p:spTgt spid="447"/>
-                            </p:tgtEl>
-                            <p:attrNameLst>
-                              <p:attrName>style.visibility</p:attrName>
-                            </p:attrNameLst>
-                          </p:cBhvr>
-                          <p:to>
-                            <p:strVal val="visible"/>
-                          </p:to>
-                        </p:set>
-                        <p:animEffect transition="in" filter="fade">
-                          <p:cBhvr>
-                            <p:cTn id="105" dur="500"/>
-                            <p:tgtEl>
-                              <p:spTgt spid="447"/>
-                            </p:tgtEl>
-                          </p:cBhvr>
-                        </p:animEffect>
-                      </p:childTnLst>
-                    </p:cTn>
-                  </p:par>
-                </p:childTnLst>
-              </p:cTn>
-              <p:prevCondLst>
-                <p:cond evt="onPrev" delay="0">
-                  <p:tgtEl>
-                    <p:sldTgt/>
-                  </p:tgtEl>
-                </p:cond>
-              </p:prevCondLst>
-              <p:nextCondLst>
-                <p:cond evt="onNext" delay="0">
-                  <p:tgtEl>
-                    <p:sldTgt/>
-                  </p:tgtEl>
-                </p:cond>
-              </p:nextCondLst>
-            </p:seq>
-          </p:childTnLst>
-        </p:cTn>
-      </p:par>
-    </p:tnLst>
-  </p:timing>
 </p:sld>
 </file>
 
@@ -40100,246 +37195,6 @@
   <p:transition spd="med" advClick="1">
     <p:wipe dir="l"/>
   </p:transition>
-  <p:timing>
-    <p:tnLst>
-      <p:par>
-        <p:cTn id="1" dur="indefinite" restart="never" nodeType="tmRoot">
-          <p:childTnLst>
-            <p:seq concurrent="1" nextAc="seek">
-              <p:cTn id="2" dur="indefinite" nodeType="mainSeq">
-                <p:childTnLst>
-                  <p:par>
-                    <p:cTn id="3" presetID="10" presetClass="entr" presetSubtype="0" fill="hold" nodeType="afterPrev">
-                      <p:stCondLst>
-                        <p:cond delay="0"/>
-                      </p:stCondLst>
-                      <p:childTnLst>
-                        <p:set>
-                          <p:cBhvr>
-                            <p:cTn id="4" dur="1" fill="hold">
-                              <p:stCondLst>
-                                <p:cond delay="0"/>
-                              </p:stCondLst>
-                            </p:cTn>
-                            <p:tgtEl>
-                              <p:spTgt spid="455"/>
-                            </p:tgtEl>
-                            <p:attrNameLst>
-                              <p:attrName>style.visibility</p:attrName>
-                            </p:attrNameLst>
-                          </p:cBhvr>
-                          <p:to>
-                            <p:strVal val="visible"/>
-                          </p:to>
-                        </p:set>
-                        <p:animEffect transition="in" filter="fade">
-                          <p:cBhvr>
-                            <p:cTn id="100" dur="500"/>
-                            <p:tgtEl>
-                              <p:spTgt spid="455"/>
-                            </p:tgtEl>
-                          </p:cBhvr>
-                        </p:animEffect>
-                      </p:childTnLst>
-                    </p:cTn>
-                  </p:par>
-                  <p:par>
-                    <p:cTn id="5" presetID="10" presetClass="entr" presetSubtype="0" fill="hold" nodeType="afterPrev">
-                      <p:stCondLst>
-                        <p:cond delay="300"/>
-                      </p:stCondLst>
-                      <p:childTnLst>
-                        <p:set>
-                          <p:cBhvr>
-                            <p:cTn id="6" dur="1" fill="hold">
-                              <p:stCondLst>
-                                <p:cond delay="0"/>
-                              </p:stCondLst>
-                            </p:cTn>
-                            <p:tgtEl>
-                              <p:spTgt spid="456"/>
-                            </p:tgtEl>
-                            <p:attrNameLst>
-                              <p:attrName>style.visibility</p:attrName>
-                            </p:attrNameLst>
-                          </p:cBhvr>
-                          <p:to>
-                            <p:strVal val="visible"/>
-                          </p:to>
-                        </p:set>
-                        <p:animEffect transition="in" filter="fade">
-                          <p:cBhvr>
-                            <p:cTn id="101" dur="500"/>
-                            <p:tgtEl>
-                              <p:spTgt spid="456"/>
-                            </p:tgtEl>
-                          </p:cBhvr>
-                        </p:animEffect>
-                      </p:childTnLst>
-                    </p:cTn>
-                  </p:par>
-                  <p:par>
-                    <p:cTn id="7" presetID="10" presetClass="entr" presetSubtype="0" fill="hold" nodeType="afterPrev">
-                      <p:stCondLst>
-                        <p:cond delay="600"/>
-                      </p:stCondLst>
-                      <p:childTnLst>
-                        <p:set>
-                          <p:cBhvr>
-                            <p:cTn id="8" dur="1" fill="hold">
-                              <p:stCondLst>
-                                <p:cond delay="0"/>
-                              </p:stCondLst>
-                            </p:cTn>
-                            <p:tgtEl>
-                              <p:spTgt spid="457"/>
-                            </p:tgtEl>
-                            <p:attrNameLst>
-                              <p:attrName>style.visibility</p:attrName>
-                            </p:attrNameLst>
-                          </p:cBhvr>
-                          <p:to>
-                            <p:strVal val="visible"/>
-                          </p:to>
-                        </p:set>
-                        <p:animEffect transition="in" filter="fade">
-                          <p:cBhvr>
-                            <p:cTn id="102" dur="500"/>
-                            <p:tgtEl>
-                              <p:spTgt spid="457"/>
-                            </p:tgtEl>
-                          </p:cBhvr>
-                        </p:animEffect>
-                      </p:childTnLst>
-                    </p:cTn>
-                  </p:par>
-                  <p:par>
-                    <p:cTn id="9" presetID="10" presetClass="entr" presetSubtype="0" fill="hold" nodeType="afterPrev">
-                      <p:stCondLst>
-                        <p:cond delay="900"/>
-                      </p:stCondLst>
-                      <p:childTnLst>
-                        <p:set>
-                          <p:cBhvr>
-                            <p:cTn id="10" dur="1" fill="hold">
-                              <p:stCondLst>
-                                <p:cond delay="0"/>
-                              </p:stCondLst>
-                            </p:cTn>
-                            <p:tgtEl>
-                              <p:spTgt spid="458"/>
-                            </p:tgtEl>
-                            <p:attrNameLst>
-                              <p:attrName>style.visibility</p:attrName>
-                            </p:attrNameLst>
-                          </p:cBhvr>
-                          <p:to>
-                            <p:strVal val="visible"/>
-                          </p:to>
-                        </p:set>
-                        <p:animEffect transition="in" filter="fade">
-                          <p:cBhvr>
-                            <p:cTn id="103" dur="500"/>
-                            <p:tgtEl>
-                              <p:spTgt spid="458"/>
-                            </p:tgtEl>
-                          </p:cBhvr>
-                        </p:animEffect>
-                      </p:childTnLst>
-                    </p:cTn>
-                  </p:par>
-                  <p:par>
-                    <p:cTn id="11" presetID="10" presetClass="entr" presetSubtype="0" fill="hold" nodeType="afterPrev">
-                      <p:stCondLst>
-                        <p:cond delay="1200"/>
-                      </p:stCondLst>
-                      <p:childTnLst>
-                        <p:set>
-                          <p:cBhvr>
-                            <p:cTn id="12" dur="1" fill="hold">
-                              <p:stCondLst>
-                                <p:cond delay="0"/>
-                              </p:stCondLst>
-                            </p:cTn>
-                            <p:tgtEl>
-                              <p:spTgt spid="459"/>
-                            </p:tgtEl>
-                            <p:attrNameLst>
-                              <p:attrName>style.visibility</p:attrName>
-                            </p:attrNameLst>
-                          </p:cBhvr>
-                          <p:to>
-                            <p:strVal val="visible"/>
-                          </p:to>
-                        </p:set>
-                        <p:animEffect transition="in" filter="fade">
-                          <p:cBhvr>
-                            <p:cTn id="104" dur="500"/>
-                            <p:tgtEl>
-                              <p:spTgt spid="459"/>
-                            </p:tgtEl>
-                          </p:cBhvr>
-                        </p:animEffect>
-                      </p:childTnLst>
-                    </p:cTn>
-                  </p:par>
-                  <p:par>
-                    <p:cTn id="13" presetID="10" presetClass="entr" presetSubtype="0" fill="hold" nodeType="afterPrev">
-                      <p:stCondLst>
-                        <p:cond delay="1500"/>
-                      </p:stCondLst>
-                      <p:childTnLst>
-                        <p:set>
-                          <p:cBhvr>
-                            <p:cTn id="14" dur="1" fill="hold">
-                              <p:stCondLst>
-                                <p:cond delay="0"/>
-                              </p:stCondLst>
-                            </p:cTn>
-                            <p:tgtEl>
-                              <p:spTgt spid="460"/>
-                            </p:tgtEl>
-                            <p:attrNameLst>
-                              <p:attrName>style.visibility</p:attrName>
-                            </p:attrNameLst>
-                          </p:cBhvr>
-                          <p:to>
-                            <p:strVal val="visible"/>
-                          </p:to>
-                        </p:set>
-                        <p:animEffect transition="in" filter="fade">
-                          <p:cBhvr>
-                            <p:cTn id="105" dur="500"/>
-                            <p:tgtEl>
-                              <p:spTgt spid="460"/>
-                            </p:tgtEl>
-                          </p:cBhvr>
-                        </p:animEffect>
-                      </p:childTnLst>
-                    </p:cTn>
-                  </p:par>
-                </p:childTnLst>
-              </p:cTn>
-              <p:prevCondLst>
-                <p:cond evt="onPrev" delay="0">
-                  <p:tgtEl>
-                    <p:sldTgt/>
-                  </p:tgtEl>
-                </p:cond>
-              </p:prevCondLst>
-              <p:nextCondLst>
-                <p:cond evt="onNext" delay="0">
-                  <p:tgtEl>
-                    <p:sldTgt/>
-                  </p:tgtEl>
-                </p:cond>
-              </p:nextCondLst>
-            </p:seq>
-          </p:childTnLst>
-        </p:cTn>
-      </p:par>
-    </p:tnLst>
-  </p:timing>
 </p:sld>
 </file>
 
@@ -40535,176 +37390,6 @@
   <p:transition spd="med" advClick="1">
     <p:fade/>
   </p:transition>
-  <p:timing>
-    <p:tnLst>
-      <p:par>
-        <p:cTn id="1" dur="indefinite" restart="never" nodeType="tmRoot">
-          <p:childTnLst>
-            <p:seq concurrent="1" nextAc="seek">
-              <p:cTn id="2" dur="indefinite" nodeType="mainSeq">
-                <p:childTnLst>
-                  <p:par>
-                    <p:cTn id="3" presetID="10" presetClass="entr" presetSubtype="0" fill="hold" nodeType="afterPrev">
-                      <p:stCondLst>
-                        <p:cond delay="0"/>
-                      </p:stCondLst>
-                      <p:childTnLst>
-                        <p:set>
-                          <p:cBhvr>
-                            <p:cTn id="4" dur="1" fill="hold">
-                              <p:stCondLst>
-                                <p:cond delay="0"/>
-                              </p:stCondLst>
-                            </p:cTn>
-                            <p:tgtEl>
-                              <p:spTgt spid="468"/>
-                            </p:tgtEl>
-                            <p:attrNameLst>
-                              <p:attrName>style.visibility</p:attrName>
-                            </p:attrNameLst>
-                          </p:cBhvr>
-                          <p:to>
-                            <p:strVal val="visible"/>
-                          </p:to>
-                        </p:set>
-                        <p:animEffect transition="in" filter="fade">
-                          <p:cBhvr>
-                            <p:cTn id="100" dur="500"/>
-                            <p:tgtEl>
-                              <p:spTgt spid="468"/>
-                            </p:tgtEl>
-                          </p:cBhvr>
-                        </p:animEffect>
-                      </p:childTnLst>
-                    </p:cTn>
-                  </p:par>
-                  <p:par>
-                    <p:cTn id="5" presetID="10" presetClass="entr" presetSubtype="0" fill="hold" nodeType="afterPrev">
-                      <p:stCondLst>
-                        <p:cond delay="300"/>
-                      </p:stCondLst>
-                      <p:childTnLst>
-                        <p:set>
-                          <p:cBhvr>
-                            <p:cTn id="6" dur="1" fill="hold">
-                              <p:stCondLst>
-                                <p:cond delay="0"/>
-                              </p:stCondLst>
-                            </p:cTn>
-                            <p:tgtEl>
-                              <p:spTgt spid="469"/>
-                            </p:tgtEl>
-                            <p:attrNameLst>
-                              <p:attrName>style.visibility</p:attrName>
-                            </p:attrNameLst>
-                          </p:cBhvr>
-                          <p:to>
-                            <p:strVal val="visible"/>
-                          </p:to>
-                        </p:set>
-                        <p:animEffect transition="in" filter="fade">
-                          <p:cBhvr>
-                            <p:cTn id="101" dur="500"/>
-                            <p:tgtEl>
-                              <p:spTgt spid="469"/>
-                            </p:tgtEl>
-                          </p:cBhvr>
-                        </p:animEffect>
-                      </p:childTnLst>
-                    </p:cTn>
-                  </p:par>
-                  <p:par>
-                    <p:cTn id="7" presetID="10" presetClass="entr" presetSubtype="0" fill="hold" nodeType="afterPrev">
-                      <p:stCondLst>
-                        <p:cond delay="600"/>
-                      </p:stCondLst>
-                      <p:childTnLst>
-                        <p:set>
-                          <p:cBhvr>
-                            <p:cTn id="8" dur="1" fill="hold">
-                              <p:stCondLst>
-                                <p:cond delay="0"/>
-                              </p:stCondLst>
-                            </p:cTn>
-                            <p:tgtEl>
-                              <p:spTgt spid="470"/>
-                            </p:tgtEl>
-                            <p:attrNameLst>
-                              <p:attrName>style.visibility</p:attrName>
-                            </p:attrNameLst>
-                          </p:cBhvr>
-                          <p:to>
-                            <p:strVal val="visible"/>
-                          </p:to>
-                        </p:set>
-                        <p:animEffect transition="in" filter="fade">
-                          <p:cBhvr>
-                            <p:cTn id="102" dur="500"/>
-                            <p:tgtEl>
-                              <p:spTgt spid="470"/>
-                            </p:tgtEl>
-                          </p:cBhvr>
-                        </p:animEffect>
-                      </p:childTnLst>
-                    </p:cTn>
-                  </p:par>
-                  <p:par>
-                    <p:cTn id="9" presetID="10" presetClass="entr" presetSubtype="0" fill="hold" nodeType="afterPrev">
-                      <p:stCondLst>
-                        <p:cond delay="900"/>
-                      </p:stCondLst>
-                      <p:childTnLst>
-                        <p:set>
-                          <p:cBhvr>
-                            <p:cTn id="10" dur="1" fill="hold">
-                              <p:stCondLst>
-                                <p:cond delay="0"/>
-                              </p:stCondLst>
-                            </p:cTn>
-                            <p:tgtEl>
-                              <p:spTgt spid="471"/>
-                            </p:tgtEl>
-                            <p:attrNameLst>
-                              <p:attrName>style.visibility</p:attrName>
-                            </p:attrNameLst>
-                          </p:cBhvr>
-                          <p:to>
-                            <p:strVal val="visible"/>
-                          </p:to>
-                        </p:set>
-                        <p:animEffect transition="in" filter="fade">
-                          <p:cBhvr>
-                            <p:cTn id="103" dur="500"/>
-                            <p:tgtEl>
-                              <p:spTgt spid="471"/>
-                            </p:tgtEl>
-                          </p:cBhvr>
-                        </p:animEffect>
-                      </p:childTnLst>
-                    </p:cTn>
-                  </p:par>
-                </p:childTnLst>
-              </p:cTn>
-              <p:prevCondLst>
-                <p:cond evt="onPrev" delay="0">
-                  <p:tgtEl>
-                    <p:sldTgt/>
-                  </p:tgtEl>
-                </p:cond>
-              </p:prevCondLst>
-              <p:nextCondLst>
-                <p:cond evt="onNext" delay="0">
-                  <p:tgtEl>
-                    <p:sldTgt/>
-                  </p:tgtEl>
-                </p:cond>
-              </p:nextCondLst>
-            </p:seq>
-          </p:childTnLst>
-        </p:cTn>
-      </p:par>
-    </p:tnLst>
-  </p:timing>
 </p:sld>
 </file>
 
@@ -40985,211 +37670,6 @@
   <p:transition spd="med" advClick="1">
     <p:fade/>
   </p:transition>
-  <p:timing>
-    <p:tnLst>
-      <p:par>
-        <p:cTn id="1" dur="indefinite" restart="never" nodeType="tmRoot">
-          <p:childTnLst>
-            <p:seq concurrent="1" nextAc="seek">
-              <p:cTn id="2" dur="indefinite" nodeType="mainSeq">
-                <p:childTnLst>
-                  <p:par>
-                    <p:cTn id="3" presetID="10" presetClass="entr" presetSubtype="0" fill="hold" nodeType="afterPrev">
-                      <p:stCondLst>
-                        <p:cond delay="0"/>
-                      </p:stCondLst>
-                      <p:childTnLst>
-                        <p:set>
-                          <p:cBhvr>
-                            <p:cTn id="4" dur="1" fill="hold">
-                              <p:stCondLst>
-                                <p:cond delay="0"/>
-                              </p:stCondLst>
-                            </p:cTn>
-                            <p:tgtEl>
-                              <p:spTgt spid="115"/>
-                            </p:tgtEl>
-                            <p:attrNameLst>
-                              <p:attrName>style.visibility</p:attrName>
-                            </p:attrNameLst>
-                          </p:cBhvr>
-                          <p:to>
-                            <p:strVal val="visible"/>
-                          </p:to>
-                        </p:set>
-                        <p:animEffect transition="in" filter="fade">
-                          <p:cBhvr>
-                            <p:cTn id="100" dur="500"/>
-                            <p:tgtEl>
-                              <p:spTgt spid="115"/>
-                            </p:tgtEl>
-                          </p:cBhvr>
-                        </p:animEffect>
-                      </p:childTnLst>
-                    </p:cTn>
-                  </p:par>
-                  <p:par>
-                    <p:cTn id="5" presetID="10" presetClass="entr" presetSubtype="0" fill="hold" nodeType="afterPrev">
-                      <p:stCondLst>
-                        <p:cond delay="300"/>
-                      </p:stCondLst>
-                      <p:childTnLst>
-                        <p:set>
-                          <p:cBhvr>
-                            <p:cTn id="6" dur="1" fill="hold">
-                              <p:stCondLst>
-                                <p:cond delay="0"/>
-                              </p:stCondLst>
-                            </p:cTn>
-                            <p:tgtEl>
-                              <p:spTgt spid="116"/>
-                            </p:tgtEl>
-                            <p:attrNameLst>
-                              <p:attrName>style.visibility</p:attrName>
-                            </p:attrNameLst>
-                          </p:cBhvr>
-                          <p:to>
-                            <p:strVal val="visible"/>
-                          </p:to>
-                        </p:set>
-                        <p:animEffect transition="in" filter="fade">
-                          <p:cBhvr>
-                            <p:cTn id="101" dur="500"/>
-                            <p:tgtEl>
-                              <p:spTgt spid="116"/>
-                            </p:tgtEl>
-                          </p:cBhvr>
-                        </p:animEffect>
-                      </p:childTnLst>
-                    </p:cTn>
-                  </p:par>
-                  <p:par>
-                    <p:cTn id="7" presetID="10" presetClass="entr" presetSubtype="0" fill="hold" nodeType="afterPrev">
-                      <p:stCondLst>
-                        <p:cond delay="600"/>
-                      </p:stCondLst>
-                      <p:childTnLst>
-                        <p:set>
-                          <p:cBhvr>
-                            <p:cTn id="8" dur="1" fill="hold">
-                              <p:stCondLst>
-                                <p:cond delay="0"/>
-                              </p:stCondLst>
-                            </p:cTn>
-                            <p:tgtEl>
-                              <p:spTgt spid="117"/>
-                            </p:tgtEl>
-                            <p:attrNameLst>
-                              <p:attrName>style.visibility</p:attrName>
-                            </p:attrNameLst>
-                          </p:cBhvr>
-                          <p:to>
-                            <p:strVal val="visible"/>
-                          </p:to>
-                        </p:set>
-                        <p:animEffect transition="in" filter="fade">
-                          <p:cBhvr>
-                            <p:cTn id="102" dur="500"/>
-                            <p:tgtEl>
-                              <p:spTgt spid="117"/>
-                            </p:tgtEl>
-                          </p:cBhvr>
-                        </p:animEffect>
-                      </p:childTnLst>
-                    </p:cTn>
-                  </p:par>
-                  <p:par>
-                    <p:cTn id="9" presetID="10" presetClass="entr" presetSubtype="0" fill="hold" nodeType="afterPrev">
-                      <p:stCondLst>
-                        <p:cond delay="900"/>
-                      </p:stCondLst>
-                      <p:childTnLst>
-                        <p:set>
-                          <p:cBhvr>
-                            <p:cTn id="10" dur="1" fill="hold">
-                              <p:stCondLst>
-                                <p:cond delay="0"/>
-                              </p:stCondLst>
-                            </p:cTn>
-                            <p:tgtEl>
-                              <p:spTgt spid="118"/>
-                            </p:tgtEl>
-                            <p:attrNameLst>
-                              <p:attrName>style.visibility</p:attrName>
-                            </p:attrNameLst>
-                          </p:cBhvr>
-                          <p:to>
-                            <p:strVal val="visible"/>
-                          </p:to>
-                        </p:set>
-                        <p:animEffect transition="in" filter="fade">
-                          <p:cBhvr>
-                            <p:cTn id="103" dur="500"/>
-                            <p:tgtEl>
-                              <p:spTgt spid="118"/>
-                            </p:tgtEl>
-                          </p:cBhvr>
-                        </p:animEffect>
-                      </p:childTnLst>
-                    </p:cTn>
-                  </p:par>
-                  <p:par>
-                    <p:cTn id="11" presetID="10" presetClass="entr" presetSubtype="0" fill="hold" nodeType="afterPrev">
-                      <p:stCondLst>
-                        <p:cond delay="1200"/>
-                      </p:stCondLst>
-                      <p:childTnLst>
-                        <p:set>
-                          <p:cBhvr>
-                            <p:cTn id="12" dur="1" fill="hold">
-                              <p:stCondLst>
-                                <p:cond delay="0"/>
-                              </p:stCondLst>
-                            </p:cTn>
-                            <p:tgtEl>
-                              <p:spTgt spid="3"/>
-                            </p:tgtEl>
-                            <p:attrNameLst>
-                              <p:attrName>style.visibility</p:attrName>
-                            </p:attrNameLst>
-                          </p:cBhvr>
-                          <p:to>
-                            <p:strVal val="visible"/>
-                          </p:to>
-                        </p:set>
-                        <p:animEffect transition="in" filter="fade">
-                          <p:cBhvr>
-                            <p:cTn id="104" dur="500"/>
-                            <p:tgtEl>
-                              <p:spTgt spid="3"/>
-                            </p:tgtEl>
-                          </p:cBhvr>
-                        </p:animEffect>
-                      </p:childTnLst>
-                    </p:cTn>
-                  </p:par>
-                </p:childTnLst>
-              </p:cTn>
-              <p:prevCondLst>
-                <p:cond evt="onPrev" delay="0">
-                  <p:tgtEl>
-                    <p:sldTgt/>
-                  </p:tgtEl>
-                </p:cond>
-              </p:prevCondLst>
-              <p:nextCondLst>
-                <p:cond evt="onNext" delay="0">
-                  <p:tgtEl>
-                    <p:sldTgt/>
-                  </p:tgtEl>
-                </p:cond>
-              </p:nextCondLst>
-            </p:seq>
-          </p:childTnLst>
-        </p:cTn>
-      </p:par>
-    </p:tnLst>
-  </p:timing>
 </p:sld>
 </file>
 
@@ -43581,246 +40061,6 @@
   <p:transition spd="med" advClick="1">
     <p:push dir="l"/>
   </p:transition>
-  <p:timing>
-    <p:tnLst>
-      <p:par>
-        <p:cTn id="1" dur="indefinite" restart="never" nodeType="tmRoot">
-          <p:childTnLst>
-            <p:seq concurrent="1" nextAc="seek">
-              <p:cTn id="2" dur="indefinite" nodeType="mainSeq">
-                <p:childTnLst>
-                  <p:par>
-                    <p:cTn id="3" presetID="10" presetClass="entr" presetSubtype="0" fill="hold" nodeType="afterPrev">
-                      <p:stCondLst>
-                        <p:cond delay="0"/>
-                      </p:stCondLst>
-                      <p:childTnLst>
-                        <p:set>
-                          <p:cBhvr>
-                            <p:cTn id="4" dur="1" fill="hold">
-                              <p:stCondLst>
-                                <p:cond delay="0"/>
-                              </p:stCondLst>
-                            </p:cTn>
-                            <p:tgtEl>
-                              <p:spTgt spid="123"/>
-                            </p:tgtEl>
-                            <p:attrNameLst>
-                              <p:attrName>style.visibility</p:attrName>
-                            </p:attrNameLst>
-                          </p:cBhvr>
-                          <p:to>
-                            <p:strVal val="visible"/>
-                          </p:to>
-                        </p:set>
-                        <p:animEffect transition="in" filter="fade">
-                          <p:cBhvr>
-                            <p:cTn id="100" dur="500"/>
-                            <p:tgtEl>
-                              <p:spTgt spid="123"/>
-                            </p:tgtEl>
-                          </p:cBhvr>
-                        </p:animEffect>
-                      </p:childTnLst>
-                    </p:cTn>
-                  </p:par>
-                  <p:par>
-                    <p:cTn id="5" presetID="10" presetClass="entr" presetSubtype="0" fill="hold" nodeType="afterPrev">
-                      <p:stCondLst>
-                        <p:cond delay="300"/>
-                      </p:stCondLst>
-                      <p:childTnLst>
-                        <p:set>
-                          <p:cBhvr>
-                            <p:cTn id="6" dur="1" fill="hold">
-                              <p:stCondLst>
-                                <p:cond delay="0"/>
-                              </p:stCondLst>
-                            </p:cTn>
-                            <p:tgtEl>
-                              <p:spTgt spid="124"/>
-                            </p:tgtEl>
-                            <p:attrNameLst>
-                              <p:attrName>style.visibility</p:attrName>
-                            </p:attrNameLst>
-                          </p:cBhvr>
-                          <p:to>
-                            <p:strVal val="visible"/>
-                          </p:to>
-                        </p:set>
-                        <p:animEffect transition="in" filter="fade">
-                          <p:cBhvr>
-                            <p:cTn id="101" dur="500"/>
-                            <p:tgtEl>
-                              <p:spTgt spid="124"/>
-                            </p:tgtEl>
-                          </p:cBhvr>
-                        </p:animEffect>
-                      </p:childTnLst>
-                    </p:cTn>
-                  </p:par>
-                  <p:par>
-                    <p:cTn id="7" presetID="10" presetClass="entr" presetSubtype="0" fill="hold" nodeType="afterPrev">
-                      <p:stCondLst>
-                        <p:cond delay="600"/>
-                      </p:stCondLst>
-                      <p:childTnLst>
-                        <p:set>
-                          <p:cBhvr>
-                            <p:cTn id="8" dur="1" fill="hold">
-                              <p:stCondLst>
-                                <p:cond delay="0"/>
-                              </p:stCondLst>
-                            </p:cTn>
-                            <p:tgtEl>
-                              <p:spTgt spid="58"/>
-                            </p:tgtEl>
-                            <p:attrNameLst>
-                              <p:attrName>style.visibility</p:attrName>
-                            </p:attrNameLst>
-                          </p:cBhvr>
-                          <p:to>
-                            <p:strVal val="visible"/>
-                          </p:to>
-                        </p:set>
-                        <p:animEffect transition="in" filter="fade">
-                          <p:cBhvr>
-                            <p:cTn id="102" dur="500"/>
-                            <p:tgtEl>
-                              <p:spTgt spid="58"/>
-                            </p:tgtEl>
-                          </p:cBhvr>
-                        </p:animEffect>
-                      </p:childTnLst>
-                    </p:cTn>
-                  </p:par>
-                  <p:par>
-                    <p:cTn id="9" presetID="10" presetClass="entr" presetSubtype="0" fill="hold" nodeType="afterPrev">
-                      <p:stCondLst>
-                        <p:cond delay="900"/>
-                      </p:stCondLst>
-                      <p:childTnLst>
-                        <p:set>
-                          <p:cBhvr>
-                            <p:cTn id="10" dur="1" fill="hold">
-                              <p:stCondLst>
-                                <p:cond delay="0"/>
-                              </p:stCondLst>
-                            </p:cTn>
-                            <p:tgtEl>
-                              <p:spTgt spid="59"/>
-                            </p:tgtEl>
-                            <p:attrNameLst>
-                              <p:attrName>style.visibility</p:attrName>
-                            </p:attrNameLst>
-                          </p:cBhvr>
-                          <p:to>
-                            <p:strVal val="visible"/>
-                          </p:to>
-                        </p:set>
-                        <p:animEffect transition="in" filter="fade">
-                          <p:cBhvr>
-                            <p:cTn id="103" dur="500"/>
-                            <p:tgtEl>
-                              <p:spTgt spid="59"/>
-                            </p:tgtEl>
-                          </p:cBhvr>
-                        </p:animEffect>
-                      </p:childTnLst>
-                    </p:cTn>
-                  </p:par>
-                  <p:par>
-                    <p:cTn id="11" presetID="10" presetClass="entr" presetSubtype="0" fill="hold" nodeType="afterPrev">
-                      <p:stCondLst>
-                        <p:cond delay="1200"/>
-                      </p:stCondLst>
-                      <p:childTnLst>
-                        <p:set>
-                          <p:cBhvr>
-                            <p:cTn id="12" dur="1" fill="hold">
-                              <p:stCondLst>
-                                <p:cond delay="0"/>
-                              </p:stCondLst>
-                            </p:cTn>
-                            <p:tgtEl>
-                              <p:spTgt spid="60"/>
-                            </p:tgtEl>
-                            <p:attrNameLst>
-                              <p:attrName>style.visibility</p:attrName>
-                            </p:attrNameLst>
-                          </p:cBhvr>
-                          <p:to>
-                            <p:strVal val="visible"/>
-                          </p:to>
-                        </p:set>
-                        <p:animEffect transition="in" filter="fade">
-                          <p:cBhvr>
-                            <p:cTn id="104" dur="500"/>
-                            <p:tgtEl>
-                              <p:spTgt spid="60"/>
-                            </p:tgtEl>
-                          </p:cBhvr>
-                        </p:animEffect>
-                      </p:childTnLst>
-                    </p:cTn>
-                  </p:par>
-                  <p:par>
-                    <p:cTn id="13" presetID="10" presetClass="entr" presetSubtype="0" fill="hold" nodeType="afterPrev">
-                      <p:stCondLst>
-                        <p:cond delay="1500"/>
-                      </p:stCondLst>
-                      <p:childTnLst>
-                        <p:set>
-                          <p:cBhvr>
-                            <p:cTn id="14" dur="1" fill="hold">
-                              <p:stCondLst>
-                                <p:cond delay="0"/>
-                              </p:stCondLst>
-                            </p:cTn>
-                            <p:tgtEl>
-                              <p:spTgt spid="61"/>
-                            </p:tgtEl>
-                            <p:attrNameLst>
-                              <p:attrName>style.visibility</p:attrName>
-                            </p:attrNameLst>
-                          </p:cBhvr>
-                          <p:to>
-                            <p:strVal val="visible"/>
-                          </p:to>
-                        </p:set>
-                        <p:animEffect transition="in" filter="fade">
-                          <p:cBhvr>
-                            <p:cTn id="105" dur="500"/>
-                            <p:tgtEl>
-                              <p:spTgt spid="61"/>
-                            </p:tgtEl>
-                          </p:cBhvr>
-                        </p:animEffect>
-                      </p:childTnLst>
-                    </p:cTn>
-                  </p:par>
-                </p:childTnLst>
-              </p:cTn>
-              <p:prevCondLst>
-                <p:cond evt="onPrev" delay="0">
-                  <p:tgtEl>
-                    <p:sldTgt/>
-                  </p:tgtEl>
-                </p:cond>
-              </p:prevCondLst>
-              <p:nextCondLst>
-                <p:cond evt="onNext" delay="0">
-                  <p:tgtEl>
-                    <p:sldTgt/>
-                  </p:tgtEl>
-                </p:cond>
-              </p:nextCondLst>
-            </p:seq>
-          </p:childTnLst>
-        </p:cTn>
-      </p:par>
-    </p:tnLst>
-  </p:timing>
 </p:sld>
 </file>
 
@@ -43933,106 +40173,6 @@
   <p:transition spd="med" advClick="1">
     <p:fade/>
   </p:transition>
-  <p:timing>
-    <p:tnLst>
-      <p:par>
-        <p:cTn id="1" dur="indefinite" restart="never" nodeType="tmRoot">
-          <p:childTnLst>
-            <p:seq concurrent="1" nextAc="seek">
-              <p:cTn id="2" dur="indefinite" nodeType="mainSeq">
-                <p:childTnLst>
-                  <p:par>
-                    <p:cTn id="3" presetID="10" presetClass="entr" presetSubtype="0" fill="hold" nodeType="afterPrev">
-                      <p:stCondLst>
-                        <p:cond delay="0"/>
-                      </p:stCondLst>
-                      <p:childTnLst>
-                        <p:set>
-                          <p:cBhvr>
-                            <p:cTn id="4" dur="1" fill="hold">
-                              <p:stCondLst>
-                                <p:cond delay="0"/>
-                              </p:stCondLst>
-                            </p:cTn>
-                            <p:tgtEl>
-                              <p:spTgt spid="156"/>
-                            </p:tgtEl>
-                            <p:attrNameLst>
-                              <p:attrName>style.visibility</p:attrName>
-                            </p:attrNameLst>
-                          </p:cBhvr>
-                          <p:to>
-                            <p:strVal val="visible"/>
-                          </p:to>
-                        </p:set>
-                        <p:animEffect transition="in" filter="fade">
-                          <p:cBhvr>
-                            <p:cTn id="100" dur="500"/>
-                            <p:tgtEl>
-                              <p:spTgt spid="156"/>
-                            </p:tgtEl>
-                          </p:cBhvr>
-                        </p:animEffect>
-                      </p:childTnLst>
-                    </p:cTn>
-                  </p:par>
-                  <p:par>
-                    <p:cTn id="5" presetID="10" presetClass="entr" presetSubtype="0" fill="hold" nodeType="afterPrev">
-                      <p:stCondLst>
-                        <p:cond delay="300"/>
-                      </p:stCondLst>
-                      <p:childTnLst>
-                        <p:set>
-                          <p:cBhvr>
-                            <p:cTn id="6" dur="1" fill="hold">
-                              <p:stCondLst>
-                                <p:cond delay="0"/>
-                              </p:stCondLst>
-                            </p:cTn>
-                            <p:tgtEl>
-                              <p:spTgt spid="157"/>
-                            </p:tgtEl>
-                            <p:attrNameLst>
-                              <p:attrName>style.visibility</p:attrName>
-                            </p:attrNameLst>
-                          </p:cBhvr>
-                          <p:to>
-                            <p:strVal val="visible"/>
-                          </p:to>
-                        </p:set>
-                        <p:animEffect transition="in" filter="fade">
-                          <p:cBhvr>
-                            <p:cTn id="101" dur="500"/>
-                            <p:tgtEl>
-                              <p:spTgt spid="157"/>
-                            </p:tgtEl>
-                          </p:cBhvr>
-                        </p:animEffect>
-                      </p:childTnLst>
-                    </p:cTn>
-                  </p:par>
-                </p:childTnLst>
-              </p:cTn>
-              <p:prevCondLst>
-                <p:cond evt="onPrev" delay="0">
-                  <p:tgtEl>
-                    <p:sldTgt/>
-                  </p:tgtEl>
-                </p:cond>
-              </p:prevCondLst>
-              <p:nextCondLst>
-                <p:cond evt="onNext" delay="0">
-                  <p:tgtEl>
-                    <p:sldTgt/>
-                  </p:tgtEl>
-                </p:cond>
-              </p:nextCondLst>
-            </p:seq>
-          </p:childTnLst>
-        </p:cTn>
-      </p:par>
-    </p:tnLst>
-  </p:timing>
 </p:sld>
 </file>
 
@@ -46506,246 +42646,6 @@
   <p:transition spd="med" advClick="1">
     <p:fade/>
   </p:transition>
-  <p:timing>
-    <p:tnLst>
-      <p:par>
-        <p:cTn id="1" dur="indefinite" restart="never" nodeType="tmRoot">
-          <p:childTnLst>
-            <p:seq concurrent="1" nextAc="seek">
-              <p:cTn id="2" dur="indefinite" nodeType="mainSeq">
-                <p:childTnLst>
-                  <p:par>
-                    <p:cTn id="3" presetID="10" presetClass="entr" presetSubtype="0" fill="hold" nodeType="afterPrev">
-                      <p:stCondLst>
-                        <p:cond delay="0"/>
-                      </p:stCondLst>
-                      <p:childTnLst>
-                        <p:set>
-                          <p:cBhvr>
-                            <p:cTn id="4" dur="1" fill="hold">
-                              <p:stCondLst>
-                                <p:cond delay="0"/>
-                              </p:stCondLst>
-                            </p:cTn>
-                            <p:tgtEl>
-                              <p:spTgt spid="162"/>
-                            </p:tgtEl>
-                            <p:attrNameLst>
-                              <p:attrName>style.visibility</p:attrName>
-                            </p:attrNameLst>
-                          </p:cBhvr>
-                          <p:to>
-                            <p:strVal val="visible"/>
-                          </p:to>
-                        </p:set>
-                        <p:animEffect transition="in" filter="fade">
-                          <p:cBhvr>
-                            <p:cTn id="100" dur="500"/>
-                            <p:tgtEl>
-                              <p:spTgt spid="162"/>
-                            </p:tgtEl>
-                          </p:cBhvr>
-                        </p:animEffect>
-                      </p:childTnLst>
-                    </p:cTn>
-                  </p:par>
-                  <p:par>
-                    <p:cTn id="5" presetID="10" presetClass="entr" presetSubtype="0" fill="hold" nodeType="afterPrev">
-                      <p:stCondLst>
-                        <p:cond delay="300"/>
-                      </p:stCondLst>
-                      <p:childTnLst>
-                        <p:set>
-                          <p:cBhvr>
-                            <p:cTn id="6" dur="1" fill="hold">
-                              <p:stCondLst>
-                                <p:cond delay="0"/>
-                              </p:stCondLst>
-                            </p:cTn>
-                            <p:tgtEl>
-                              <p:spTgt spid="163"/>
-                            </p:tgtEl>
-                            <p:attrNameLst>
-                              <p:attrName>style.visibility</p:attrName>
-                            </p:attrNameLst>
-                          </p:cBhvr>
-                          <p:to>
-                            <p:strVal val="visible"/>
-                          </p:to>
-                        </p:set>
-                        <p:animEffect transition="in" filter="fade">
-                          <p:cBhvr>
-                            <p:cTn id="101" dur="500"/>
-                            <p:tgtEl>
-                              <p:spTgt spid="163"/>
-                            </p:tgtEl>
-                          </p:cBhvr>
-                        </p:animEffect>
-                      </p:childTnLst>
-                    </p:cTn>
-                  </p:par>
-                  <p:par>
-                    <p:cTn id="7" presetID="10" presetClass="entr" presetSubtype="0" fill="hold" nodeType="afterPrev">
-                      <p:stCondLst>
-                        <p:cond delay="600"/>
-                      </p:stCondLst>
-                      <p:childTnLst>
-                        <p:set>
-                          <p:cBhvr>
-                            <p:cTn id="8" dur="1" fill="hold">
-                              <p:stCondLst>
-                                <p:cond delay="0"/>
-                              </p:stCondLst>
-                            </p:cTn>
-                            <p:tgtEl>
-                              <p:spTgt spid="164"/>
-                            </p:tgtEl>
-                            <p:attrNameLst>
-                              <p:attrName>style.visibility</p:attrName>
-                            </p:attrNameLst>
-                          </p:cBhvr>
-                          <p:to>
-                            <p:strVal val="visible"/>
-                          </p:to>
-                        </p:set>
-                        <p:animEffect transition="in" filter="fade">
-                          <p:cBhvr>
-                            <p:cTn id="102" dur="500"/>
-                            <p:tgtEl>
-                              <p:spTgt spid="164"/>
-                            </p:tgtEl>
-                          </p:cBhvr>
-                        </p:animEffect>
-                      </p:childTnLst>
-                    </p:cTn>
-                  </p:par>
-                  <p:par>
-                    <p:cTn id="9" presetID="10" presetClass="entr" presetSubtype="0" fill="hold" nodeType="afterPrev">
-                      <p:stCondLst>
-                        <p:cond delay="900"/>
-                      </p:stCondLst>
-                      <p:childTnLst>
-                        <p:set>
-                          <p:cBhvr>
-                            <p:cTn id="10" dur="1" fill="hold">
-                              <p:stCondLst>
-                                <p:cond delay="0"/>
-                              </p:stCondLst>
-                            </p:cTn>
-                            <p:tgtEl>
-                              <p:spTgt spid="57"/>
-                            </p:tgtEl>
-                            <p:attrNameLst>
-                              <p:attrName>style.visibility</p:attrName>
-                            </p:attrNameLst>
-                          </p:cBhvr>
-                          <p:to>
-                            <p:strVal val="visible"/>
-                          </p:to>
-                        </p:set>
-                        <p:animEffect transition="in" filter="fade">
-                          <p:cBhvr>
-                            <p:cTn id="103" dur="500"/>
-                            <p:tgtEl>
-                              <p:spTgt spid="57"/>
-                            </p:tgtEl>
-                          </p:cBhvr>
-                        </p:animEffect>
-                      </p:childTnLst>
-                    </p:cTn>
-                  </p:par>
-                  <p:par>
-                    <p:cTn id="11" presetID="10" presetClass="entr" presetSubtype="0" fill="hold" nodeType="afterPrev">
-                      <p:stCondLst>
-                        <p:cond delay="1200"/>
-                      </p:stCondLst>
-                      <p:childTnLst>
-                        <p:set>
-                          <p:cBhvr>
-                            <p:cTn id="12" dur="1" fill="hold">
-                              <p:stCondLst>
-                                <p:cond delay="0"/>
-                              </p:stCondLst>
-                            </p:cTn>
-                            <p:tgtEl>
-                              <p:spTgt spid="58"/>
-                            </p:tgtEl>
-                            <p:attrNameLst>
-                              <p:attrName>style.visibility</p:attrName>
-                            </p:attrNameLst>
-                          </p:cBhvr>
-                          <p:to>
-                            <p:strVal val="visible"/>
-                          </p:to>
-                        </p:set>
-                        <p:animEffect transition="in" filter="fade">
-                          <p:cBhvr>
-                            <p:cTn id="104" dur="500"/>
-                            <p:tgtEl>
-                              <p:spTgt spid="58"/>
-                            </p:tgtEl>
-                          </p:cBhvr>
-                        </p:animEffect>
-                      </p:childTnLst>
-                    </p:cTn>
-                  </p:par>
-                  <p:par>
-                    <p:cTn id="13" presetID="10" presetClass="entr" presetSubtype="0" fill="hold" nodeType="afterPrev">
-                      <p:stCondLst>
-                        <p:cond delay="1500"/>
-                      </p:stCondLst>
-                      <p:childTnLst>
-                        <p:set>
-                          <p:cBhvr>
-                            <p:cTn id="14" dur="1" fill="hold">
-                              <p:stCondLst>
-                                <p:cond delay="0"/>
-                              </p:stCondLst>
-                            </p:cTn>
-                            <p:tgtEl>
-                              <p:spTgt spid="59"/>
-                            </p:tgtEl>
-                            <p:attrNameLst>
-                              <p:attrName>style.visibility</p:attrName>
-                            </p:attrNameLst>
-                          </p:cBhvr>
-                          <p:to>
-                            <p:strVal val="visible"/>
-                          </p:to>
-                        </p:set>
-                        <p:animEffect transition="in" filter="fade">
-                          <p:cBhvr>
-                            <p:cTn id="105" dur="500"/>
-                            <p:tgtEl>
-                              <p:spTgt spid="59"/>
-                            </p:tgtEl>
-                          </p:cBhvr>
-                        </p:animEffect>
-                      </p:childTnLst>
-                    </p:cTn>
-                  </p:par>
-                </p:childTnLst>
-              </p:cTn>
-              <p:prevCondLst>
-                <p:cond evt="onPrev" delay="0">
-                  <p:tgtEl>
-                    <p:sldTgt/>
-                  </p:tgtEl>
-                </p:cond>
-              </p:prevCondLst>
-              <p:nextCondLst>
-                <p:cond evt="onNext" delay="0">
-                  <p:tgtEl>
-                    <p:sldTgt/>
-                  </p:tgtEl>
-                </p:cond>
-              </p:nextCondLst>
-            </p:seq>
-          </p:childTnLst>
-        </p:cTn>
-      </p:par>
-    </p:tnLst>
-  </p:timing>
 </p:sld>
 </file>
 
@@ -49276,246 +45176,6 @@
   <p:transition spd="med" advClick="1">
     <p:push dir="l"/>
   </p:transition>
-  <p:timing>
-    <p:tnLst>
-      <p:par>
-        <p:cTn id="1" dur="indefinite" restart="never" nodeType="tmRoot">
-          <p:childTnLst>
-            <p:seq concurrent="1" nextAc="seek">
-              <p:cTn id="2" dur="indefinite" nodeType="mainSeq">
-                <p:childTnLst>
-                  <p:par>
-                    <p:cTn id="3" presetID="10" presetClass="entr" presetSubtype="0" fill="hold" nodeType="afterPrev">
-                      <p:stCondLst>
-                        <p:cond delay="0"/>
-                      </p:stCondLst>
-                      <p:childTnLst>
-                        <p:set>
-                          <p:cBhvr>
-                            <p:cTn id="4" dur="1" fill="hold">
-                              <p:stCondLst>
-                                <p:cond delay="0"/>
-                              </p:stCondLst>
-                            </p:cTn>
-                            <p:tgtEl>
-                              <p:spTgt spid="195"/>
-                            </p:tgtEl>
-                            <p:attrNameLst>
-                              <p:attrName>style.visibility</p:attrName>
-                            </p:attrNameLst>
-                          </p:cBhvr>
-                          <p:to>
-                            <p:strVal val="visible"/>
-                          </p:to>
-                        </p:set>
-                        <p:animEffect transition="in" filter="fade">
-                          <p:cBhvr>
-                            <p:cTn id="100" dur="500"/>
-                            <p:tgtEl>
-                              <p:spTgt spid="195"/>
-                            </p:tgtEl>
-                          </p:cBhvr>
-                        </p:animEffect>
-                      </p:childTnLst>
-                    </p:cTn>
-                  </p:par>
-                  <p:par>
-                    <p:cTn id="5" presetID="10" presetClass="entr" presetSubtype="0" fill="hold" nodeType="afterPrev">
-                      <p:stCondLst>
-                        <p:cond delay="300"/>
-                      </p:stCondLst>
-                      <p:childTnLst>
-                        <p:set>
-                          <p:cBhvr>
-                            <p:cTn id="6" dur="1" fill="hold">
-                              <p:stCondLst>
-                                <p:cond delay="0"/>
-                              </p:stCondLst>
-                            </p:cTn>
-                            <p:tgtEl>
-                              <p:spTgt spid="224"/>
-                            </p:tgtEl>
-                            <p:attrNameLst>
-                              <p:attrName>style.visibility</p:attrName>
-                            </p:attrNameLst>
-                          </p:cBhvr>
-                          <p:to>
-                            <p:strVal val="visible"/>
-                          </p:to>
-                        </p:set>
-                        <p:animEffect transition="in" filter="fade">
-                          <p:cBhvr>
-                            <p:cTn id="101" dur="500"/>
-                            <p:tgtEl>
-                              <p:spTgt spid="224"/>
-                            </p:tgtEl>
-                          </p:cBhvr>
-                        </p:animEffect>
-                      </p:childTnLst>
-                    </p:cTn>
-                  </p:par>
-                  <p:par>
-                    <p:cTn id="7" presetID="10" presetClass="entr" presetSubtype="0" fill="hold" nodeType="afterPrev">
-                      <p:stCondLst>
-                        <p:cond delay="600"/>
-                      </p:stCondLst>
-                      <p:childTnLst>
-                        <p:set>
-                          <p:cBhvr>
-                            <p:cTn id="8" dur="1" fill="hold">
-                              <p:stCondLst>
-                                <p:cond delay="0"/>
-                              </p:stCondLst>
-                            </p:cTn>
-                            <p:tgtEl>
-                              <p:spTgt spid="225"/>
-                            </p:tgtEl>
-                            <p:attrNameLst>
-                              <p:attrName>style.visibility</p:attrName>
-                            </p:attrNameLst>
-                          </p:cBhvr>
-                          <p:to>
-                            <p:strVal val="visible"/>
-                          </p:to>
-                        </p:set>
-                        <p:animEffect transition="in" filter="fade">
-                          <p:cBhvr>
-                            <p:cTn id="102" dur="500"/>
-                            <p:tgtEl>
-                              <p:spTgt spid="225"/>
-                            </p:tgtEl>
-                          </p:cBhvr>
-                        </p:animEffect>
-                      </p:childTnLst>
-                    </p:cTn>
-                  </p:par>
-                  <p:par>
-                    <p:cTn id="9" presetID="10" presetClass="entr" presetSubtype="0" fill="hold" nodeType="afterPrev">
-                      <p:stCondLst>
-                        <p:cond delay="900"/>
-                      </p:stCondLst>
-                      <p:childTnLst>
-                        <p:set>
-                          <p:cBhvr>
-                            <p:cTn id="10" dur="1" fill="hold">
-                              <p:stCondLst>
-                                <p:cond delay="0"/>
-                              </p:stCondLst>
-                            </p:cTn>
-                            <p:tgtEl>
-                              <p:spTgt spid="61"/>
-                            </p:tgtEl>
-                            <p:attrNameLst>
-                              <p:attrName>style.visibility</p:attrName>
-                            </p:attrNameLst>
-                          </p:cBhvr>
-                          <p:to>
-                            <p:strVal val="visible"/>
-                          </p:to>
-                        </p:set>
-                        <p:animEffect transition="in" filter="fade">
-                          <p:cBhvr>
-                            <p:cTn id="103" dur="500"/>
-                            <p:tgtEl>
-                              <p:spTgt spid="61"/>
-                            </p:tgtEl>
-                          </p:cBhvr>
-                        </p:animEffect>
-                      </p:childTnLst>
-                    </p:cTn>
-                  </p:par>
-                  <p:par>
-                    <p:cTn id="11" presetID="10" presetClass="entr" presetSubtype="0" fill="hold" nodeType="afterPrev">
-                      <p:stCondLst>
-                        <p:cond delay="1200"/>
-                      </p:stCondLst>
-                      <p:childTnLst>
-                        <p:set>
-                          <p:cBhvr>
-                            <p:cTn id="12" dur="1" fill="hold">
-                              <p:stCondLst>
-                                <p:cond delay="0"/>
-                              </p:stCondLst>
-                            </p:cTn>
-                            <p:tgtEl>
-                              <p:spTgt spid="62"/>
-                            </p:tgtEl>
-                            <p:attrNameLst>
-                              <p:attrName>style.visibility</p:attrName>
-                            </p:attrNameLst>
-                          </p:cBhvr>
-                          <p:to>
-                            <p:strVal val="visible"/>
-                          </p:to>
-                        </p:set>
-                        <p:animEffect transition="in" filter="fade">
-                          <p:cBhvr>
-                            <p:cTn id="104" dur="500"/>
-                            <p:tgtEl>
-                              <p:spTgt spid="62"/>
-                            </p:tgtEl>
-                          </p:cBhvr>
-                        </p:animEffect>
-                      </p:childTnLst>
-                    </p:cTn>
-                  </p:par>
-                  <p:par>
-                    <p:cTn id="13" presetID="10" presetClass="entr" presetSubtype="0" fill="hold" nodeType="afterPrev">
-                      <p:stCondLst>
-                        <p:cond delay="1500"/>
-                      </p:stCondLst>
-                      <p:childTnLst>
-                        <p:set>
-                          <p:cBhvr>
-                            <p:cTn id="14" dur="1" fill="hold">
-                              <p:stCondLst>
-                                <p:cond delay="0"/>
-                              </p:stCondLst>
-                            </p:cTn>
-                            <p:tgtEl>
-                              <p:spTgt spid="63"/>
-                            </p:tgtEl>
-                            <p:attrNameLst>
-                              <p:attrName>style.visibility</p:attrName>
-                            </p:attrNameLst>
-                          </p:cBhvr>
-                          <p:to>
-                            <p:strVal val="visible"/>
-                          </p:to>
-                        </p:set>
-                        <p:animEffect transition="in" filter="fade">
-                          <p:cBhvr>
-                            <p:cTn id="105" dur="500"/>
-                            <p:tgtEl>
-                              <p:spTgt spid="63"/>
-                            </p:tgtEl>
-                          </p:cBhvr>
-                        </p:animEffect>
-                      </p:childTnLst>
-                    </p:cTn>
-                  </p:par>
-                </p:childTnLst>
-              </p:cTn>
-              <p:prevCondLst>
-                <p:cond evt="onPrev" delay="0">
-                  <p:tgtEl>
-                    <p:sldTgt/>
-                  </p:tgtEl>
-                </p:cond>
-              </p:prevCondLst>
-              <p:nextCondLst>
-                <p:cond evt="onNext" delay="0">
-                  <p:tgtEl>
-                    <p:sldTgt/>
-                  </p:tgtEl>
-                </p:cond>
-              </p:nextCondLst>
-            </p:seq>
-          </p:childTnLst>
-        </p:cTn>
-      </p:par>
-    </p:tnLst>
-  </p:timing>
 </p:sld>
 </file>
 
@@ -51995,246 +47655,6 @@
   <p:transition spd="med" advClick="1">
     <p:fade/>
   </p:transition>
-  <p:timing>
-    <p:tnLst>
-      <p:par>
-        <p:cTn id="1" dur="indefinite" restart="never" nodeType="tmRoot">
-          <p:childTnLst>
-            <p:seq concurrent="1" nextAc="seek">
-              <p:cTn id="2" dur="indefinite" nodeType="mainSeq">
-                <p:childTnLst>
-                  <p:par>
-                    <p:cTn id="3" presetID="10" presetClass="entr" presetSubtype="0" fill="hold" nodeType="afterPrev">
-                      <p:stCondLst>
-                        <p:cond delay="0"/>
-                      </p:stCondLst>
-                      <p:childTnLst>
-                        <p:set>
-                          <p:cBhvr>
-                            <p:cTn id="4" dur="1" fill="hold">
-                              <p:stCondLst>
-                                <p:cond delay="0"/>
-                              </p:stCondLst>
-                            </p:cTn>
-                            <p:tgtEl>
-                              <p:spTgt spid="230"/>
-                            </p:tgtEl>
-                            <p:attrNameLst>
-                              <p:attrName>style.visibility</p:attrName>
-                            </p:attrNameLst>
-                          </p:cBhvr>
-                          <p:to>
-                            <p:strVal val="visible"/>
-                          </p:to>
-                        </p:set>
-                        <p:animEffect transition="in" filter="fade">
-                          <p:cBhvr>
-                            <p:cTn id="100" dur="500"/>
-                            <p:tgtEl>
-                              <p:spTgt spid="230"/>
-                            </p:tgtEl>
-                          </p:cBhvr>
-                        </p:animEffect>
-                      </p:childTnLst>
-                    </p:cTn>
-                  </p:par>
-                  <p:par>
-                    <p:cTn id="5" presetID="10" presetClass="entr" presetSubtype="0" fill="hold" nodeType="afterPrev">
-                      <p:stCondLst>
-                        <p:cond delay="300"/>
-                      </p:stCondLst>
-                      <p:childTnLst>
-                        <p:set>
-                          <p:cBhvr>
-                            <p:cTn id="6" dur="1" fill="hold">
-                              <p:stCondLst>
-                                <p:cond delay="0"/>
-                              </p:stCondLst>
-                            </p:cTn>
-                            <p:tgtEl>
-                              <p:spTgt spid="231"/>
-                            </p:tgtEl>
-                            <p:attrNameLst>
-                              <p:attrName>style.visibility</p:attrName>
-                            </p:attrNameLst>
-                          </p:cBhvr>
-                          <p:to>
-                            <p:strVal val="visible"/>
-                          </p:to>
-                        </p:set>
-                        <p:animEffect transition="in" filter="fade">
-                          <p:cBhvr>
-                            <p:cTn id="101" dur="500"/>
-                            <p:tgtEl>
-                              <p:spTgt spid="231"/>
-                            </p:tgtEl>
-                          </p:cBhvr>
-                        </p:animEffect>
-                      </p:childTnLst>
-                    </p:cTn>
-                  </p:par>
-                  <p:par>
-                    <p:cTn id="7" presetID="10" presetClass="entr" presetSubtype="0" fill="hold" nodeType="afterPrev">
-                      <p:stCondLst>
-                        <p:cond delay="600"/>
-                      </p:stCondLst>
-                      <p:childTnLst>
-                        <p:set>
-                          <p:cBhvr>
-                            <p:cTn id="8" dur="1" fill="hold">
-                              <p:stCondLst>
-                                <p:cond delay="0"/>
-                              </p:stCondLst>
-                            </p:cTn>
-                            <p:tgtEl>
-                              <p:spTgt spid="232"/>
-                            </p:tgtEl>
-                            <p:attrNameLst>
-                              <p:attrName>style.visibility</p:attrName>
-                            </p:attrNameLst>
-                          </p:cBhvr>
-                          <p:to>
-                            <p:strVal val="visible"/>
-                          </p:to>
-                        </p:set>
-                        <p:animEffect transition="in" filter="fade">
-                          <p:cBhvr>
-                            <p:cTn id="102" dur="500"/>
-                            <p:tgtEl>
-                              <p:spTgt spid="232"/>
-                            </p:tgtEl>
-                          </p:cBhvr>
-                        </p:animEffect>
-                      </p:childTnLst>
-                    </p:cTn>
-                  </p:par>
-                  <p:par>
-                    <p:cTn id="9" presetID="10" presetClass="entr" presetSubtype="0" fill="hold" nodeType="afterPrev">
-                      <p:stCondLst>
-                        <p:cond delay="900"/>
-                      </p:stCondLst>
-                      <p:childTnLst>
-                        <p:set>
-                          <p:cBhvr>
-                            <p:cTn id="10" dur="1" fill="hold">
-                              <p:stCondLst>
-                                <p:cond delay="0"/>
-                              </p:stCondLst>
-                            </p:cTn>
-                            <p:tgtEl>
-                              <p:spTgt spid="233"/>
-                            </p:tgtEl>
-                            <p:attrNameLst>
-                              <p:attrName>style.visibility</p:attrName>
-                            </p:attrNameLst>
-                          </p:cBhvr>
-                          <p:to>
-                            <p:strVal val="visible"/>
-                          </p:to>
-                        </p:set>
-                        <p:animEffect transition="in" filter="fade">
-                          <p:cBhvr>
-                            <p:cTn id="103" dur="500"/>
-                            <p:tgtEl>
-                              <p:spTgt spid="233"/>
-                            </p:tgtEl>
-                          </p:cBhvr>
-                        </p:animEffect>
-                      </p:childTnLst>
-                    </p:cTn>
-                  </p:par>
-                  <p:par>
-                    <p:cTn id="11" presetID="10" presetClass="entr" presetSubtype="0" fill="hold" nodeType="afterPrev">
-                      <p:stCondLst>
-                        <p:cond delay="1200"/>
-                      </p:stCondLst>
-                      <p:childTnLst>
-                        <p:set>
-                          <p:cBhvr>
-                            <p:cTn id="12" dur="1" fill="hold">
-                              <p:stCondLst>
-                                <p:cond delay="0"/>
-                              </p:stCondLst>
-                            </p:cTn>
-                            <p:tgtEl>
-                              <p:spTgt spid="32"/>
-                            </p:tgtEl>
-                            <p:attrNameLst>
-                              <p:attrName>style.visibility</p:attrName>
-                            </p:attrNameLst>
-                          </p:cBhvr>
-                          <p:to>
-                            <p:strVal val="visible"/>
-                          </p:to>
-                        </p:set>
-                        <p:animEffect transition="in" filter="fade">
-                          <p:cBhvr>
-                            <p:cTn id="104" dur="500"/>
-                            <p:tgtEl>
-                              <p:spTgt spid="32"/>
-                            </p:tgtEl>
-                          </p:cBhvr>
-                        </p:animEffect>
-                      </p:childTnLst>
-                    </p:cTn>
-                  </p:par>
-                  <p:par>
-                    <p:cTn id="13" presetID="10" presetClass="entr" presetSubtype="0" fill="hold" nodeType="afterPrev">
-                      <p:stCondLst>
-                        <p:cond delay="1500"/>
-                      </p:stCondLst>
-                      <p:childTnLst>
-                        <p:set>
-                          <p:cBhvr>
-                            <p:cTn id="14" dur="1" fill="hold">
-                              <p:stCondLst>
-                                <p:cond delay="0"/>
-                              </p:stCondLst>
-                            </p:cTn>
-                            <p:tgtEl>
-                              <p:spTgt spid="33"/>
-                            </p:tgtEl>
-                            <p:attrNameLst>
-                              <p:attrName>style.visibility</p:attrName>
-                            </p:attrNameLst>
-                          </p:cBhvr>
-                          <p:to>
-                            <p:strVal val="visible"/>
-                          </p:to>
-                        </p:set>
-                        <p:animEffect transition="in" filter="fade">
-                          <p:cBhvr>
-                            <p:cTn id="105" dur="500"/>
-                            <p:tgtEl>
-                              <p:spTgt spid="33"/>
-                            </p:tgtEl>
-                          </p:cBhvr>
-                        </p:animEffect>
-                      </p:childTnLst>
-                    </p:cTn>
-                  </p:par>
-                </p:childTnLst>
-              </p:cTn>
-              <p:prevCondLst>
-                <p:cond evt="onPrev" delay="0">
-                  <p:tgtEl>
-                    <p:sldTgt/>
-                  </p:tgtEl>
-                </p:cond>
-              </p:prevCondLst>
-              <p:nextCondLst>
-                <p:cond evt="onNext" delay="0">
-                  <p:tgtEl>
-                    <p:sldTgt/>
-                  </p:tgtEl>
-                </p:cond>
-              </p:nextCondLst>
-            </p:seq>
-          </p:childTnLst>
-        </p:cTn>
-      </p:par>
-    </p:tnLst>
-  </p:timing>
 </p:sld>
 </file>
 
@@ -52533,211 +47953,6 @@
   <p:transition spd="med" advClick="1">
     <p:fade/>
   </p:transition>
-  <p:timing>
-    <p:tnLst>
-      <p:par>
-        <p:cTn id="1" dur="indefinite" restart="never" nodeType="tmRoot">
-          <p:childTnLst>
-            <p:seq concurrent="1" nextAc="seek">
-              <p:cTn id="2" dur="indefinite" nodeType="mainSeq">
-                <p:childTnLst>
-                  <p:par>
-                    <p:cTn id="3" presetID="10" presetClass="entr" presetSubtype="0" fill="hold" nodeType="afterPrev">
-                      <p:stCondLst>
-                        <p:cond delay="0"/>
-                      </p:stCondLst>
-                      <p:childTnLst>
-                        <p:set>
-                          <p:cBhvr>
-                            <p:cTn id="4" dur="1" fill="hold">
-                              <p:stCondLst>
-                                <p:cond delay="0"/>
-                              </p:stCondLst>
-                            </p:cTn>
-                            <p:tgtEl>
-                              <p:spTgt spid="264"/>
-                            </p:tgtEl>
-                            <p:attrNameLst>
-                              <p:attrName>style.visibility</p:attrName>
-                            </p:attrNameLst>
-                          </p:cBhvr>
-                          <p:to>
-                            <p:strVal val="visible"/>
-                          </p:to>
-                        </p:set>
-                        <p:animEffect transition="in" filter="fade">
-                          <p:cBhvr>
-                            <p:cTn id="100" dur="500"/>
-                            <p:tgtEl>
-                              <p:spTgt spid="264"/>
-                            </p:tgtEl>
-                          </p:cBhvr>
-                        </p:animEffect>
-                      </p:childTnLst>
-                    </p:cTn>
-                  </p:par>
-                  <p:par>
-                    <p:cTn id="5" presetID="10" presetClass="entr" presetSubtype="0" fill="hold" nodeType="afterPrev">
-                      <p:stCondLst>
-                        <p:cond delay="300"/>
-                      </p:stCondLst>
-                      <p:childTnLst>
-                        <p:set>
-                          <p:cBhvr>
-                            <p:cTn id="6" dur="1" fill="hold">
-                              <p:stCondLst>
-                                <p:cond delay="0"/>
-                              </p:stCondLst>
-                            </p:cTn>
-                            <p:tgtEl>
-                              <p:spTgt spid="265"/>
-                            </p:tgtEl>
-                            <p:attrNameLst>
-                              <p:attrName>style.visibility</p:attrName>
-                            </p:attrNameLst>
-                          </p:cBhvr>
-                          <p:to>
-                            <p:strVal val="visible"/>
-                          </p:to>
-                        </p:set>
-                        <p:animEffect transition="in" filter="fade">
-                          <p:cBhvr>
-                            <p:cTn id="101" dur="500"/>
-                            <p:tgtEl>
-                              <p:spTgt spid="265"/>
-                            </p:tgtEl>
-                          </p:cBhvr>
-                        </p:animEffect>
-                      </p:childTnLst>
-                    </p:cTn>
-                  </p:par>
-                  <p:par>
-                    <p:cTn id="7" presetID="10" presetClass="entr" presetSubtype="0" fill="hold" nodeType="afterPrev">
-                      <p:stCondLst>
-                        <p:cond delay="600"/>
-                      </p:stCondLst>
-                      <p:childTnLst>
-                        <p:set>
-                          <p:cBhvr>
-                            <p:cTn id="8" dur="1" fill="hold">
-                              <p:stCondLst>
-                                <p:cond delay="0"/>
-                              </p:stCondLst>
-                            </p:cTn>
-                            <p:tgtEl>
-                              <p:spTgt spid="266"/>
-                            </p:tgtEl>
-                            <p:attrNameLst>
-                              <p:attrName>style.visibility</p:attrName>
-                            </p:attrNameLst>
-                          </p:cBhvr>
-                          <p:to>
-                            <p:strVal val="visible"/>
-                          </p:to>
-                        </p:set>
-                        <p:animEffect transition="in" filter="fade">
-                          <p:cBhvr>
-                            <p:cTn id="102" dur="500"/>
-                            <p:tgtEl>
-                              <p:spTgt spid="266"/>
-                            </p:tgtEl>
-                          </p:cBhvr>
-                        </p:animEffect>
-                      </p:childTnLst>
-                    </p:cTn>
-                  </p:par>
-                  <p:par>
-                    <p:cTn id="9" presetID="10" presetClass="entr" presetSubtype="0" fill="hold" nodeType="afterPrev">
-                      <p:stCondLst>
-                        <p:cond delay="900"/>
-                      </p:stCondLst>
-                      <p:childTnLst>
-                        <p:set>
-                          <p:cBhvr>
-                            <p:cTn id="10" dur="1" fill="hold">
-                              <p:stCondLst>
-                                <p:cond delay="0"/>
-                              </p:stCondLst>
-                            </p:cTn>
-                            <p:tgtEl>
-                              <p:spTgt spid="267"/>
-                            </p:tgtEl>
-                            <p:attrNameLst>
-                              <p:attrName>style.visibility</p:attrName>
-                            </p:attrNameLst>
-                          </p:cBhvr>
-                          <p:to>
-                            <p:strVal val="visible"/>
-                          </p:to>
-                        </p:set>
-                        <p:animEffect transition="in" filter="fade">
-                          <p:cBhvr>
-                            <p:cTn id="103" dur="500"/>
-                            <p:tgtEl>
-                              <p:spTgt spid="267"/>
-                            </p:tgtEl>
-                          </p:cBhvr>
-                        </p:animEffect>
-                      </p:childTnLst>
-                    </p:cTn>
-                  </p:par>
-                  <p:par>
-                    <p:cTn id="11" presetID="10" presetClass="entr" presetSubtype="0" fill="hold" nodeType="afterPrev">
-                      <p:stCondLst>
-                        <p:cond delay="1200"/>
-                      </p:stCondLst>
-                      <p:childTnLst>
-                        <p:set>
-                          <p:cBhvr>
-                            <p:cTn id="12" dur="1" fill="hold">
-                              <p:stCondLst>
-                                <p:cond delay="0"/>
-                              </p:stCondLst>
-                            </p:cTn>
-                            <p:tgtEl>
-                              <p:spTgt spid="268"/>
-                            </p:tgtEl>
-                            <p:attrNameLst>
-                              <p:attrName>style.visibility</p:attrName>
-                            </p:attrNameLst>
-                          </p:cBhvr>
-                          <p:to>
-                            <p:strVal val="visible"/>
-                          </p:to>
-                        </p:set>
-                        <p:animEffect transition="in" filter="fade">
-                          <p:cBhvr>
-                            <p:cTn id="104" dur="500"/>
-                            <p:tgtEl>
-                              <p:spTgt spid="268"/>
-                            </p:tgtEl>
-                          </p:cBhvr>
-                        </p:animEffect>
-                      </p:childTnLst>
-                    </p:cTn>
-                  </p:par>
-                </p:childTnLst>
-              </p:cTn>
-              <p:prevCondLst>
-                <p:cond evt="onPrev" delay="0">
-                  <p:tgtEl>
-                    <p:sldTgt/>
-                  </p:tgtEl>
-                </p:cond>
-              </p:prevCondLst>
-              <p:nextCondLst>
-                <p:cond evt="onNext" delay="0">
-                  <p:tgtEl>
-                    <p:sldTgt/>
-                  </p:tgtEl>
-                </p:cond>
-              </p:nextCondLst>
-            </p:seq>
-          </p:childTnLst>
-        </p:cTn>
-      </p:par>
-    </p:tnLst>
-  </p:timing>
 </p:sld>
 </file>
 

</xml_diff>

<commit_message>
Remove slide 19 (proficiency bar chart)
Removed the proficiency graph slide, reducing deck from 23 to 22
slides. Updated index.html, thumbnails, and PDF accordingly.

Co-Authored-By: Claude Opus 4.6 <noreply@anthropic.com>
</commit_message>
<xml_diff>
--- a/Tracey-Scott-Portfolio-New.pptx
+++ b/Tracey-Scott-Portfolio-New.pptx
@@ -26,7 +26,6 @@
     <p:sldId id="271" r:id="rId17"/>
     <p:sldId id="272" r:id="rId18"/>
     <p:sldId id="273" r:id="rId19"/>
-    <p:sldId id="274" r:id="rId20"/>
     <p:sldId id="275" r:id="rId21"/>
     <p:sldId id="276" r:id="rId22"/>
     <p:sldId id="277" r:id="rId23"/>
@@ -1732,110 +1731,6 @@
       <p:sp>
         <p:nvSpPr>
           <p:cNvPr id="391" name="Google Shape;391;g35ed75ccf_057:notes"/>
-          <p:cNvSpPr txBox="1">
-            <a:spLocks noGrp="1"/>
-          </p:cNvSpPr>
-          <p:nvPr>
-            <p:ph type="body" idx="1"/>
-          </p:nvPr>
-        </p:nvSpPr>
-        <p:spPr>
-          <a:xfrm>
-            <a:off x="685800" y="4343400"/>
-            <a:ext cx="5486400" cy="4114800"/>
-          </a:xfrm>
-          <a:prstGeom prst="rect">
-            <a:avLst/>
-          </a:prstGeom>
-        </p:spPr>
-        <p:txBody>
-          <a:bodyPr spcFirstLastPara="1" wrap="square" lIns="91425" tIns="91425" rIns="91425" bIns="91425" anchor="t" anchorCtr="0">
-            <a:noAutofit/>
-          </a:bodyPr>
-          <a:lstStyle/>
-          <a:p>
-            <a:pPr marL="0" lvl="0" indent="0" algn="l" rtl="0">
-              <a:spcBef>
-                <a:spcPts val="0"/>
-              </a:spcBef>
-              <a:spcAft>
-                <a:spcPts val="0"/>
-              </a:spcAft>
-              <a:buNone/>
-            </a:pPr>
-            <a:endParaRPr/>
-          </a:p>
-        </p:txBody>
-      </p:sp>
-    </p:spTree>
-  </p:cSld>
-  <p:clrMapOvr>
-    <a:masterClrMapping/>
-  </p:clrMapOvr>
-</p:notes>
-</file>
-
-<file path=ppt/notesSlides/notesSlide19.xml><?xml version="1.0" encoding="utf-8"?>
-<p:notes xmlns:a="http://schemas.openxmlformats.org/drawingml/2006/main" xmlns:r="http://schemas.openxmlformats.org/officeDocument/2006/relationships" xmlns:p="http://schemas.openxmlformats.org/presentationml/2006/main" showMasterSp="0" showMasterPhAnim="0">
-  <p:cSld>
-    <p:spTree>
-      <p:nvGrpSpPr>
-        <p:cNvPr id="1" name="Shape 401"/>
-        <p:cNvGrpSpPr/>
-        <p:nvPr/>
-      </p:nvGrpSpPr>
-      <p:grpSpPr>
-        <a:xfrm>
-          <a:off x="0" y="0"/>
-          <a:ext cx="0" cy="0"/>
-          <a:chOff x="0" y="0"/>
-          <a:chExt cx="0" cy="0"/>
-        </a:xfrm>
-      </p:grpSpPr>
-      <p:sp>
-        <p:nvSpPr>
-          <p:cNvPr id="402" name="Google Shape;402;g35ed75ccf_073:notes"/>
-          <p:cNvSpPr>
-            <a:spLocks noGrp="1" noRot="1" noChangeAspect="1"/>
-          </p:cNvSpPr>
-          <p:nvPr>
-            <p:ph type="sldImg" idx="2"/>
-          </p:nvPr>
-        </p:nvSpPr>
-        <p:spPr>
-          <a:xfrm>
-            <a:off x="381000" y="685800"/>
-            <a:ext cx="6096000" cy="3429000"/>
-          </a:xfrm>
-          <a:custGeom>
-            <a:avLst/>
-            <a:gdLst/>
-            <a:ahLst/>
-            <a:cxnLst/>
-            <a:rect l="l" t="t" r="r" b="b"/>
-            <a:pathLst>
-              <a:path w="120000" h="120000" extrusionOk="0">
-                <a:moveTo>
-                  <a:pt x="0" y="0"/>
-                </a:moveTo>
-                <a:lnTo>
-                  <a:pt x="120000" y="0"/>
-                </a:lnTo>
-                <a:lnTo>
-                  <a:pt x="120000" y="120000"/>
-                </a:lnTo>
-                <a:lnTo>
-                  <a:pt x="0" y="120000"/>
-                </a:lnTo>
-                <a:close/>
-              </a:path>
-            </a:pathLst>
-          </a:custGeom>
-        </p:spPr>
-      </p:sp>
-      <p:sp>
-        <p:nvSpPr>
-          <p:cNvPr id="403" name="Google Shape;403;g35ed75ccf_073:notes"/>
           <p:cNvSpPr txBox="1">
             <a:spLocks noGrp="1"/>
           </p:cNvSpPr>
@@ -33332,929 +33227,6 @@
 </p:sld>
 </file>
 
-<file path=ppt/slides/slide19.xml><?xml version="1.0" encoding="utf-8"?>
-<p:sld xmlns:a="http://schemas.openxmlformats.org/drawingml/2006/main" xmlns:r="http://schemas.openxmlformats.org/officeDocument/2006/relationships" xmlns:p="http://schemas.openxmlformats.org/presentationml/2006/main">
-  <p:cSld>
-    <p:spTree>
-      <p:nvGrpSpPr>
-        <p:cNvPr id="1" name="Shape 404"/>
-        <p:cNvGrpSpPr/>
-        <p:nvPr/>
-      </p:nvGrpSpPr>
-      <p:grpSpPr>
-        <a:xfrm>
-          <a:off x="0" y="0"/>
-          <a:ext cx="0" cy="0"/>
-          <a:chOff x="0" y="0"/>
-          <a:chExt cx="0" cy="0"/>
-        </a:xfrm>
-      </p:grpSpPr>
-      <p:sp>
-        <p:nvSpPr>
-          <p:cNvPr id="405" name="Google Shape;405;p29"/>
-          <p:cNvSpPr txBox="1">
-            <a:spLocks noGrp="1"/>
-          </p:cNvSpPr>
-          <p:nvPr>
-            <p:ph type="body" idx="1"/>
-          </p:nvPr>
-        </p:nvSpPr>
-        <p:spPr>
-          <a:xfrm>
-            <a:off x="855300" y="4406300"/>
-            <a:ext cx="7433400" cy="311400"/>
-          </a:xfrm>
-          <a:prstGeom prst="rect">
-            <a:avLst/>
-          </a:prstGeom>
-        </p:spPr>
-        <p:txBody>
-          <a:bodyPr spcFirstLastPara="1" wrap="square" lIns="0" tIns="0" rIns="0" bIns="0" anchor="t" anchorCtr="0">
-            <a:noAutofit/>
-          </a:bodyPr>
-          <a:lstStyle/>
-          <a:p>
-            <a:pPr marL="0" lvl="0" indent="0" algn="l" rtl="0">
-              <a:spcBef>
-                <a:spcPts val="0"/>
-              </a:spcBef>
-              <a:spcAft>
-                <a:spcPts val="800"/>
-              </a:spcAft>
-              <a:buNone/>
-            </a:pPr>
-            <a:r>
-              <a:rPr lang="en"/>
-              <a:t>Self-assessed proficiency across the production stack</a:t>
-            </a:r>
-            <a:endParaRPr/>
-          </a:p>
-        </p:txBody>
-      </p:sp>
-      <p:sp>
-        <p:nvSpPr>
-          <p:cNvPr id="406" name="Google Shape;406;p29"/>
-          <p:cNvSpPr txBox="1">
-            <a:spLocks noGrp="1"/>
-          </p:cNvSpPr>
-          <p:nvPr>
-            <p:ph type="sldNum" idx="12"/>
-          </p:nvPr>
-        </p:nvSpPr>
-        <p:spPr>
-          <a:xfrm>
-            <a:off x="8693400" y="4749850"/>
-            <a:ext cx="450600" cy="347100"/>
-          </a:xfrm>
-          <a:prstGeom prst="rect">
-            <a:avLst/>
-          </a:prstGeom>
-        </p:spPr>
-        <p:txBody>
-          <a:bodyPr spcFirstLastPara="1" wrap="square" lIns="0" tIns="0" rIns="0" bIns="0" anchor="ctr" anchorCtr="0">
-            <a:noAutofit/>
-          </a:bodyPr>
-          <a:lstStyle/>
-          <a:p>
-            <a:pPr marL="0" lvl="0" indent="0" algn="ctr" rtl="0">
-              <a:spcBef>
-                <a:spcPts val="0"/>
-              </a:spcBef>
-              <a:spcAft>
-                <a:spcPts val="0"/>
-              </a:spcAft>
-              <a:buNone/>
-            </a:pPr>
-            <a:fld id="{00000000-1234-1234-1234-123412341234}" type="slidenum">
-              <a:rPr lang="en"/>
-              <a:t>19</a:t>
-            </a:fld>
-            <a:endParaRPr/>
-          </a:p>
-        </p:txBody>
-      </p:sp>
-      <p:cxnSp>
-        <p:nvCxnSpPr>
-          <p:cNvPr id="407" name="Google Shape;407;p29"/>
-          <p:cNvCxnSpPr/>
-          <p:nvPr/>
-        </p:nvCxnSpPr>
-        <p:spPr>
-          <a:xfrm>
-            <a:off x="952500" y="1074701"/>
-            <a:ext cx="7239000" cy="0"/>
-          </a:xfrm>
-          <a:prstGeom prst="straightConnector1">
-            <a:avLst/>
-          </a:prstGeom>
-          <a:noFill/>
-          <a:ln w="9525" cap="flat" cmpd="sng">
-            <a:solidFill>
-              <a:schemeClr val="accent5"/>
-            </a:solidFill>
-            <a:prstDash val="solid"/>
-            <a:round/>
-            <a:headEnd type="none" w="med" len="med"/>
-            <a:tailEnd type="none" w="med" len="med"/>
-          </a:ln>
-        </p:spPr>
-      </p:cxnSp>
-      <p:cxnSp>
-        <p:nvCxnSpPr>
-          <p:cNvPr id="408" name="Google Shape;408;p29"/>
-          <p:cNvCxnSpPr/>
-          <p:nvPr/>
-        </p:nvCxnSpPr>
-        <p:spPr>
-          <a:xfrm>
-            <a:off x="952500" y="1784183"/>
-            <a:ext cx="7239000" cy="0"/>
-          </a:xfrm>
-          <a:prstGeom prst="straightConnector1">
-            <a:avLst/>
-          </a:prstGeom>
-          <a:noFill/>
-          <a:ln w="9525" cap="flat" cmpd="sng">
-            <a:solidFill>
-              <a:schemeClr val="accent5"/>
-            </a:solidFill>
-            <a:prstDash val="solid"/>
-            <a:round/>
-            <a:headEnd type="none" w="med" len="med"/>
-            <a:tailEnd type="none" w="med" len="med"/>
-          </a:ln>
-        </p:spPr>
-      </p:cxnSp>
-      <p:cxnSp>
-        <p:nvCxnSpPr>
-          <p:cNvPr id="409" name="Google Shape;409;p29"/>
-          <p:cNvCxnSpPr/>
-          <p:nvPr/>
-        </p:nvCxnSpPr>
-        <p:spPr>
-          <a:xfrm>
-            <a:off x="952500" y="2493664"/>
-            <a:ext cx="7239000" cy="0"/>
-          </a:xfrm>
-          <a:prstGeom prst="straightConnector1">
-            <a:avLst/>
-          </a:prstGeom>
-          <a:noFill/>
-          <a:ln w="9525" cap="flat" cmpd="sng">
-            <a:solidFill>
-              <a:schemeClr val="accent5"/>
-            </a:solidFill>
-            <a:prstDash val="solid"/>
-            <a:round/>
-            <a:headEnd type="none" w="med" len="med"/>
-            <a:tailEnd type="none" w="med" len="med"/>
-          </a:ln>
-        </p:spPr>
-      </p:cxnSp>
-      <p:cxnSp>
-        <p:nvCxnSpPr>
-          <p:cNvPr id="410" name="Google Shape;410;p29"/>
-          <p:cNvCxnSpPr/>
-          <p:nvPr/>
-        </p:nvCxnSpPr>
-        <p:spPr>
-          <a:xfrm>
-            <a:off x="952500" y="3203146"/>
-            <a:ext cx="7239000" cy="0"/>
-          </a:xfrm>
-          <a:prstGeom prst="straightConnector1">
-            <a:avLst/>
-          </a:prstGeom>
-          <a:noFill/>
-          <a:ln w="9525" cap="flat" cmpd="sng">
-            <a:solidFill>
-              <a:schemeClr val="accent5"/>
-            </a:solidFill>
-            <a:prstDash val="solid"/>
-            <a:round/>
-            <a:headEnd type="none" w="med" len="med"/>
-            <a:tailEnd type="none" w="med" len="med"/>
-          </a:ln>
-        </p:spPr>
-      </p:cxnSp>
-      <p:cxnSp>
-        <p:nvCxnSpPr>
-          <p:cNvPr id="411" name="Google Shape;411;p29"/>
-          <p:cNvCxnSpPr/>
-          <p:nvPr/>
-        </p:nvCxnSpPr>
-        <p:spPr>
-          <a:xfrm>
-            <a:off x="952500" y="3934526"/>
-            <a:ext cx="7239000" cy="0"/>
-          </a:xfrm>
-          <a:prstGeom prst="straightConnector1">
-            <a:avLst/>
-          </a:prstGeom>
-          <a:noFill/>
-          <a:ln w="9525" cap="flat" cmpd="sng">
-            <a:solidFill>
-              <a:schemeClr val="accent5"/>
-            </a:solidFill>
-            <a:prstDash val="solid"/>
-            <a:round/>
-            <a:headEnd type="none" w="med" len="med"/>
-            <a:tailEnd type="none" w="med" len="med"/>
-          </a:ln>
-        </p:spPr>
-      </p:cxnSp>
-      <p:sp>
-        <p:nvSpPr>
-          <p:cNvPr id="412" name="Google Shape;412;p29"/>
-          <p:cNvSpPr txBox="1"/>
-          <p:nvPr/>
-        </p:nvSpPr>
-        <p:spPr>
-          <a:xfrm>
-            <a:off x="952500" y="915950"/>
-            <a:ext cx="309300" cy="3030300"/>
-          </a:xfrm>
-          <a:prstGeom prst="rect">
-            <a:avLst/>
-          </a:prstGeom>
-          <a:noFill/>
-          <a:ln>
-            <a:noFill/>
-          </a:ln>
-        </p:spPr>
-        <p:txBody>
-          <a:bodyPr spcFirstLastPara="1" wrap="square" lIns="0" tIns="0" rIns="0" bIns="0" anchor="t" anchorCtr="0">
-            <a:noAutofit/>
-          </a:bodyPr>
-          <a:lstStyle/>
-          <a:p>
-            <a:pPr marL="0" marR="0" lvl="0" indent="0" algn="r" rtl="0">
-              <a:lnSpc>
-                <a:spcPct val="100000"/>
-              </a:lnSpc>
-              <a:spcBef>
-                <a:spcPts val="0"/>
-              </a:spcBef>
-              <a:spcAft>
-                <a:spcPts val="0"/>
-              </a:spcAft>
-              <a:buNone/>
-            </a:pPr>
-            <a:r>
-              <a:rPr lang="en" sz="1000">
-                <a:solidFill>
-                  <a:schemeClr val="dk2"/>
-                </a:solidFill>
-                <a:latin typeface="Barlow Light"/>
-                <a:ea typeface="Barlow Light"/>
-                <a:cs typeface="Barlow Light"/>
-                <a:sym typeface="Barlow Light"/>
-              </a:rPr>
-              <a:t>4000</a:t>
-            </a:r>
-            <a:endParaRPr sz="1000">
-              <a:solidFill>
-                <a:schemeClr val="dk2"/>
-              </a:solidFill>
-              <a:latin typeface="Barlow Light"/>
-              <a:ea typeface="Barlow Light"/>
-              <a:cs typeface="Barlow Light"/>
-              <a:sym typeface="Barlow Light"/>
-            </a:endParaRPr>
-          </a:p>
-          <a:p>
-            <a:pPr marL="0" marR="0" lvl="0" indent="0" algn="r" rtl="0">
-              <a:lnSpc>
-                <a:spcPct val="100000"/>
-              </a:lnSpc>
-              <a:spcBef>
-                <a:spcPts val="4400"/>
-              </a:spcBef>
-              <a:spcAft>
-                <a:spcPts val="0"/>
-              </a:spcAft>
-              <a:buNone/>
-            </a:pPr>
-            <a:r>
-              <a:rPr lang="en" sz="1000">
-                <a:solidFill>
-                  <a:schemeClr val="dk2"/>
-                </a:solidFill>
-                <a:latin typeface="Barlow Light"/>
-                <a:ea typeface="Barlow Light"/>
-                <a:cs typeface="Barlow Light"/>
-                <a:sym typeface="Barlow Light"/>
-              </a:rPr>
-              <a:t>3000</a:t>
-            </a:r>
-            <a:endParaRPr sz="1000">
-              <a:solidFill>
-                <a:schemeClr val="dk2"/>
-              </a:solidFill>
-              <a:latin typeface="Barlow Light"/>
-              <a:ea typeface="Barlow Light"/>
-              <a:cs typeface="Barlow Light"/>
-              <a:sym typeface="Barlow Light"/>
-            </a:endParaRPr>
-          </a:p>
-          <a:p>
-            <a:pPr marL="0" marR="0" lvl="0" indent="0" algn="r" rtl="0">
-              <a:lnSpc>
-                <a:spcPct val="100000"/>
-              </a:lnSpc>
-              <a:spcBef>
-                <a:spcPts val="4400"/>
-              </a:spcBef>
-              <a:spcAft>
-                <a:spcPts val="0"/>
-              </a:spcAft>
-              <a:buNone/>
-            </a:pPr>
-            <a:r>
-              <a:rPr lang="en" sz="1000">
-                <a:solidFill>
-                  <a:schemeClr val="dk2"/>
-                </a:solidFill>
-                <a:latin typeface="Barlow Light"/>
-                <a:ea typeface="Barlow Light"/>
-                <a:cs typeface="Barlow Light"/>
-                <a:sym typeface="Barlow Light"/>
-              </a:rPr>
-              <a:t>2000</a:t>
-            </a:r>
-            <a:endParaRPr sz="1000">
-              <a:solidFill>
-                <a:schemeClr val="dk2"/>
-              </a:solidFill>
-              <a:latin typeface="Barlow Light"/>
-              <a:ea typeface="Barlow Light"/>
-              <a:cs typeface="Barlow Light"/>
-              <a:sym typeface="Barlow Light"/>
-            </a:endParaRPr>
-          </a:p>
-          <a:p>
-            <a:pPr marL="0" marR="0" lvl="0" indent="0" algn="r" rtl="0">
-              <a:lnSpc>
-                <a:spcPct val="100000"/>
-              </a:lnSpc>
-              <a:spcBef>
-                <a:spcPts val="4400"/>
-              </a:spcBef>
-              <a:spcAft>
-                <a:spcPts val="0"/>
-              </a:spcAft>
-              <a:buNone/>
-            </a:pPr>
-            <a:r>
-              <a:rPr lang="en" sz="1000">
-                <a:solidFill>
-                  <a:schemeClr val="dk2"/>
-                </a:solidFill>
-                <a:latin typeface="Barlow Light"/>
-                <a:ea typeface="Barlow Light"/>
-                <a:cs typeface="Barlow Light"/>
-                <a:sym typeface="Barlow Light"/>
-              </a:rPr>
-              <a:t>1000</a:t>
-            </a:r>
-            <a:endParaRPr sz="1000">
-              <a:solidFill>
-                <a:schemeClr val="dk2"/>
-              </a:solidFill>
-              <a:latin typeface="Barlow Light"/>
-              <a:ea typeface="Barlow Light"/>
-              <a:cs typeface="Barlow Light"/>
-              <a:sym typeface="Barlow Light"/>
-            </a:endParaRPr>
-          </a:p>
-          <a:p>
-            <a:pPr marL="0" marR="0" lvl="0" indent="0" algn="r" rtl="0">
-              <a:lnSpc>
-                <a:spcPct val="100000"/>
-              </a:lnSpc>
-              <a:spcBef>
-                <a:spcPts val="4400"/>
-              </a:spcBef>
-              <a:spcAft>
-                <a:spcPts val="4400"/>
-              </a:spcAft>
-              <a:buNone/>
-            </a:pPr>
-            <a:r>
-              <a:rPr lang="en" sz="1000">
-                <a:solidFill>
-                  <a:schemeClr val="dk2"/>
-                </a:solidFill>
-                <a:latin typeface="Barlow Light"/>
-                <a:ea typeface="Barlow Light"/>
-                <a:cs typeface="Barlow Light"/>
-                <a:sym typeface="Barlow Light"/>
-              </a:rPr>
-              <a:t>0</a:t>
-            </a:r>
-            <a:endParaRPr sz="1000">
-              <a:solidFill>
-                <a:schemeClr val="dk2"/>
-              </a:solidFill>
-              <a:latin typeface="Barlow Light"/>
-              <a:ea typeface="Barlow Light"/>
-              <a:cs typeface="Barlow Light"/>
-              <a:sym typeface="Barlow Light"/>
-            </a:endParaRPr>
-          </a:p>
-        </p:txBody>
-      </p:sp>
-      <p:sp>
-        <p:nvSpPr>
-          <p:cNvPr id="413" name="Google Shape;413;p29"/>
-          <p:cNvSpPr/>
-          <p:nvPr/>
-        </p:nvSpPr>
-        <p:spPr>
-          <a:xfrm>
-            <a:off x="1572782" y="2380937"/>
-            <a:ext cx="233700" cy="1553700"/>
-          </a:xfrm>
-          <a:prstGeom prst="rect">
-            <a:avLst/>
-          </a:prstGeom>
-          <a:solidFill>
-            <a:schemeClr val="accent1"/>
-          </a:solidFill>
-          <a:ln>
-            <a:noFill/>
-          </a:ln>
-        </p:spPr>
-        <p:txBody>
-          <a:bodyPr spcFirstLastPara="1" wrap="square" lIns="91425" tIns="91425" rIns="91425" bIns="91425" anchor="ctr" anchorCtr="0">
-            <a:noAutofit/>
-          </a:bodyPr>
-          <a:lstStyle/>
-          <a:p>
-            <a:pPr marL="0" lvl="0" indent="0" algn="l" rtl="0">
-              <a:spcBef>
-                <a:spcPts val="0"/>
-              </a:spcBef>
-              <a:spcAft>
-                <a:spcPts val="0"/>
-              </a:spcAft>
-              <a:buNone/>
-            </a:pPr>
-            <a:endParaRPr/>
-          </a:p>
-        </p:txBody>
-      </p:sp>
-      <p:sp>
-        <p:nvSpPr>
-          <p:cNvPr id="414" name="Google Shape;414;p29"/>
-          <p:cNvSpPr/>
-          <p:nvPr/>
-        </p:nvSpPr>
-        <p:spPr>
-          <a:xfrm>
-            <a:off x="1887026" y="1986874"/>
-            <a:ext cx="233700" cy="1947900"/>
-          </a:xfrm>
-          <a:prstGeom prst="rect">
-            <a:avLst/>
-          </a:prstGeom>
-          <a:solidFill>
-            <a:schemeClr val="accent2"/>
-          </a:solidFill>
-          <a:ln>
-            <a:noFill/>
-          </a:ln>
-        </p:spPr>
-        <p:txBody>
-          <a:bodyPr spcFirstLastPara="1" wrap="square" lIns="91425" tIns="91425" rIns="91425" bIns="91425" anchor="ctr" anchorCtr="0">
-            <a:noAutofit/>
-          </a:bodyPr>
-          <a:lstStyle/>
-          <a:p>
-            <a:pPr marL="0" lvl="0" indent="0" algn="l" rtl="0">
-              <a:spcBef>
-                <a:spcPts val="0"/>
-              </a:spcBef>
-              <a:spcAft>
-                <a:spcPts val="0"/>
-              </a:spcAft>
-              <a:buNone/>
-            </a:pPr>
-            <a:endParaRPr/>
-          </a:p>
-        </p:txBody>
-      </p:sp>
-      <p:sp>
-        <p:nvSpPr>
-          <p:cNvPr id="415" name="Google Shape;415;p29"/>
-          <p:cNvSpPr/>
-          <p:nvPr/>
-        </p:nvSpPr>
-        <p:spPr>
-          <a:xfrm>
-            <a:off x="2201270" y="2493664"/>
-            <a:ext cx="233700" cy="1441200"/>
-          </a:xfrm>
-          <a:prstGeom prst="rect">
-            <a:avLst/>
-          </a:prstGeom>
-          <a:solidFill>
-            <a:schemeClr val="accent3"/>
-          </a:solidFill>
-          <a:ln>
-            <a:noFill/>
-          </a:ln>
-        </p:spPr>
-        <p:txBody>
-          <a:bodyPr spcFirstLastPara="1" wrap="square" lIns="91425" tIns="91425" rIns="91425" bIns="91425" anchor="ctr" anchorCtr="0">
-            <a:noAutofit/>
-          </a:bodyPr>
-          <a:lstStyle/>
-          <a:p>
-            <a:pPr marL="0" lvl="0" indent="0" algn="l" rtl="0">
-              <a:spcBef>
-                <a:spcPts val="0"/>
-              </a:spcBef>
-              <a:spcAft>
-                <a:spcPts val="0"/>
-              </a:spcAft>
-              <a:buNone/>
-            </a:pPr>
-            <a:endParaRPr/>
-          </a:p>
-        </p:txBody>
-      </p:sp>
-      <p:sp>
-        <p:nvSpPr>
-          <p:cNvPr id="416" name="Google Shape;416;p29"/>
-          <p:cNvSpPr/>
-          <p:nvPr/>
-        </p:nvSpPr>
-        <p:spPr>
-          <a:xfrm>
-            <a:off x="3325786" y="2694727"/>
-            <a:ext cx="233700" cy="1239900"/>
-          </a:xfrm>
-          <a:prstGeom prst="rect">
-            <a:avLst/>
-          </a:prstGeom>
-          <a:solidFill>
-            <a:schemeClr val="accent1"/>
-          </a:solidFill>
-          <a:ln>
-            <a:noFill/>
-          </a:ln>
-        </p:spPr>
-        <p:txBody>
-          <a:bodyPr spcFirstLastPara="1" wrap="square" lIns="91425" tIns="91425" rIns="91425" bIns="91425" anchor="ctr" anchorCtr="0">
-            <a:noAutofit/>
-          </a:bodyPr>
-          <a:lstStyle/>
-          <a:p>
-            <a:pPr marL="0" lvl="0" indent="0" algn="l" rtl="0">
-              <a:spcBef>
-                <a:spcPts val="0"/>
-              </a:spcBef>
-              <a:spcAft>
-                <a:spcPts val="0"/>
-              </a:spcAft>
-              <a:buNone/>
-            </a:pPr>
-            <a:endParaRPr/>
-          </a:p>
-        </p:txBody>
-      </p:sp>
-      <p:sp>
-        <p:nvSpPr>
-          <p:cNvPr id="417" name="Google Shape;417;p29"/>
-          <p:cNvSpPr/>
-          <p:nvPr/>
-        </p:nvSpPr>
-        <p:spPr>
-          <a:xfrm>
-            <a:off x="3640031" y="2096344"/>
-            <a:ext cx="233700" cy="1838400"/>
-          </a:xfrm>
-          <a:prstGeom prst="rect">
-            <a:avLst/>
-          </a:prstGeom>
-          <a:solidFill>
-            <a:schemeClr val="accent2"/>
-          </a:solidFill>
-          <a:ln>
-            <a:noFill/>
-          </a:ln>
-        </p:spPr>
-        <p:txBody>
-          <a:bodyPr spcFirstLastPara="1" wrap="square" lIns="91425" tIns="91425" rIns="91425" bIns="91425" anchor="ctr" anchorCtr="0">
-            <a:noAutofit/>
-          </a:bodyPr>
-          <a:lstStyle/>
-          <a:p>
-            <a:pPr marL="0" lvl="0" indent="0" algn="l" rtl="0">
-              <a:spcBef>
-                <a:spcPts val="0"/>
-              </a:spcBef>
-              <a:spcAft>
-                <a:spcPts val="0"/>
-              </a:spcAft>
-              <a:buNone/>
-            </a:pPr>
-            <a:endParaRPr/>
-          </a:p>
-        </p:txBody>
-      </p:sp>
-      <p:sp>
-        <p:nvSpPr>
-          <p:cNvPr id="418" name="Google Shape;418;p29"/>
-          <p:cNvSpPr/>
-          <p:nvPr/>
-        </p:nvSpPr>
-        <p:spPr>
-          <a:xfrm>
-            <a:off x="3954275" y="1229025"/>
-            <a:ext cx="233700" cy="2706000"/>
-          </a:xfrm>
-          <a:prstGeom prst="rect">
-            <a:avLst/>
-          </a:prstGeom>
-          <a:solidFill>
-            <a:schemeClr val="accent3"/>
-          </a:solidFill>
-          <a:ln>
-            <a:noFill/>
-          </a:ln>
-        </p:spPr>
-        <p:txBody>
-          <a:bodyPr spcFirstLastPara="1" wrap="square" lIns="91425" tIns="91425" rIns="91425" bIns="91425" anchor="ctr" anchorCtr="0">
-            <a:noAutofit/>
-          </a:bodyPr>
-          <a:lstStyle/>
-          <a:p>
-            <a:pPr marL="0" lvl="0" indent="0" algn="l" rtl="0">
-              <a:spcBef>
-                <a:spcPts val="0"/>
-              </a:spcBef>
-              <a:spcAft>
-                <a:spcPts val="0"/>
-              </a:spcAft>
-              <a:buNone/>
-            </a:pPr>
-            <a:endParaRPr/>
-          </a:p>
-        </p:txBody>
-      </p:sp>
-      <p:sp>
-        <p:nvSpPr>
-          <p:cNvPr id="419" name="Google Shape;419;p29"/>
-          <p:cNvSpPr/>
-          <p:nvPr/>
-        </p:nvSpPr>
-        <p:spPr>
-          <a:xfrm>
-            <a:off x="5078791" y="2140120"/>
-            <a:ext cx="233700" cy="1794600"/>
-          </a:xfrm>
-          <a:prstGeom prst="rect">
-            <a:avLst/>
-          </a:prstGeom>
-          <a:solidFill>
-            <a:schemeClr val="accent1"/>
-          </a:solidFill>
-          <a:ln>
-            <a:noFill/>
-          </a:ln>
-        </p:spPr>
-        <p:txBody>
-          <a:bodyPr spcFirstLastPara="1" wrap="square" lIns="91425" tIns="91425" rIns="91425" bIns="91425" anchor="ctr" anchorCtr="0">
-            <a:noAutofit/>
-          </a:bodyPr>
-          <a:lstStyle/>
-          <a:p>
-            <a:pPr marL="0" lvl="0" indent="0" algn="l" rtl="0">
-              <a:spcBef>
-                <a:spcPts val="0"/>
-              </a:spcBef>
-              <a:spcAft>
-                <a:spcPts val="0"/>
-              </a:spcAft>
-              <a:buNone/>
-            </a:pPr>
-            <a:endParaRPr/>
-          </a:p>
-        </p:txBody>
-      </p:sp>
-      <p:sp>
-        <p:nvSpPr>
-          <p:cNvPr id="420" name="Google Shape;420;p29"/>
-          <p:cNvSpPr/>
-          <p:nvPr/>
-        </p:nvSpPr>
-        <p:spPr>
-          <a:xfrm>
-            <a:off x="5393035" y="1074577"/>
-            <a:ext cx="233700" cy="2860200"/>
-          </a:xfrm>
-          <a:prstGeom prst="rect">
-            <a:avLst/>
-          </a:prstGeom>
-          <a:solidFill>
-            <a:schemeClr val="accent2"/>
-          </a:solidFill>
-          <a:ln>
-            <a:noFill/>
-          </a:ln>
-        </p:spPr>
-        <p:txBody>
-          <a:bodyPr spcFirstLastPara="1" wrap="square" lIns="91425" tIns="91425" rIns="91425" bIns="91425" anchor="ctr" anchorCtr="0">
-            <a:noAutofit/>
-          </a:bodyPr>
-          <a:lstStyle/>
-          <a:p>
-            <a:pPr marL="0" lvl="0" indent="0" algn="l" rtl="0">
-              <a:spcBef>
-                <a:spcPts val="0"/>
-              </a:spcBef>
-              <a:spcAft>
-                <a:spcPts val="0"/>
-              </a:spcAft>
-              <a:buNone/>
-            </a:pPr>
-            <a:endParaRPr/>
-          </a:p>
-        </p:txBody>
-      </p:sp>
-      <p:sp>
-        <p:nvSpPr>
-          <p:cNvPr id="421" name="Google Shape;421;p29"/>
-          <p:cNvSpPr/>
-          <p:nvPr/>
-        </p:nvSpPr>
-        <p:spPr>
-          <a:xfrm>
-            <a:off x="5707280" y="2322562"/>
-            <a:ext cx="233700" cy="1611900"/>
-          </a:xfrm>
-          <a:prstGeom prst="rect">
-            <a:avLst/>
-          </a:prstGeom>
-          <a:solidFill>
-            <a:schemeClr val="accent3"/>
-          </a:solidFill>
-          <a:ln>
-            <a:noFill/>
-          </a:ln>
-        </p:spPr>
-        <p:txBody>
-          <a:bodyPr spcFirstLastPara="1" wrap="square" lIns="91425" tIns="91425" rIns="91425" bIns="91425" anchor="ctr" anchorCtr="0">
-            <a:noAutofit/>
-          </a:bodyPr>
-          <a:lstStyle/>
-          <a:p>
-            <a:pPr marL="0" lvl="0" indent="0" algn="l" rtl="0">
-              <a:spcBef>
-                <a:spcPts val="0"/>
-              </a:spcBef>
-              <a:spcAft>
-                <a:spcPts val="0"/>
-              </a:spcAft>
-              <a:buNone/>
-            </a:pPr>
-            <a:endParaRPr/>
-          </a:p>
-        </p:txBody>
-      </p:sp>
-      <p:sp>
-        <p:nvSpPr>
-          <p:cNvPr id="422" name="Google Shape;422;p29"/>
-          <p:cNvSpPr/>
-          <p:nvPr/>
-        </p:nvSpPr>
-        <p:spPr>
-          <a:xfrm>
-            <a:off x="6831796" y="2753101"/>
-            <a:ext cx="233700" cy="1181400"/>
-          </a:xfrm>
-          <a:prstGeom prst="rect">
-            <a:avLst/>
-          </a:prstGeom>
-          <a:solidFill>
-            <a:schemeClr val="accent1"/>
-          </a:solidFill>
-          <a:ln>
-            <a:noFill/>
-          </a:ln>
-        </p:spPr>
-        <p:txBody>
-          <a:bodyPr spcFirstLastPara="1" wrap="square" lIns="91425" tIns="91425" rIns="91425" bIns="91425" anchor="ctr" anchorCtr="0">
-            <a:noAutofit/>
-          </a:bodyPr>
-          <a:lstStyle/>
-          <a:p>
-            <a:pPr marL="0" lvl="0" indent="0" algn="l" rtl="0">
-              <a:spcBef>
-                <a:spcPts val="0"/>
-              </a:spcBef>
-              <a:spcAft>
-                <a:spcPts val="0"/>
-              </a:spcAft>
-              <a:buNone/>
-            </a:pPr>
-            <a:endParaRPr/>
-          </a:p>
-        </p:txBody>
-      </p:sp>
-      <p:sp>
-        <p:nvSpPr>
-          <p:cNvPr id="423" name="Google Shape;423;p29"/>
-          <p:cNvSpPr/>
-          <p:nvPr/>
-        </p:nvSpPr>
-        <p:spPr>
-          <a:xfrm>
-            <a:off x="7146040" y="1293620"/>
-            <a:ext cx="233700" cy="2641200"/>
-          </a:xfrm>
-          <a:prstGeom prst="rect">
-            <a:avLst/>
-          </a:prstGeom>
-          <a:solidFill>
-            <a:schemeClr val="accent2"/>
-          </a:solidFill>
-          <a:ln>
-            <a:noFill/>
-          </a:ln>
-        </p:spPr>
-        <p:txBody>
-          <a:bodyPr spcFirstLastPara="1" wrap="square" lIns="91425" tIns="91425" rIns="91425" bIns="91425" anchor="ctr" anchorCtr="0">
-            <a:noAutofit/>
-          </a:bodyPr>
-          <a:lstStyle/>
-          <a:p>
-            <a:pPr marL="0" lvl="0" indent="0" algn="l" rtl="0">
-              <a:spcBef>
-                <a:spcPts val="0"/>
-              </a:spcBef>
-              <a:spcAft>
-                <a:spcPts val="0"/>
-              </a:spcAft>
-              <a:buNone/>
-            </a:pPr>
-            <a:endParaRPr/>
-          </a:p>
-        </p:txBody>
-      </p:sp>
-      <p:sp>
-        <p:nvSpPr>
-          <p:cNvPr id="424" name="Google Shape;424;p29"/>
-          <p:cNvSpPr/>
-          <p:nvPr/>
-        </p:nvSpPr>
-        <p:spPr>
-          <a:xfrm>
-            <a:off x="7460284" y="1607410"/>
-            <a:ext cx="233700" cy="2327400"/>
-          </a:xfrm>
-          <a:prstGeom prst="rect">
-            <a:avLst/>
-          </a:prstGeom>
-          <a:solidFill>
-            <a:schemeClr val="accent3"/>
-          </a:solidFill>
-          <a:ln>
-            <a:noFill/>
-          </a:ln>
-        </p:spPr>
-        <p:txBody>
-          <a:bodyPr spcFirstLastPara="1" wrap="square" lIns="91425" tIns="91425" rIns="91425" bIns="91425" anchor="ctr" anchorCtr="0">
-            <a:noAutofit/>
-          </a:bodyPr>
-          <a:lstStyle/>
-          <a:p>
-            <a:pPr marL="0" lvl="0" indent="0" algn="l" rtl="0">
-              <a:spcBef>
-                <a:spcPts val="0"/>
-              </a:spcBef>
-              <a:spcAft>
-                <a:spcPts val="0"/>
-              </a:spcAft>
-              <a:buNone/>
-            </a:pPr>
-            <a:endParaRPr/>
-          </a:p>
-        </p:txBody>
-      </p:sp>
-    </p:spTree>
-  </p:cSld>
-  <p:clrMapOvr>
-    <a:masterClrMapping/>
-  </p:clrMapOvr>
-  <p:transition spd="med" advClick="1">
-    <p:fade/>
-  </p:transition>
-</p:sld>
-</file>
-
 <file path=ppt/slides/slide2.xml><?xml version="1.0" encoding="utf-8"?>
 <p:sld xmlns:a="http://schemas.openxmlformats.org/drawingml/2006/main" xmlns:r="http://schemas.openxmlformats.org/officeDocument/2006/relationships" xmlns:p="http://schemas.openxmlformats.org/presentationml/2006/main">
   <p:cSld>

</xml_diff>